<commit_message>
Slide deck: figure titles, justified notes, Garamond
Co-Authored-By: Claude Fable 5 <noreply@anthropic.com>
Claude-Session: https://claude.ai/code/session_01DNzQPDcr3zfLTraMHUHqUn
</commit_message>
<xml_diff>
--- a/report/teacher_attrition_figures.pptx
+++ b/report/teacher_attrition_figures.pptx
@@ -1943,9 +1943,48 @@
           <a:chExt cx="0" cy="0"/>
         </a:xfrm>
       </p:grpSpPr>
+      <p:sp>
+        <p:nvSpPr>
+          <p:cNvPr id="2" name="Text 0"/>
+          <p:cNvSpPr/>
+          <p:nvPr/>
+        </p:nvSpPr>
+        <p:spPr>
+          <a:xfrm>
+            <a:off x="457200" y="201168"/>
+            <a:ext cx="11274552" cy="502920"/>
+          </a:xfrm>
+          <a:prstGeom prst="rect">
+            <a:avLst/>
+          </a:prstGeom>
+          <a:noFill/>
+          <a:ln/>
+        </p:spPr>
+        <p:txBody>
+          <a:bodyPr wrap="square" lIns="0" tIns="0" rIns="0" bIns="0" rtlCol="0" anchor="ctr"/>
+          <a:lstStyle/>
+          <a:p>
+            <a:pPr algn="ctr" indent="0" marL="0">
+              <a:buNone/>
+            </a:pPr>
+            <a:r>
+              <a:rPr lang="en-US" sz="2100" dirty="0">
+                <a:solidFill>
+                  <a:srgbClr val="1A2430"/>
+                </a:solidFill>
+                <a:latin typeface="Garamond" pitchFamily="34" charset="0"/>
+                <a:ea typeface="Garamond" pitchFamily="34" charset="-122"/>
+                <a:cs typeface="Garamond" pitchFamily="34" charset="-120"/>
+              </a:rPr>
+              <a:t>Figure 1. Composition of the Teaching Workforce, 2005–2024</a:t>
+            </a:r>
+            <a:endParaRPr lang="en-US" sz="2100" dirty="0"/>
+          </a:p>
+        </p:txBody>
+      </p:sp>
       <p:pic>
         <p:nvPicPr>
-          <p:cNvPr id="2" name="Image 0" descr="figs_png/g1_workforce.png">    </p:cNvPr>
+          <p:cNvPr id="3" name="Image 0" descr="figs_png/g1_workforce.png">    </p:cNvPr>
           <p:cNvPicPr>
             <a:picLocks noChangeAspect="1"/>
           </p:cNvPicPr>
@@ -1959,8 +1998,8 @@
         </p:blipFill>
         <p:spPr>
           <a:xfrm>
-            <a:off x="603177" y="274320"/>
-            <a:ext cx="10982597" cy="5212080"/>
+            <a:off x="1133040" y="804672"/>
+            <a:ext cx="9922873" cy="4709160"/>
           </a:xfrm>
           <a:prstGeom prst="rect">
             <a:avLst/>
@@ -1969,13 +2008,13 @@
       </p:pic>
       <p:sp>
         <p:nvSpPr>
-          <p:cNvPr id="3" name="Text 0"/>
+          <p:cNvPr id="4" name="Text 1"/>
           <p:cNvSpPr/>
           <p:nvPr/>
         </p:nvSpPr>
         <p:spPr>
           <a:xfrm>
-            <a:off x="457200" y="5623560"/>
+            <a:off x="457200" y="5650992"/>
             <a:ext cx="11274552" cy="1097280"/>
           </a:xfrm>
           <a:prstGeom prst="rect">
@@ -1988,7 +2027,7 @@
           <a:bodyPr wrap="square" lIns="0" tIns="0" rIns="0" bIns="0" rtlCol="0" anchor="t"/>
           <a:lstStyle/>
           <a:p>
-            <a:pPr algn="l" indent="0" marL="0">
+            <a:pPr algn="just" indent="0" marL="0">
               <a:buNone/>
             </a:pPr>
             <a:r>
@@ -1996,9 +2035,9 @@
                 <a:solidFill>
                   <a:srgbClr val="5A6572"/>
                 </a:solidFill>
-                <a:latin typeface="Calibri" pitchFamily="34" charset="0"/>
-                <a:ea typeface="Calibri" pitchFamily="34" charset="-122"/>
-                <a:cs typeface="Calibri" pitchFamily="34" charset="-120"/>
+                <a:latin typeface="Garamond" pitchFamily="34" charset="0"/>
+                <a:ea typeface="Garamond" pitchFamily="34" charset="-122"/>
+                <a:cs typeface="Garamond" pitchFamily="34" charset="-120"/>
               </a:rPr>
               <a:t>Notes: College-graduate teachers aged 18+ whose longest job last year was K–12 teaching; ASEC supplement weights. Thin gray lines are annual values; blue lines are centered 3-year averages, with endpoint values printed. “Public school,” “part-time,” and “pension plan” refer to the longest job held last year; the open circle marks 2013, a year with a reduced sample due to the ASEC redesign. Source: author’s calculations from March CPS supplements, survey years 2006–2025.</a:t>
             </a:r>
@@ -2038,9 +2077,48 @@
           <a:chExt cx="0" cy="0"/>
         </a:xfrm>
       </p:grpSpPr>
+      <p:sp>
+        <p:nvSpPr>
+          <p:cNvPr id="2" name="Text 0"/>
+          <p:cNvSpPr/>
+          <p:nvPr/>
+        </p:nvSpPr>
+        <p:spPr>
+          <a:xfrm>
+            <a:off x="457200" y="201168"/>
+            <a:ext cx="11274552" cy="502920"/>
+          </a:xfrm>
+          <a:prstGeom prst="rect">
+            <a:avLst/>
+          </a:prstGeom>
+          <a:noFill/>
+          <a:ln/>
+        </p:spPr>
+        <p:txBody>
+          <a:bodyPr wrap="square" lIns="0" tIns="0" rIns="0" bIns="0" rtlCol="0" anchor="ctr"/>
+          <a:lstStyle/>
+          <a:p>
+            <a:pPr algn="ctr" indent="0" marL="0">
+              <a:buNone/>
+            </a:pPr>
+            <a:r>
+              <a:rPr lang="en-US" sz="2100" dirty="0">
+                <a:solidFill>
+                  <a:srgbClr val="1A2430"/>
+                </a:solidFill>
+                <a:latin typeface="Garamond" pitchFamily="34" charset="0"/>
+                <a:ea typeface="Garamond" pitchFamily="34" charset="-122"/>
+                <a:cs typeface="Garamond" pitchFamily="34" charset="-120"/>
+              </a:rPr>
+              <a:t>Figure 10. The Distribution of Earnings Changes: Stayers and Leavers</a:t>
+            </a:r>
+            <a:endParaRPr lang="en-US" sz="2100" dirty="0"/>
+          </a:p>
+        </p:txBody>
+      </p:sp>
       <p:pic>
         <p:nvPicPr>
-          <p:cNvPr id="2" name="Image 0" descr="figs_png/g5b_earnings_density.png">    </p:cNvPr>
+          <p:cNvPr id="3" name="Image 0" descr="figs_png/g5b_earnings_density.png">    </p:cNvPr>
           <p:cNvPicPr>
             <a:picLocks noChangeAspect="1"/>
           </p:cNvPicPr>
@@ -2054,8 +2132,8 @@
         </p:blipFill>
         <p:spPr>
           <a:xfrm>
-            <a:off x="1109008" y="274320"/>
-            <a:ext cx="9970936" cy="5212080"/>
+            <a:off x="1590062" y="804672"/>
+            <a:ext cx="9008828" cy="4709160"/>
           </a:xfrm>
           <a:prstGeom prst="rect">
             <a:avLst/>
@@ -2064,13 +2142,13 @@
       </p:pic>
       <p:sp>
         <p:nvSpPr>
-          <p:cNvPr id="3" name="Text 0"/>
+          <p:cNvPr id="4" name="Text 1"/>
           <p:cNvSpPr/>
           <p:nvPr/>
         </p:nvSpPr>
         <p:spPr>
           <a:xfrm>
-            <a:off x="457200" y="5623560"/>
+            <a:off x="457200" y="5650992"/>
             <a:ext cx="11274552" cy="1097280"/>
           </a:xfrm>
           <a:prstGeom prst="rect">
@@ -2083,7 +2161,7 @@
           <a:bodyPr wrap="square" lIns="0" tIns="0" rIns="0" bIns="0" rtlCol="0" anchor="t"/>
           <a:lstStyle/>
           <a:p>
-            <a:pPr algn="l" indent="0" marL="0">
+            <a:pPr algn="just" indent="0" marL="0">
               <a:buNone/>
             </a:pPr>
             <a:r>
@@ -2091,9 +2169,9 @@
                 <a:solidFill>
                   <a:srgbClr val="5A6572"/>
                 </a:solidFill>
-                <a:latin typeface="Calibri" pitchFamily="34" charset="0"/>
-                <a:ea typeface="Calibri" pitchFamily="34" charset="-122"/>
-                <a:cs typeface="Calibri" pitchFamily="34" charset="-120"/>
+                <a:latin typeface="Garamond" pitchFamily="34" charset="0"/>
+                <a:ea typeface="Garamond" pitchFamily="34" charset="-122"/>
+                <a:cs typeface="Garamond" pitchFamily="34" charset="-120"/>
               </a:rPr>
               <a:t>Notes: Kernel densities of the person-level change in annual wage and salary earnings (log points ×100) between the teaching year and the next, for teachers linked across consecutive supplements (rotation-group links, survey years 2011–2025; identity validated on sex and age). Navy: stayers (12,195 links; median +3). Red: leavers employed the following year (225 links; median +15). “Lose big”/“win big” denote changes beyond ±30 log points. The sample conditions on positive earnings in both years; 47 percent of all leavers report zero earnings the following year. Bandwidth 0.25. Source: author’s calculations from March CPS supplements.</a:t>
             </a:r>
@@ -2133,9 +2211,48 @@
           <a:chExt cx="0" cy="0"/>
         </a:xfrm>
       </p:grpSpPr>
+      <p:sp>
+        <p:nvSpPr>
+          <p:cNvPr id="2" name="Text 0"/>
+          <p:cNvSpPr/>
+          <p:nvPr/>
+        </p:nvSpPr>
+        <p:spPr>
+          <a:xfrm>
+            <a:off x="457200" y="201168"/>
+            <a:ext cx="11274552" cy="502920"/>
+          </a:xfrm>
+          <a:prstGeom prst="rect">
+            <a:avLst/>
+          </a:prstGeom>
+          <a:noFill/>
+          <a:ln/>
+        </p:spPr>
+        <p:txBody>
+          <a:bodyPr wrap="square" lIns="0" tIns="0" rIns="0" bIns="0" rtlCol="0" anchor="ctr"/>
+          <a:lstStyle/>
+          <a:p>
+            <a:pPr algn="ctr" indent="0" marL="0">
+              <a:buNone/>
+            </a:pPr>
+            <a:r>
+              <a:rPr lang="en-US" sz="2100" dirty="0">
+                <a:solidFill>
+                  <a:srgbClr val="1A2430"/>
+                </a:solidFill>
+                <a:latin typeface="Garamond" pitchFamily="34" charset="0"/>
+                <a:ea typeface="Garamond" pitchFamily="34" charset="-122"/>
+                <a:cs typeface="Garamond" pitchFamily="34" charset="-120"/>
+              </a:rPr>
+              <a:t>Figure 11. Real Median Earnings by Profession, 2004–2014 and 2015–2025</a:t>
+            </a:r>
+            <a:endParaRPr lang="en-US" sz="2100" dirty="0"/>
+          </a:p>
+        </p:txBody>
+      </p:sp>
       <p:pic>
         <p:nvPicPr>
-          <p:cNvPr id="2" name="Image 0" descr="figs_png/n6b_pay_windows.png">    </p:cNvPr>
+          <p:cNvPr id="3" name="Image 0" descr="figs_png/n6b_pay_windows.png">    </p:cNvPr>
           <p:cNvPicPr>
             <a:picLocks noChangeAspect="1"/>
           </p:cNvPicPr>
@@ -2149,8 +2266,8 @@
         </p:blipFill>
         <p:spPr>
           <a:xfrm>
-            <a:off x="1130590" y="274320"/>
-            <a:ext cx="9927771" cy="5212080"/>
+            <a:off x="1609562" y="804672"/>
+            <a:ext cx="8969829" cy="4709160"/>
           </a:xfrm>
           <a:prstGeom prst="rect">
             <a:avLst/>
@@ -2159,13 +2276,13 @@
       </p:pic>
       <p:sp>
         <p:nvSpPr>
-          <p:cNvPr id="3" name="Text 0"/>
+          <p:cNvPr id="4" name="Text 1"/>
           <p:cNvSpPr/>
           <p:nvPr/>
         </p:nvSpPr>
         <p:spPr>
           <a:xfrm>
-            <a:off x="457200" y="5623560"/>
+            <a:off x="457200" y="5650992"/>
             <a:ext cx="11274552" cy="1097280"/>
           </a:xfrm>
           <a:prstGeom prst="rect">
@@ -2178,7 +2295,7 @@
           <a:bodyPr wrap="square" lIns="0" tIns="0" rIns="0" bIns="0" rtlCol="0" anchor="t"/>
           <a:lstStyle/>
           <a:p>
-            <a:pPr algn="l" indent="0" marL="0">
+            <a:pPr algn="just" indent="0" marL="0">
               <a:buNone/>
             </a:pPr>
             <a:r>
@@ -2186,9 +2303,9 @@
                 <a:solidFill>
                   <a:srgbClr val="5A6572"/>
                 </a:solidFill>
-                <a:latin typeface="Calibri" pitchFamily="34" charset="0"/>
-                <a:ea typeface="Calibri" pitchFamily="34" charset="-122"/>
-                <a:cs typeface="Calibri" pitchFamily="34" charset="-120"/>
+                <a:latin typeface="Garamond" pitchFamily="34" charset="0"/>
+                <a:ea typeface="Garamond" pitchFamily="34" charset="-122"/>
+                <a:cs typeface="Garamond" pitchFamily="34" charset="-120"/>
               </a:rPr>
               <a:t>Notes: Weighted median annual wage and salary earnings of full-time, full-year college graduates aged 25–60, in each profession and overall, deflated to 2024 dollars with the CPI-U; the two windows pool survey years 2004–2014 and 2015–2025. Filled dots (with values): recent window. Source: author’s calculations from March CPS supplements; CPI: BLS via FRED.</a:t>
             </a:r>
@@ -2228,9 +2345,48 @@
           <a:chExt cx="0" cy="0"/>
         </a:xfrm>
       </p:grpSpPr>
+      <p:sp>
+        <p:nvSpPr>
+          <p:cNvPr id="2" name="Text 0"/>
+          <p:cNvSpPr/>
+          <p:nvPr/>
+        </p:nvSpPr>
+        <p:spPr>
+          <a:xfrm>
+            <a:off x="457200" y="201168"/>
+            <a:ext cx="11274552" cy="502920"/>
+          </a:xfrm>
+          <a:prstGeom prst="rect">
+            <a:avLst/>
+          </a:prstGeom>
+          <a:noFill/>
+          <a:ln/>
+        </p:spPr>
+        <p:txBody>
+          <a:bodyPr wrap="square" lIns="0" tIns="0" rIns="0" bIns="0" rtlCol="0" anchor="ctr"/>
+          <a:lstStyle/>
+          <a:p>
+            <a:pPr algn="ctr" indent="0" marL="0">
+              <a:buNone/>
+            </a:pPr>
+            <a:r>
+              <a:rPr lang="en-US" sz="2100" dirty="0">
+                <a:solidFill>
+                  <a:srgbClr val="1A2430"/>
+                </a:solidFill>
+                <a:latin typeface="Garamond" pitchFamily="34" charset="0"/>
+                <a:ea typeface="Garamond" pitchFamily="34" charset="-122"/>
+                <a:cs typeface="Garamond" pitchFamily="34" charset="-120"/>
+              </a:rPr>
+              <a:t>Figure 12. Average Marginal Effects on the Probability of Leaving Teaching</a:t>
+            </a:r>
+            <a:endParaRPr lang="en-US" sz="2100" dirty="0"/>
+          </a:p>
+        </p:txBody>
+      </p:sp>
       <p:pic>
         <p:nvPicPr>
-          <p:cNvPr id="2" name="Image 0" descr="figs_png/g6_ame.png">    </p:cNvPr>
+          <p:cNvPr id="3" name="Image 0" descr="figs_png/g6_ame.png">    </p:cNvPr>
           <p:cNvPicPr>
             <a:picLocks noChangeAspect="1"/>
           </p:cNvPicPr>
@@ -2244,8 +2400,8 @@
         </p:blipFill>
         <p:spPr>
           <a:xfrm>
-            <a:off x="2619756" y="274320"/>
-            <a:ext cx="6949440" cy="5212080"/>
+            <a:off x="2955036" y="804672"/>
+            <a:ext cx="6278880" cy="4709160"/>
           </a:xfrm>
           <a:prstGeom prst="rect">
             <a:avLst/>
@@ -2254,13 +2410,13 @@
       </p:pic>
       <p:sp>
         <p:nvSpPr>
-          <p:cNvPr id="3" name="Text 0"/>
+          <p:cNvPr id="4" name="Text 1"/>
           <p:cNvSpPr/>
           <p:nvPr/>
         </p:nvSpPr>
         <p:spPr>
           <a:xfrm>
-            <a:off x="457200" y="5623560"/>
+            <a:off x="457200" y="5650992"/>
             <a:ext cx="11274552" cy="1097280"/>
           </a:xfrm>
           <a:prstGeom prst="rect">
@@ -2273,7 +2429,7 @@
           <a:bodyPr wrap="square" lIns="0" tIns="0" rIns="0" bIns="0" rtlCol="0" anchor="t"/>
           <a:lstStyle/>
           <a:p>
-            <a:pPr algn="l" indent="0" marL="0">
+            <a:pPr algn="just" indent="0" marL="0">
               <a:buNone/>
             </a:pPr>
             <a:r>
@@ -2281,9 +2437,9 @@
                 <a:solidFill>
                   <a:srgbClr val="5A6572"/>
                 </a:solidFill>
-                <a:latin typeface="Calibri" pitchFamily="34" charset="0"/>
-                <a:ea typeface="Calibri" pitchFamily="34" charset="-122"/>
-                <a:cs typeface="Calibri" pitchFamily="34" charset="-120"/>
+                <a:latin typeface="Garamond" pitchFamily="34" charset="0"/>
+                <a:ea typeface="Garamond" pitchFamily="34" charset="-122"/>
+                <a:cs typeface="Garamond" pitchFamily="34" charset="-120"/>
               </a:rPr>
               <a:t>Notes: Average marginal effects (percentage points) on the probability of leaving teaching, from a probit on college-graduate teachers pooled over calendar 2015–2024 with year effects; whiskers are 95 percent confidence intervals; filled markers are significant at 5 percent. “Worked full year” is 50+ weeks at the last-year job; “part-time” is under 35 weekly hours. n = 28,900. Source: author’s calculations from March CPS supplements.</a:t>
             </a:r>
@@ -2323,9 +2479,48 @@
           <a:chExt cx="0" cy="0"/>
         </a:xfrm>
       </p:grpSpPr>
+      <p:sp>
+        <p:nvSpPr>
+          <p:cNvPr id="2" name="Text 0"/>
+          <p:cNvSpPr/>
+          <p:nvPr/>
+        </p:nvSpPr>
+        <p:spPr>
+          <a:xfrm>
+            <a:off x="457200" y="201168"/>
+            <a:ext cx="11274552" cy="502920"/>
+          </a:xfrm>
+          <a:prstGeom prst="rect">
+            <a:avLst/>
+          </a:prstGeom>
+          <a:noFill/>
+          <a:ln/>
+        </p:spPr>
+        <p:txBody>
+          <a:bodyPr wrap="square" lIns="0" tIns="0" rIns="0" bIns="0" rtlCol="0" anchor="ctr"/>
+          <a:lstStyle/>
+          <a:p>
+            <a:pPr algn="ctr" indent="0" marL="0">
+              <a:buNone/>
+            </a:pPr>
+            <a:r>
+              <a:rPr lang="en-US" sz="2100" dirty="0">
+                <a:solidFill>
+                  <a:srgbClr val="1A2430"/>
+                </a:solidFill>
+                <a:latin typeface="Garamond" pitchFamily="34" charset="0"/>
+                <a:ea typeface="Garamond" pitchFamily="34" charset="-122"/>
+                <a:cs typeface="Garamond" pitchFamily="34" charset="-120"/>
+              </a:rPr>
+              <a:t>Figure 13. Rates of Leaving by Profession, 2004–2014 and 2015–2025</a:t>
+            </a:r>
+            <a:endParaRPr lang="en-US" sz="2100" dirty="0"/>
+          </a:p>
+        </p:txBody>
+      </p:sp>
       <p:pic>
         <p:nvPicPr>
-          <p:cNvPr id="2" name="Image 0" descr="figs_png/g7_professions.png">    </p:cNvPr>
+          <p:cNvPr id="3" name="Image 0" descr="figs_png/g7_professions.png">    </p:cNvPr>
           <p:cNvPicPr>
             <a:picLocks noChangeAspect="1"/>
           </p:cNvPicPr>
@@ -2339,8 +2534,8 @@
         </p:blipFill>
         <p:spPr>
           <a:xfrm>
-            <a:off x="1562233" y="274320"/>
-            <a:ext cx="9064487" cy="5212080"/>
+            <a:off x="1999554" y="804672"/>
+            <a:ext cx="8189843" cy="4709160"/>
           </a:xfrm>
           <a:prstGeom prst="rect">
             <a:avLst/>
@@ -2349,13 +2544,13 @@
       </p:pic>
       <p:sp>
         <p:nvSpPr>
-          <p:cNvPr id="3" name="Text 0"/>
+          <p:cNvPr id="4" name="Text 1"/>
           <p:cNvSpPr/>
           <p:nvPr/>
         </p:nvSpPr>
         <p:spPr>
           <a:xfrm>
-            <a:off x="457200" y="5623560"/>
+            <a:off x="457200" y="5650992"/>
             <a:ext cx="11274552" cy="1097280"/>
           </a:xfrm>
           <a:prstGeom prst="rect">
@@ -2368,7 +2563,7 @@
           <a:bodyPr wrap="square" lIns="0" tIns="0" rIns="0" bIns="0" rtlCol="0" anchor="t"/>
           <a:lstStyle/>
           <a:p>
-            <a:pPr algn="l" indent="0" marL="0">
+            <a:pPr algn="just" indent="0" marL="0">
               <a:buNone/>
             </a:pPr>
             <a:r>
@@ -2376,9 +2571,9 @@
                 <a:solidFill>
                   <a:srgbClr val="5A6572"/>
                 </a:solidFill>
-                <a:latin typeface="Calibri" pitchFamily="34" charset="0"/>
-                <a:ea typeface="Calibri" pitchFamily="34" charset="-122"/>
-                <a:cs typeface="Calibri" pitchFamily="34" charset="-120"/>
+                <a:latin typeface="Garamond" pitchFamily="34" charset="0"/>
+                <a:ea typeface="Garamond" pitchFamily="34" charset="-122"/>
+                <a:cs typeface="Garamond" pitchFamily="34" charset="-120"/>
               </a:rPr>
               <a:t>Notes: Annual rate of leaving each profession (same route-based definition as for teachers, college graduates, ASEC weights), pooled over survey years 2004–2014 (open) and 2015–2025 (filled, with values). Occupation codes harmonized across the 2002, 2010, and 2018 Census classification regimes. Source: author’s calculations from March CPS supplements.</a:t>
             </a:r>
@@ -2418,9 +2613,48 @@
           <a:chExt cx="0" cy="0"/>
         </a:xfrm>
       </p:grpSpPr>
+      <p:sp>
+        <p:nvSpPr>
+          <p:cNvPr id="2" name="Text 0"/>
+          <p:cNvSpPr/>
+          <p:nvPr/>
+        </p:nvSpPr>
+        <p:spPr>
+          <a:xfrm>
+            <a:off x="457200" y="201168"/>
+            <a:ext cx="11274552" cy="502920"/>
+          </a:xfrm>
+          <a:prstGeom prst="rect">
+            <a:avLst/>
+          </a:prstGeom>
+          <a:noFill/>
+          <a:ln/>
+        </p:spPr>
+        <p:txBody>
+          <a:bodyPr wrap="square" lIns="0" tIns="0" rIns="0" bIns="0" rtlCol="0" anchor="ctr"/>
+          <a:lstStyle/>
+          <a:p>
+            <a:pPr algn="ctr" indent="0" marL="0">
+              <a:buNone/>
+            </a:pPr>
+            <a:r>
+              <a:rPr lang="en-US" sz="2100" dirty="0">
+                <a:solidFill>
+                  <a:srgbClr val="1A2430"/>
+                </a:solidFill>
+                <a:latin typeface="Garamond" pitchFamily="34" charset="0"/>
+                <a:ea typeface="Garamond" pitchFamily="34" charset="-122"/>
+                <a:cs typeface="Garamond" pitchFamily="34" charset="-120"/>
+              </a:rPr>
+              <a:t>Figure 2. Leaving Teaching, 1997–2024</a:t>
+            </a:r>
+            <a:endParaRPr lang="en-US" sz="2100" dirty="0"/>
+          </a:p>
+        </p:txBody>
+      </p:sp>
       <p:pic>
         <p:nvPicPr>
-          <p:cNvPr id="2" name="Image 0" descr="figs_png/g2_evolution.png">    </p:cNvPr>
+          <p:cNvPr id="3" name="Image 0" descr="figs_png/g2_evolution.png">    </p:cNvPr>
           <p:cNvPicPr>
             <a:picLocks noChangeAspect="1"/>
           </p:cNvPicPr>
@@ -2434,8 +2668,8 @@
         </p:blipFill>
         <p:spPr>
           <a:xfrm>
-            <a:off x="882396" y="274320"/>
-            <a:ext cx="10424160" cy="5212080"/>
+            <a:off x="1385316" y="804672"/>
+            <a:ext cx="9418320" cy="4709160"/>
           </a:xfrm>
           <a:prstGeom prst="rect">
             <a:avLst/>
@@ -2444,13 +2678,13 @@
       </p:pic>
       <p:sp>
         <p:nvSpPr>
-          <p:cNvPr id="3" name="Text 0"/>
+          <p:cNvPr id="4" name="Text 1"/>
           <p:cNvSpPr/>
           <p:nvPr/>
         </p:nvSpPr>
         <p:spPr>
           <a:xfrm>
-            <a:off x="457200" y="5623560"/>
+            <a:off x="457200" y="5650992"/>
             <a:ext cx="11274552" cy="1097280"/>
           </a:xfrm>
           <a:prstGeom prst="rect">
@@ -2463,7 +2697,7 @@
           <a:bodyPr wrap="square" lIns="0" tIns="0" rIns="0" bIns="0" rtlCol="0" anchor="t"/>
           <a:lstStyle/>
           <a:p>
-            <a:pPr algn="l" indent="0" marL="0">
+            <a:pPr algn="just" indent="0" marL="0">
               <a:buNone/>
             </a:pPr>
             <a:r>
@@ -2471,9 +2705,9 @@
                 <a:solidFill>
                   <a:srgbClr val="5A6572"/>
                 </a:solidFill>
-                <a:latin typeface="Calibri" pitchFamily="34" charset="0"/>
-                <a:ea typeface="Calibri" pitchFamily="34" charset="-122"/>
-                <a:cs typeface="Calibri" pitchFamily="34" charset="-120"/>
+                <a:latin typeface="Garamond" pitchFamily="34" charset="0"/>
+                <a:ea typeface="Garamond" pitchFamily="34" charset="-122"/>
+                <a:cs typeface="Garamond" pitchFamily="34" charset="-120"/>
               </a:rPr>
               <a:t>Notes: Share of college-graduate teachers (longest job last calendar year) not employed in a teaching occupation the following March; ASEC weights. Shaded band: 95 percent confidence interval using a design factor of 1.5. Dotted line: the 1997–2024 mean (8.6). The gray band marks the Covid supplements. Source: author’s calculations from March CPS supplements, survey years 1998–2025.</a:t>
             </a:r>
@@ -2513,9 +2747,48 @@
           <a:chExt cx="0" cy="0"/>
         </a:xfrm>
       </p:grpSpPr>
+      <p:sp>
+        <p:nvSpPr>
+          <p:cNvPr id="2" name="Text 0"/>
+          <p:cNvSpPr/>
+          <p:nvPr/>
+        </p:nvSpPr>
+        <p:spPr>
+          <a:xfrm>
+            <a:off x="457200" y="201168"/>
+            <a:ext cx="11274552" cy="502920"/>
+          </a:xfrm>
+          <a:prstGeom prst="rect">
+            <a:avLst/>
+          </a:prstGeom>
+          <a:noFill/>
+          <a:ln/>
+        </p:spPr>
+        <p:txBody>
+          <a:bodyPr wrap="square" lIns="0" tIns="0" rIns="0" bIns="0" rtlCol="0" anchor="ctr"/>
+          <a:lstStyle/>
+          <a:p>
+            <a:pPr algn="ctr" indent="0" marL="0">
+              <a:buNone/>
+            </a:pPr>
+            <a:r>
+              <a:rPr lang="en-US" sz="2100" dirty="0">
+                <a:solidFill>
+                  <a:srgbClr val="1A2430"/>
+                </a:solidFill>
+                <a:latin typeface="Garamond" pitchFamily="34" charset="0"/>
+                <a:ea typeface="Garamond" pitchFamily="34" charset="-122"/>
+                <a:cs typeface="Garamond" pitchFamily="34" charset="-120"/>
+              </a:rPr>
+              <a:t>Figure 3. Destinations of Teachers Who Leave the Profession</a:t>
+            </a:r>
+            <a:endParaRPr lang="en-US" sz="2100" dirty="0"/>
+          </a:p>
+        </p:txBody>
+      </p:sp>
       <p:pic>
         <p:nvPicPr>
-          <p:cNvPr id="2" name="Image 0" descr="figs_png/g3_flow100.png">    </p:cNvPr>
+          <p:cNvPr id="3" name="Image 0" descr="figs_png/g3_flow100.png">    </p:cNvPr>
           <p:cNvPicPr>
             <a:picLocks noChangeAspect="1"/>
           </p:cNvPicPr>
@@ -2529,8 +2802,8 @@
         </p:blipFill>
         <p:spPr>
           <a:xfrm>
-            <a:off x="655784" y="274320"/>
-            <a:ext cx="10877384" cy="5212080"/>
+            <a:off x="1180570" y="804672"/>
+            <a:ext cx="9827812" cy="4709160"/>
           </a:xfrm>
           <a:prstGeom prst="rect">
             <a:avLst/>
@@ -2539,13 +2812,13 @@
       </p:pic>
       <p:sp>
         <p:nvSpPr>
-          <p:cNvPr id="3" name="Text 0"/>
+          <p:cNvPr id="4" name="Text 1"/>
           <p:cNvSpPr/>
           <p:nvPr/>
         </p:nvSpPr>
         <p:spPr>
           <a:xfrm>
-            <a:off x="457200" y="5623560"/>
+            <a:off x="457200" y="5650992"/>
             <a:ext cx="11274552" cy="1097280"/>
           </a:xfrm>
           <a:prstGeom prst="rect">
@@ -2558,7 +2831,7 @@
           <a:bodyPr wrap="square" lIns="0" tIns="0" rIns="0" bIns="0" rtlCol="0" anchor="t"/>
           <a:lstStyle/>
           <a:p>
-            <a:pPr algn="l" indent="0" marL="0">
+            <a:pPr algn="just" indent="0" marL="0">
               <a:buNone/>
             </a:pPr>
             <a:r>
@@ -2566,9 +2839,9 @@
                 <a:solidFill>
                   <a:srgbClr val="5A6572"/>
                 </a:solidFill>
-                <a:latin typeface="Calibri" pitchFamily="34" charset="0"/>
-                <a:ea typeface="Calibri" pitchFamily="34" charset="-122"/>
-                <a:cs typeface="Calibri" pitchFamily="34" charset="-120"/>
+                <a:latin typeface="Garamond" pitchFamily="34" charset="0"/>
+                <a:ea typeface="Garamond" pitchFamily="34" charset="-122"/>
+                <a:cs typeface="Garamond" pitchFamily="34" charset="-120"/>
               </a:rPr>
               <a:t>Notes: College-graduate leavers pooled over calendar 2015–2024, ASEC weights. Top bar: labor force status the March after the teaching year; “out of the labor force” is split at age 55. Bottom bar: the occupational destination of the 26 employed leavers, rescaled to sum to their total. Source: author’s calculations from March CPS supplements.</a:t>
             </a:r>
@@ -2608,9 +2881,48 @@
           <a:chExt cx="0" cy="0"/>
         </a:xfrm>
       </p:grpSpPr>
+      <p:sp>
+        <p:nvSpPr>
+          <p:cNvPr id="2" name="Text 0"/>
+          <p:cNvSpPr/>
+          <p:nvPr/>
+        </p:nvSpPr>
+        <p:spPr>
+          <a:xfrm>
+            <a:off x="457200" y="201168"/>
+            <a:ext cx="11274552" cy="502920"/>
+          </a:xfrm>
+          <a:prstGeom prst="rect">
+            <a:avLst/>
+          </a:prstGeom>
+          <a:noFill/>
+          <a:ln/>
+        </p:spPr>
+        <p:txBody>
+          <a:bodyPr wrap="square" lIns="0" tIns="0" rIns="0" bIns="0" rtlCol="0" anchor="ctr"/>
+          <a:lstStyle/>
+          <a:p>
+            <a:pPr algn="ctr" indent="0" marL="0">
+              <a:buNone/>
+            </a:pPr>
+            <a:r>
+              <a:rPr lang="en-US" sz="2100" dirty="0">
+                <a:solidFill>
+                  <a:srgbClr val="1A2430"/>
+                </a:solidFill>
+                <a:latin typeface="Garamond" pitchFamily="34" charset="0"/>
+                <a:ea typeface="Garamond" pitchFamily="34" charset="-122"/>
+                <a:cs typeface="Garamond" pitchFamily="34" charset="-120"/>
+              </a:rPr>
+              <a:t>Figure 4. Leaving Teaching by Age and Route</a:t>
+            </a:r>
+            <a:endParaRPr lang="en-US" sz="2100" dirty="0"/>
+          </a:p>
+        </p:txBody>
+      </p:sp>
       <p:pic>
         <p:nvPicPr>
-          <p:cNvPr id="2" name="Image 0" descr="figs_png/g4_routes_age.png">    </p:cNvPr>
+          <p:cNvPr id="3" name="Image 0" descr="figs_png/g4_routes_age.png">    </p:cNvPr>
           <p:cNvPicPr>
             <a:picLocks noChangeAspect="1"/>
           </p:cNvPicPr>
@@ -2624,8 +2936,8 @@
         </p:blipFill>
         <p:spPr>
           <a:xfrm>
-            <a:off x="1006493" y="274320"/>
-            <a:ext cx="10175966" cy="5212080"/>
+            <a:off x="1497439" y="804672"/>
+            <a:ext cx="9194074" cy="4709160"/>
           </a:xfrm>
           <a:prstGeom prst="rect">
             <a:avLst/>
@@ -2634,13 +2946,13 @@
       </p:pic>
       <p:sp>
         <p:nvSpPr>
-          <p:cNvPr id="3" name="Text 0"/>
+          <p:cNvPr id="4" name="Text 1"/>
           <p:cNvSpPr/>
           <p:nvPr/>
         </p:nvSpPr>
         <p:spPr>
           <a:xfrm>
-            <a:off x="457200" y="5623560"/>
+            <a:off x="457200" y="5650992"/>
             <a:ext cx="11274552" cy="1097280"/>
           </a:xfrm>
           <a:prstGeom prst="rect">
@@ -2653,7 +2965,7 @@
           <a:bodyPr wrap="square" lIns="0" tIns="0" rIns="0" bIns="0" rtlCol="0" anchor="t"/>
           <a:lstStyle/>
           <a:p>
-            <a:pPr algn="l" indent="0" marL="0">
+            <a:pPr algn="just" indent="0" marL="0">
               <a:buNone/>
             </a:pPr>
             <a:r>
@@ -2661,9 +2973,9 @@
                 <a:solidFill>
                   <a:srgbClr val="5A6572"/>
                 </a:solidFill>
-                <a:latin typeface="Calibri" pitchFamily="34" charset="0"/>
-                <a:ea typeface="Calibri" pitchFamily="34" charset="-122"/>
-                <a:cs typeface="Calibri" pitchFamily="34" charset="-120"/>
+                <a:latin typeface="Garamond" pitchFamily="34" charset="0"/>
+                <a:ea typeface="Garamond" pitchFamily="34" charset="-122"/>
+                <a:cs typeface="Garamond" pitchFamily="34" charset="-120"/>
               </a:rPr>
               <a:t>Notes: College-graduate teachers pooled over calendar 2015–2024, ASEC weights; ten age groups. The black line is the total leaving rate; stacked areas decompose it into exits to another job, unemployment, and out of the labor force. Source: author’s calculations from March CPS supplements.</a:t>
             </a:r>
@@ -2703,9 +3015,48 @@
           <a:chExt cx="0" cy="0"/>
         </a:xfrm>
       </p:grpSpPr>
+      <p:sp>
+        <p:nvSpPr>
+          <p:cNvPr id="2" name="Text 0"/>
+          <p:cNvSpPr/>
+          <p:nvPr/>
+        </p:nvSpPr>
+        <p:spPr>
+          <a:xfrm>
+            <a:off x="457200" y="201168"/>
+            <a:ext cx="11274552" cy="502920"/>
+          </a:xfrm>
+          <a:prstGeom prst="rect">
+            <a:avLst/>
+          </a:prstGeom>
+          <a:noFill/>
+          <a:ln/>
+        </p:spPr>
+        <p:txBody>
+          <a:bodyPr wrap="square" lIns="0" tIns="0" rIns="0" bIns="0" rtlCol="0" anchor="ctr"/>
+          <a:lstStyle/>
+          <a:p>
+            <a:pPr algn="ctr" indent="0" marL="0">
+              <a:buNone/>
+            </a:pPr>
+            <a:r>
+              <a:rPr lang="en-US" sz="2100" dirty="0">
+                <a:solidFill>
+                  <a:srgbClr val="1A2430"/>
+                </a:solidFill>
+                <a:latin typeface="Garamond" pitchFamily="34" charset="0"/>
+                <a:ea typeface="Garamond" pitchFamily="34" charset="-122"/>
+                <a:cs typeface="Garamond" pitchFamily="34" charset="-120"/>
+              </a:rPr>
+              <a:t>Figure 5. Exit Routes by School Sector</a:t>
+            </a:r>
+            <a:endParaRPr lang="en-US" sz="2100" dirty="0"/>
+          </a:p>
+        </p:txBody>
+      </p:sp>
       <p:pic>
         <p:nvPicPr>
-          <p:cNvPr id="2" name="Image 0" descr="figs_png/g10_sector_routes.png">    </p:cNvPr>
+          <p:cNvPr id="3" name="Image 0" descr="figs_png/g10_sector_routes.png">    </p:cNvPr>
           <p:cNvPicPr>
             <a:picLocks noChangeAspect="1"/>
           </p:cNvPicPr>
@@ -2719,8 +3070,8 @@
         </p:blipFill>
         <p:spPr>
           <a:xfrm>
-            <a:off x="1684254" y="274320"/>
-            <a:ext cx="8820443" cy="5212080"/>
+            <a:off x="2109802" y="804672"/>
+            <a:ext cx="7969348" cy="4709160"/>
           </a:xfrm>
           <a:prstGeom prst="rect">
             <a:avLst/>
@@ -2729,13 +3080,13 @@
       </p:pic>
       <p:sp>
         <p:nvSpPr>
-          <p:cNvPr id="3" name="Text 0"/>
+          <p:cNvPr id="4" name="Text 1"/>
           <p:cNvSpPr/>
           <p:nvPr/>
         </p:nvSpPr>
         <p:spPr>
           <a:xfrm>
-            <a:off x="457200" y="5623560"/>
+            <a:off x="457200" y="5650992"/>
             <a:ext cx="11274552" cy="1097280"/>
           </a:xfrm>
           <a:prstGeom prst="rect">
@@ -2748,7 +3099,7 @@
           <a:bodyPr wrap="square" lIns="0" tIns="0" rIns="0" bIns="0" rtlCol="0" anchor="t"/>
           <a:lstStyle/>
           <a:p>
-            <a:pPr algn="l" indent="0" marL="0">
+            <a:pPr algn="just" indent="0" marL="0">
               <a:buNone/>
             </a:pPr>
             <a:r>
@@ -2756,9 +3107,9 @@
                 <a:solidFill>
                   <a:srgbClr val="5A6572"/>
                 </a:solidFill>
-                <a:latin typeface="Calibri" pitchFamily="34" charset="0"/>
-                <a:ea typeface="Calibri" pitchFamily="34" charset="-122"/>
-                <a:cs typeface="Calibri" pitchFamily="34" charset="-120"/>
+                <a:latin typeface="Garamond" pitchFamily="34" charset="0"/>
+                <a:ea typeface="Garamond" pitchFamily="34" charset="-122"/>
+                <a:cs typeface="Garamond" pitchFamily="34" charset="-120"/>
               </a:rPr>
               <a:t>Notes: Route-specific annual exit rates of college-graduate teachers by sector of the last-year job (class of worker: government vs. private), pooled 2015–2024, ASEC weights. A private-school teacher who moves to a public school—or vice versa—remains a teacher and is not a leaver here. Source: author’s calculations from March CPS supplements.</a:t>
             </a:r>
@@ -2798,9 +3149,48 @@
           <a:chExt cx="0" cy="0"/>
         </a:xfrm>
       </p:grpSpPr>
+      <p:sp>
+        <p:nvSpPr>
+          <p:cNvPr id="2" name="Text 0"/>
+          <p:cNvSpPr/>
+          <p:nvPr/>
+        </p:nvSpPr>
+        <p:spPr>
+          <a:xfrm>
+            <a:off x="457200" y="201168"/>
+            <a:ext cx="11274552" cy="502920"/>
+          </a:xfrm>
+          <a:prstGeom prst="rect">
+            <a:avLst/>
+          </a:prstGeom>
+          <a:noFill/>
+          <a:ln/>
+        </p:spPr>
+        <p:txBody>
+          <a:bodyPr wrap="square" lIns="0" tIns="0" rIns="0" bIns="0" rtlCol="0" anchor="ctr"/>
+          <a:lstStyle/>
+          <a:p>
+            <a:pPr algn="ctr" indent="0" marL="0">
+              <a:buNone/>
+            </a:pPr>
+            <a:r>
+              <a:rPr lang="en-US" sz="2100" dirty="0">
+                <a:solidFill>
+                  <a:srgbClr val="1A2430"/>
+                </a:solidFill>
+                <a:latin typeface="Garamond" pitchFamily="34" charset="0"/>
+                <a:ea typeface="Garamond" pitchFamily="34" charset="-122"/>
+                <a:cs typeface="Garamond" pitchFamily="34" charset="-120"/>
+              </a:rPr>
+              <a:t>Figure 6. The Effect of a New Baby on Leaving, by Profession</a:t>
+            </a:r>
+            <a:endParaRPr lang="en-US" sz="2100" dirty="0"/>
+          </a:p>
+        </p:txBody>
+      </p:sp>
       <p:pic>
         <p:nvPicPr>
-          <p:cNvPr id="2" name="Image 0" descr="figs_png/g8_newbaby.png">    </p:cNvPr>
+          <p:cNvPr id="3" name="Image 0" descr="figs_png/g8_newbaby.png">    </p:cNvPr>
           <p:cNvPicPr>
             <a:picLocks noChangeAspect="1"/>
           </p:cNvPicPr>
@@ -2814,8 +3204,8 @@
         </p:blipFill>
         <p:spPr>
           <a:xfrm>
-            <a:off x="1590173" y="274320"/>
-            <a:ext cx="9008606" cy="5212080"/>
+            <a:off x="2024799" y="804672"/>
+            <a:ext cx="8139355" cy="4709160"/>
           </a:xfrm>
           <a:prstGeom prst="rect">
             <a:avLst/>
@@ -2824,13 +3214,13 @@
       </p:pic>
       <p:sp>
         <p:nvSpPr>
-          <p:cNvPr id="3" name="Text 0"/>
+          <p:cNvPr id="4" name="Text 1"/>
           <p:cNvSpPr/>
           <p:nvPr/>
         </p:nvSpPr>
         <p:spPr>
           <a:xfrm>
-            <a:off x="457200" y="5623560"/>
+            <a:off x="457200" y="5650992"/>
             <a:ext cx="11274552" cy="1097280"/>
           </a:xfrm>
           <a:prstGeom prst="rect">
@@ -2843,7 +3233,7 @@
           <a:bodyPr wrap="square" lIns="0" tIns="0" rIns="0" bIns="0" rtlCol="0" anchor="t"/>
           <a:lstStyle/>
           <a:p>
-            <a:pPr algn="l" indent="0" marL="0">
+            <a:pPr algn="just" indent="0" marL="0">
               <a:buNone/>
             </a:pPr>
             <a:r>
@@ -2851,9 +3241,9 @@
                 <a:solidFill>
                   <a:srgbClr val="5A6572"/>
                 </a:solidFill>
-                <a:latin typeface="Calibri" pitchFamily="34" charset="0"/>
-                <a:ea typeface="Calibri" pitchFamily="34" charset="-122"/>
-                <a:cs typeface="Calibri" pitchFamily="34" charset="-120"/>
+                <a:latin typeface="Garamond" pitchFamily="34" charset="0"/>
+                <a:ea typeface="Garamond" pitchFamily="34" charset="-122"/>
+                <a:cs typeface="Garamond" pitchFamily="34" charset="-120"/>
               </a:rPr>
               <a:t>Notes: Average marginal effect of a new baby (own child aged 0 in the household) on the probability that a woman leaves each profession, from profession-specific probits with age, age squared, marital status, education, and year effects; whiskers are 95 percent confidence intervals. Solid bars are significant at 5 percent; light bars are not. Samples pool 2010–2024. Source: author’s calculations from March CPS supplements.</a:t>
             </a:r>
@@ -2893,9 +3283,48 @@
           <a:chExt cx="0" cy="0"/>
         </a:xfrm>
       </p:grpSpPr>
+      <p:sp>
+        <p:nvSpPr>
+          <p:cNvPr id="2" name="Text 0"/>
+          <p:cNvSpPr/>
+          <p:nvPr/>
+        </p:nvSpPr>
+        <p:spPr>
+          <a:xfrm>
+            <a:off x="457200" y="201168"/>
+            <a:ext cx="11274552" cy="502920"/>
+          </a:xfrm>
+          <a:prstGeom prst="rect">
+            <a:avLst/>
+          </a:prstGeom>
+          <a:noFill/>
+          <a:ln/>
+        </p:spPr>
+        <p:txBody>
+          <a:bodyPr wrap="square" lIns="0" tIns="0" rIns="0" bIns="0" rtlCol="0" anchor="ctr"/>
+          <a:lstStyle/>
+          <a:p>
+            <a:pPr algn="ctr" indent="0" marL="0">
+              <a:buNone/>
+            </a:pPr>
+            <a:r>
+              <a:rPr lang="en-US" sz="2100" dirty="0">
+                <a:solidFill>
+                  <a:srgbClr val="1A2430"/>
+                </a:solidFill>
+                <a:latin typeface="Garamond" pitchFamily="34" charset="0"/>
+                <a:ea typeface="Garamond" pitchFamily="34" charset="-122"/>
+                <a:cs typeface="Garamond" pitchFamily="34" charset="-120"/>
+              </a:rPr>
+              <a:t>Figure 7. Labor Force Exit of Women Teachers, With and Without Young Children</a:t>
+            </a:r>
+            <a:endParaRPr lang="en-US" sz="2100" dirty="0"/>
+          </a:p>
+        </p:txBody>
+      </p:sp>
       <p:pic>
         <p:nvPicPr>
-          <p:cNvPr id="2" name="Image 0" descr="figs_png/g9_mothers.png">    </p:cNvPr>
+          <p:cNvPr id="3" name="Image 0" descr="figs_png/g9_mothers.png">    </p:cNvPr>
           <p:cNvPicPr>
             <a:picLocks noChangeAspect="1"/>
           </p:cNvPicPr>
@@ -2909,8 +3338,8 @@
         </p:blipFill>
         <p:spPr>
           <a:xfrm>
-            <a:off x="882396" y="274320"/>
-            <a:ext cx="10424160" cy="5212080"/>
+            <a:off x="1385316" y="804672"/>
+            <a:ext cx="9418320" cy="4709160"/>
           </a:xfrm>
           <a:prstGeom prst="rect">
             <a:avLst/>
@@ -2919,13 +3348,13 @@
       </p:pic>
       <p:sp>
         <p:nvSpPr>
-          <p:cNvPr id="3" name="Text 0"/>
+          <p:cNvPr id="4" name="Text 1"/>
           <p:cNvSpPr/>
           <p:nvPr/>
         </p:nvSpPr>
         <p:spPr>
           <a:xfrm>
-            <a:off x="457200" y="5623560"/>
+            <a:off x="457200" y="5650992"/>
             <a:ext cx="11274552" cy="1097280"/>
           </a:xfrm>
           <a:prstGeom prst="rect">
@@ -2938,7 +3367,7 @@
           <a:bodyPr wrap="square" lIns="0" tIns="0" rIns="0" bIns="0" rtlCol="0" anchor="t"/>
           <a:lstStyle/>
           <a:p>
-            <a:pPr algn="l" indent="0" marL="0">
+            <a:pPr algn="just" indent="0" marL="0">
               <a:buNone/>
             </a:pPr>
             <a:r>
@@ -2946,9 +3375,9 @@
                 <a:solidFill>
                   <a:srgbClr val="5A6572"/>
                 </a:solidFill>
-                <a:latin typeface="Calibri" pitchFamily="34" charset="0"/>
-                <a:ea typeface="Calibri" pitchFamily="34" charset="-122"/>
-                <a:cs typeface="Calibri" pitchFamily="34" charset="-120"/>
+                <a:latin typeface="Garamond" pitchFamily="34" charset="0"/>
+                <a:ea typeface="Garamond" pitchFamily="34" charset="-122"/>
+                <a:cs typeface="Garamond" pitchFamily="34" charset="-120"/>
               </a:rPr>
               <a:t>Notes: Women teachers aged 22–45, college graduates; annual probability of leaving the labor force (thin lines) and centered 3-year averages (bold), separately for those with and without an own child under 6 at home. Endpoint values printed. Source: author’s calculations from March CPS supplements, survey years 1998–2025.</a:t>
             </a:r>
@@ -2988,9 +3417,48 @@
           <a:chExt cx="0" cy="0"/>
         </a:xfrm>
       </p:grpSpPr>
+      <p:sp>
+        <p:nvSpPr>
+          <p:cNvPr id="2" name="Text 0"/>
+          <p:cNvSpPr/>
+          <p:nvPr/>
+        </p:nvSpPr>
+        <p:spPr>
+          <a:xfrm>
+            <a:off x="457200" y="201168"/>
+            <a:ext cx="11274552" cy="502920"/>
+          </a:xfrm>
+          <a:prstGeom prst="rect">
+            <a:avLst/>
+          </a:prstGeom>
+          <a:noFill/>
+          <a:ln/>
+        </p:spPr>
+        <p:txBody>
+          <a:bodyPr wrap="square" lIns="0" tIns="0" rIns="0" bIns="0" rtlCol="0" anchor="ctr"/>
+          <a:lstStyle/>
+          <a:p>
+            <a:pPr algn="ctr" indent="0" marL="0">
+              <a:buNone/>
+            </a:pPr>
+            <a:r>
+              <a:rPr lang="en-US" sz="2100" dirty="0">
+                <a:solidFill>
+                  <a:srgbClr val="1A2430"/>
+                </a:solidFill>
+                <a:latin typeface="Garamond" pitchFamily="34" charset="0"/>
+                <a:ea typeface="Garamond" pitchFamily="34" charset="-122"/>
+                <a:cs typeface="Garamond" pitchFamily="34" charset="-120"/>
+              </a:rPr>
+              <a:t>Figure 8. Leaving Teaching and the Unemployment Rate, 1997–2024</a:t>
+            </a:r>
+            <a:endParaRPr lang="en-US" sz="2100" dirty="0"/>
+          </a:p>
+        </p:txBody>
+      </p:sp>
       <p:pic>
         <p:nvPicPr>
-          <p:cNvPr id="2" name="Image 0" descr="figs_png/n5_cyclicality.png">    </p:cNvPr>
+          <p:cNvPr id="3" name="Image 0" descr="figs_png/n5_cyclicality.png">    </p:cNvPr>
           <p:cNvPicPr>
             <a:picLocks noChangeAspect="1"/>
           </p:cNvPicPr>
@@ -3004,7 +3472,7 @@
         </p:blipFill>
         <p:spPr>
           <a:xfrm>
-            <a:off x="470916" y="793341"/>
+            <a:off x="470916" y="1072233"/>
             <a:ext cx="11247120" cy="4174039"/>
           </a:xfrm>
           <a:prstGeom prst="rect">
@@ -3014,13 +3482,13 @@
       </p:pic>
       <p:sp>
         <p:nvSpPr>
-          <p:cNvPr id="3" name="Text 0"/>
+          <p:cNvPr id="4" name="Text 1"/>
           <p:cNvSpPr/>
           <p:nvPr/>
         </p:nvSpPr>
         <p:spPr>
           <a:xfrm>
-            <a:off x="457200" y="5623560"/>
+            <a:off x="457200" y="5650992"/>
             <a:ext cx="11274552" cy="1097280"/>
           </a:xfrm>
           <a:prstGeom prst="rect">
@@ -3033,7 +3501,7 @@
           <a:bodyPr wrap="square" lIns="0" tIns="0" rIns="0" bIns="0" rtlCol="0" anchor="t"/>
           <a:lstStyle/>
           <a:p>
-            <a:pPr algn="l" indent="0" marL="0">
+            <a:pPr algn="just" indent="0" marL="0">
               <a:buNone/>
             </a:pPr>
             <a:r>
@@ -3041,9 +3509,9 @@
                 <a:solidFill>
                   <a:srgbClr val="5A6572"/>
                 </a:solidFill>
-                <a:latin typeface="Calibri" pitchFamily="34" charset="0"/>
-                <a:ea typeface="Calibri" pitchFamily="34" charset="-122"/>
-                <a:cs typeface="Calibri" pitchFamily="34" charset="-120"/>
+                <a:latin typeface="Garamond" pitchFamily="34" charset="0"/>
+                <a:ea typeface="Garamond" pitchFamily="34" charset="-122"/>
+                <a:cs typeface="Garamond" pitchFamily="34" charset="-120"/>
               </a:rPr>
               <a:t>Notes: Left: the leaving series (annual, from calendar 2000) against the BLS national unemployment rate (annual average). Right: binned scatter (deciles of the unemployment rate in the survey month, March of t+1, when the exit is observed) of the two labor-market routes, with OLS fits on the underlying annual data; correlations are −0.16 (to another job) and +0.29 (out of the labor force). Unemployment: BLS via FRED (UNRATE). Source: author’s calculations from March CPS supplements.</a:t>
             </a:r>
@@ -3083,9 +3551,48 @@
           <a:chExt cx="0" cy="0"/>
         </a:xfrm>
       </p:grpSpPr>
+      <p:sp>
+        <p:nvSpPr>
+          <p:cNvPr id="2" name="Text 0"/>
+          <p:cNvSpPr/>
+          <p:nvPr/>
+        </p:nvSpPr>
+        <p:spPr>
+          <a:xfrm>
+            <a:off x="457200" y="201168"/>
+            <a:ext cx="11274552" cy="502920"/>
+          </a:xfrm>
+          <a:prstGeom prst="rect">
+            <a:avLst/>
+          </a:prstGeom>
+          <a:noFill/>
+          <a:ln/>
+        </p:spPr>
+        <p:txBody>
+          <a:bodyPr wrap="square" lIns="0" tIns="0" rIns="0" bIns="0" rtlCol="0" anchor="ctr"/>
+          <a:lstStyle/>
+          <a:p>
+            <a:pPr algn="ctr" indent="0" marL="0">
+              <a:buNone/>
+            </a:pPr>
+            <a:r>
+              <a:rPr lang="en-US" sz="2100" dirty="0">
+                <a:solidFill>
+                  <a:srgbClr val="1A2430"/>
+                </a:solidFill>
+                <a:latin typeface="Garamond" pitchFamily="34" charset="0"/>
+                <a:ea typeface="Garamond" pitchFamily="34" charset="-122"/>
+                <a:cs typeface="Garamond" pitchFamily="34" charset="-120"/>
+              </a:rPr>
+              <a:t>Figure 9. Leaving and State Unemployment: Two Examples</a:t>
+            </a:r>
+            <a:endParaRPr lang="en-US" sz="2100" dirty="0"/>
+          </a:p>
+        </p:txBody>
+      </p:sp>
       <p:pic>
         <p:nvPicPr>
-          <p:cNvPr id="2" name="Image 0" descr="figs_png/n5b_states_trio.png">    </p:cNvPr>
+          <p:cNvPr id="3" name="Image 0" descr="figs_png/n5b_states_trio.png">    </p:cNvPr>
           <p:cNvPicPr>
             <a:picLocks noChangeAspect="1"/>
           </p:cNvPicPr>
@@ -3099,8 +3606,8 @@
         </p:blipFill>
         <p:spPr>
           <a:xfrm>
-            <a:off x="470916" y="331623"/>
-            <a:ext cx="11247120" cy="5097474"/>
+            <a:off x="899307" y="804672"/>
+            <a:ext cx="10390339" cy="4709160"/>
           </a:xfrm>
           <a:prstGeom prst="rect">
             <a:avLst/>
@@ -3109,13 +3616,13 @@
       </p:pic>
       <p:sp>
         <p:nvSpPr>
-          <p:cNvPr id="3" name="Text 0"/>
+          <p:cNvPr id="4" name="Text 1"/>
           <p:cNvSpPr/>
           <p:nvPr/>
         </p:nvSpPr>
         <p:spPr>
           <a:xfrm>
-            <a:off x="457200" y="5623560"/>
+            <a:off x="457200" y="5650992"/>
             <a:ext cx="11274552" cy="1097280"/>
           </a:xfrm>
           <a:prstGeom prst="rect">
@@ -3128,7 +3635,7 @@
           <a:bodyPr wrap="square" lIns="0" tIns="0" rIns="0" bIns="0" rtlCol="0" anchor="t"/>
           <a:lstStyle/>
           <a:p>
-            <a:pPr algn="l" indent="0" marL="0">
+            <a:pPr algn="just" indent="0" marL="0">
               <a:buNone/>
             </a:pPr>
             <a:r>
@@ -3136,9 +3643,9 @@
                 <a:solidFill>
                   <a:srgbClr val="5A6572"/>
                 </a:solidFill>
-                <a:latin typeface="Calibri" pitchFamily="34" charset="0"/>
-                <a:ea typeface="Calibri" pitchFamily="34" charset="-122"/>
-                <a:cs typeface="Calibri" pitchFamily="34" charset="-120"/>
+                <a:latin typeface="Garamond" pitchFamily="34" charset="0"/>
+                <a:ea typeface="Garamond" pitchFamily="34" charset="-122"/>
+                <a:cs typeface="Garamond" pitchFamily="34" charset="-120"/>
               </a:rPr>
               <a:t>Notes: Annual state leaving rates of college-graduate teachers (dots; one per year, 1997–2024) against the state unemployment rate in the survey month (BLS Local Area Unemployment Statistics), with OLS fits. North Carolina and New Jersey are shown as examples of the two signs. State of residence is recovered from the household records of the raw files. Source: author’s calculations from March CPS supplements.</a:t>
             </a:r>

</xml_diff>

<commit_message>
Slide deck: cover slide and concise speaker notes
Co-Authored-By: Claude Fable 5 <noreply@anthropic.com>
Claude-Session: https://claude.ai/code/session_01DNzQPDcr3zfLTraMHUHqUn
</commit_message>
<xml_diff>
--- a/report/teacher_attrition_figures.pptx
+++ b/report/teacher_attrition_figures.pptx
@@ -18,9 +18,10 @@
     <p:sldId id="266" r:id="rId12"/>
     <p:sldId id="267" r:id="rId13"/>
     <p:sldId id="268" r:id="rId14"/>
+    <p:sldId id="269" r:id="rId15"/>
   </p:sldIdLst>
   <p:notesMasterIdLst>
-    <p:notesMasterId r:id="rId15"/>
+    <p:notesMasterId r:id="rId16"/>
   </p:notesMasterIdLst>
   <p:sldSz cx="12192000" cy="6858000"/>
   <p:notesSz cx="6858000" cy="12192000"/>
@@ -514,7 +515,7 @@
           <a:p>
             <a:r>
               <a:rPr lang="en-US" dirty="0"/>
-              <a:t/>
+              <a:t>One question, one instrument, twenty-eight years. The exodus is the claim, the anatomy is the answer.</a:t>
             </a:r>
             <a:endParaRPr lang="en-US" dirty="0"/>
           </a:p>
@@ -602,7 +603,7 @@
           <a:p>
             <a:r>
               <a:rPr lang="en-US" dirty="0"/>
-              <a:t/>
+              <a:t>Fifty-one regressions, four significant slopes, all on the recession side. Not one state shows teachers leaving when the economy heats up.</a:t>
             </a:r>
             <a:endParaRPr lang="en-US" dirty="0"/>
           </a:p>
@@ -690,7 +691,7 @@
           <a:p>
             <a:r>
               <a:rPr lang="en-US" dirty="0"/>
-              <a:t/>
+              <a:t>Switching pays a median of 15 log points, with enormous tails. A quarter lose big, and 47 percent of all leavers earn nothing at all. Leaving is a gamble, and teachers act accordingly.</a:t>
             </a:r>
             <a:endParaRPr lang="en-US" dirty="0"/>
           </a:p>
@@ -778,7 +779,7 @@
           <a:p>
             <a:r>
               <a:rPr lang="en-US" dirty="0"/>
-              <a:t/>
+              <a:t>Teacher pay is flat at 66,000 dollars while every comparison profession moved up. The penalty grew from 20 to 28 percent of the college median.</a:t>
             </a:r>
             <a:endParaRPr lang="en-US" dirty="0"/>
           </a:p>
@@ -866,7 +867,7 @@
           <a:p>
             <a:r>
               <a:rPr lang="en-US" dirty="0"/>
-              <a:t/>
+              <a:t>The contract predicts exit, the person barely does. Full-year work, hours and pension coverage dwarf every demographic. The one personal event that matters is a birth.</a:t>
             </a:r>
             <a:endParaRPr lang="en-US" dirty="0"/>
           </a:p>
@@ -890,6 +891,94 @@
             <a:fld id="{F7021451-1387-4CA6-816F-3879F97B5CBC}" type="slidenum">
               <a:rPr lang="en-US"/>
               <a:t>13</a:t>
+            </a:fld>
+            <a:endParaRPr lang="en-US"/>
+          </a:p>
+        </p:txBody>
+      </p:sp>
+    </p:spTree>
+    <p:extLst>
+      <p:ext uri="{BB962C8B-B14F-4D97-AF65-F5344CB8AC3E}">
+        <p14:creationId xmlns:p14="http://schemas.microsoft.com/office/powerpoint/2010/main" val="1024086991"/>
+      </p:ext>
+    </p:extLst>
+  </p:cSld>
+  <p:clrMapOvr>
+    <a:masterClrMapping/>
+  </p:clrMapOvr>
+</p:notes>
+</file>
+
+<file path=ppt/notesSlides/notesSlide14.xml><?xml version="1.0" encoding="utf-8"?>
+<p:notes xmlns:a="http://schemas.openxmlformats.org/drawingml/2006/main" xmlns:r="http://schemas.openxmlformats.org/officeDocument/2006/relationships" xmlns:p="http://schemas.openxmlformats.org/presentationml/2006/main">
+  <p:cSld>
+    <p:spTree>
+      <p:nvGrpSpPr>
+        <p:cNvPr id="1" name=""/>
+        <p:cNvGrpSpPr/>
+        <p:nvPr/>
+      </p:nvGrpSpPr>
+      <p:grpSpPr>
+        <a:xfrm>
+          <a:off x="0" y="0"/>
+          <a:ext cx="0" cy="0"/>
+          <a:chOff x="0" y="0"/>
+          <a:chExt cx="0" cy="0"/>
+        </a:xfrm>
+      </p:grpSpPr>
+      <p:sp>
+        <p:nvSpPr>
+          <p:cNvPr id="2" name="Slide Image Placeholder 1"/>
+          <p:cNvSpPr>
+            <a:spLocks noGrp="1" noRot="1" noChangeAspect="1"/>
+          </p:cNvSpPr>
+          <p:nvPr>
+            <p:ph type="sldImg"/>
+          </p:nvPr>
+        </p:nvSpPr>
+        <p:spPr/>
+      </p:sp>
+      <p:sp>
+        <p:nvSpPr>
+          <p:cNvPr id="3" name="Notes Placeholder 2"/>
+          <p:cNvSpPr>
+            <a:spLocks noGrp="1"/>
+          </p:cNvSpPr>
+          <p:nvPr>
+            <p:ph type="body" idx="1"/>
+          </p:nvPr>
+        </p:nvSpPr>
+        <p:spPr/>
+        <p:txBody>
+          <a:bodyPr/>
+          <a:lstStyle/>
+          <a:p>
+            <a:r>
+              <a:rPr lang="en-US" dirty="0"/>
+              <a:t>Teaching is the only profession here whose attrition fell across decades. Whatever is pushing pharmacists and therapists up is economy-wide, not a crisis of schools.</a:t>
+            </a:r>
+            <a:endParaRPr lang="en-US" dirty="0"/>
+          </a:p>
+        </p:txBody>
+      </p:sp>
+      <p:sp>
+        <p:nvSpPr>
+          <p:cNvPr id="4" name="Slide Number Placeholder 3"/>
+          <p:cNvSpPr>
+            <a:spLocks noGrp="1"/>
+          </p:cNvSpPr>
+          <p:nvPr>
+            <p:ph type="sldNum" sz="quarter" idx="10"/>
+          </p:nvPr>
+        </p:nvSpPr>
+        <p:spPr/>
+        <p:txBody>
+          <a:bodyPr/>
+          <a:lstStyle/>
+          <a:p>
+            <a:fld id="{F7021451-1387-4CA6-816F-3879F97B5CBC}" type="slidenum">
+              <a:rPr lang="en-US"/>
+              <a:t>14</a:t>
             </a:fld>
             <a:endParaRPr lang="en-US"/>
           </a:p>
@@ -954,7 +1043,7 @@
           <a:p>
             <a:r>
               <a:rPr lang="en-US" dirty="0"/>
-              <a:t/>
+              <a:t>The workforce is aging and its pension coverage has fallen from 80 to 66 percent. The contract is deteriorating on exactly the margin that predicts exit.</a:t>
             </a:r>
             <a:endParaRPr lang="en-US" dirty="0"/>
           </a:p>
@@ -1042,7 +1131,7 @@
           <a:p>
             <a:r>
               <a:rPr lang="en-US" dirty="0"/>
-              <a:t/>
+              <a:t>Twenty-eight years, no trend. The two worst years are 2001 and 2019, a generation apart. Any exodus narrative starts from a fact this series does not contain.</a:t>
             </a:r>
             <a:endParaRPr lang="en-US" dirty="0"/>
           </a:p>
@@ -1130,7 +1219,7 @@
           <a:p>
             <a:r>
               <a:rPr lang="en-US" dirty="0"/>
-              <a:t/>
+              <a:t>Of every 100 leavers, only 26 hold another job the next March. The exodus scenario, a working-age teacher productively employed elsewhere, is barely one leaver in six.</a:t>
             </a:r>
             <a:endParaRPr lang="en-US" dirty="0"/>
           </a:p>
@@ -1218,7 +1307,7 @@
           <a:p>
             <a:r>
               <a:rPr lang="en-US" dirty="0"/>
-              <a:t/>
+              <a:t>The age profile is a U. The left arm is career search, the right arm is retirement. Mid-career teachers, the ones schools most need to keep, are the least mobile workers in the figure.</a:t>
             </a:r>
             <a:endParaRPr lang="en-US" dirty="0"/>
           </a:p>
@@ -1306,7 +1395,7 @@
           <a:p>
             <a:r>
               <a:rPr lang="en-US" dirty="0"/>
-              <a:t/>
+              <a:t>Private schools lose teachers at twice the public rate, through every route. Tenure, salary schedules and pensions are retention policy that already works.</a:t>
             </a:r>
             <a:endParaRPr lang="en-US" dirty="0"/>
           </a:p>
@@ -1394,7 +1483,7 @@
           <a:p>
             <a:r>
               <a:rPr lang="en-US" dirty="0"/>
-              <a:t/>
+              <a:t>A birth raises a teacher's exit by twice as much as a nurse's. Teaching is the college profession where a classroom cannot be covered part time.</a:t>
             </a:r>
             <a:endParaRPr lang="en-US" dirty="0"/>
           </a:p>
@@ -1482,7 +1571,7 @@
           <a:p>
             <a:r>
               <a:rPr lang="en-US" dirty="0"/>
-              <a:t/>
+              <a:t>The classic exit to home is disappearing. The gap between mothers and other young women teachers went from seven points to under two in twenty-five years.</a:t>
             </a:r>
             <a:endParaRPr lang="en-US" dirty="0"/>
           </a:p>
@@ -1570,7 +1659,7 @@
           <a:p>
             <a:r>
               <a:rPr lang="en-US" dirty="0"/>
-              <a:t/>
+              <a:t>Booms do not poach teachers. Where exits respond to the cycle at all, recessions push them out. The poaching story has no support in the data.</a:t>
             </a:r>
             <a:endParaRPr lang="en-US" dirty="0"/>
           </a:p>
@@ -1951,8 +2040,8 @@
         </p:nvSpPr>
         <p:spPr>
           <a:xfrm>
-            <a:off x="457200" y="201168"/>
-            <a:ext cx="11274552" cy="502920"/>
+            <a:off x="731520" y="1965960"/>
+            <a:ext cx="10725912" cy="914400"/>
           </a:xfrm>
           <a:prstGeom prst="rect">
             <a:avLst/>
@@ -1968,7 +2057,7 @@
               <a:buNone/>
             </a:pPr>
             <a:r>
-              <a:rPr lang="en-US" sz="2100" dirty="0">
+              <a:rPr lang="en-US" sz="4000" dirty="0">
                 <a:solidFill>
                   <a:srgbClr val="1A2430"/>
                 </a:solidFill>
@@ -1976,46 +2065,22 @@
                 <a:ea typeface="Garamond" pitchFamily="34" charset="-122"/>
                 <a:cs typeface="Garamond" pitchFamily="34" charset="-120"/>
               </a:rPr>
-              <a:t>Figure 1. Composition of the Teaching Workforce, 2005–2024</a:t>
-            </a:r>
-            <a:endParaRPr lang="en-US" sz="2100" dirty="0"/>
-          </a:p>
-        </p:txBody>
-      </p:sp>
-      <p:pic>
-        <p:nvPicPr>
-          <p:cNvPr id="3" name="Image 0" descr="figs_png/g1_workforce.png">    </p:cNvPr>
-          <p:cNvPicPr>
-            <a:picLocks noChangeAspect="1"/>
-          </p:cNvPicPr>
-          <p:nvPr/>
-        </p:nvPicPr>
-        <p:blipFill>
-          <a:blip r:embed="rId1"/>
-          <a:stretch>
-            <a:fillRect/>
-          </a:stretch>
-        </p:blipFill>
-        <p:spPr>
-          <a:xfrm>
-            <a:off x="1133040" y="804672"/>
-            <a:ext cx="9922873" cy="4709160"/>
-          </a:xfrm>
-          <a:prstGeom prst="rect">
-            <a:avLst/>
-          </a:prstGeom>
-        </p:spPr>
-      </p:pic>
-      <p:sp>
-        <p:nvSpPr>
-          <p:cNvPr id="4" name="Text 1"/>
+              <a:t>Who Leaves Teaching, and Why?</a:t>
+            </a:r>
+            <a:endParaRPr lang="en-US" sz="4000" dirty="0"/>
+          </a:p>
+        </p:txBody>
+      </p:sp>
+      <p:sp>
+        <p:nvSpPr>
+          <p:cNvPr id="3" name="Text 1"/>
           <p:cNvSpPr/>
           <p:nvPr/>
         </p:nvSpPr>
         <p:spPr>
           <a:xfrm>
-            <a:off x="457200" y="5650992"/>
-            <a:ext cx="11274552" cy="1097280"/>
+            <a:off x="731520" y="2971800"/>
+            <a:ext cx="10725912" cy="548640"/>
           </a:xfrm>
           <a:prstGeom prst="rect">
             <a:avLst/>
@@ -2024,14 +2089,92 @@
           <a:ln/>
         </p:spPr>
         <p:txBody>
-          <a:bodyPr wrap="square" lIns="0" tIns="0" rIns="0" bIns="0" rtlCol="0" anchor="t"/>
-          <a:lstStyle/>
-          <a:p>
-            <a:pPr algn="just" indent="0" marL="0">
+          <a:bodyPr wrap="square" lIns="0" tIns="0" rIns="0" bIns="0" rtlCol="0" anchor="ctr"/>
+          <a:lstStyle/>
+          <a:p>
+            <a:pPr algn="ctr" indent="0" marL="0">
               <a:buNone/>
             </a:pPr>
             <a:r>
-              <a:rPr lang="en-US" sz="950" dirty="0">
+              <a:rPr lang="en-US" sz="2200" dirty="0">
+                <a:solidFill>
+                  <a:srgbClr val="1A2430"/>
+                </a:solidFill>
+                <a:latin typeface="Garamond" pitchFamily="34" charset="0"/>
+                <a:ea typeface="Garamond" pitchFamily="34" charset="-122"/>
+                <a:cs typeface="Garamond" pitchFamily="34" charset="-120"/>
+              </a:rPr>
+              <a:t>The Anatomy of Teacher Attrition in the United States, 1997–2024</a:t>
+            </a:r>
+            <a:endParaRPr lang="en-US" sz="2200" dirty="0"/>
+          </a:p>
+        </p:txBody>
+      </p:sp>
+      <p:sp>
+        <p:nvSpPr>
+          <p:cNvPr id="4" name="Text 2"/>
+          <p:cNvSpPr/>
+          <p:nvPr/>
+        </p:nvSpPr>
+        <p:spPr>
+          <a:xfrm>
+            <a:off x="731520" y="3977640"/>
+            <a:ext cx="10725912" cy="411480"/>
+          </a:xfrm>
+          <a:prstGeom prst="rect">
+            <a:avLst/>
+          </a:prstGeom>
+          <a:noFill/>
+          <a:ln/>
+        </p:spPr>
+        <p:txBody>
+          <a:bodyPr wrap="square" lIns="0" tIns="0" rIns="0" bIns="0" rtlCol="0" anchor="ctr"/>
+          <a:lstStyle/>
+          <a:p>
+            <a:pPr algn="ctr" indent="0" marL="0">
+              <a:buNone/>
+            </a:pPr>
+            <a:r>
+              <a:rPr lang="en-US" sz="1700" dirty="0">
+                <a:solidFill>
+                  <a:srgbClr val="1A2430"/>
+                </a:solidFill>
+                <a:latin typeface="Garamond" pitchFamily="34" charset="0"/>
+                <a:ea typeface="Garamond" pitchFamily="34" charset="-122"/>
+                <a:cs typeface="Garamond" pitchFamily="34" charset="-120"/>
+              </a:rPr>
+              <a:t>José Elías Durán Roa</a:t>
+            </a:r>
+            <a:endParaRPr lang="en-US" sz="1700" dirty="0"/>
+          </a:p>
+        </p:txBody>
+      </p:sp>
+      <p:sp>
+        <p:nvSpPr>
+          <p:cNvPr id="5" name="Text 3"/>
+          <p:cNvSpPr/>
+          <p:nvPr/>
+        </p:nvSpPr>
+        <p:spPr>
+          <a:xfrm>
+            <a:off x="731520" y="4434840"/>
+            <a:ext cx="10725912" cy="365760"/>
+          </a:xfrm>
+          <a:prstGeom prst="rect">
+            <a:avLst/>
+          </a:prstGeom>
+          <a:noFill/>
+          <a:ln/>
+        </p:spPr>
+        <p:txBody>
+          <a:bodyPr wrap="square" lIns="0" tIns="0" rIns="0" bIns="0" rtlCol="0" anchor="ctr"/>
+          <a:lstStyle/>
+          <a:p>
+            <a:pPr algn="ctr" indent="0" marL="0">
+              <a:buNone/>
+            </a:pPr>
+            <a:r>
+              <a:rPr lang="en-US" sz="1300" dirty="0">
                 <a:solidFill>
                   <a:srgbClr val="5A6572"/>
                 </a:solidFill>
@@ -2039,9 +2182,9 @@
                 <a:ea typeface="Garamond" pitchFamily="34" charset="-122"/>
                 <a:cs typeface="Garamond" pitchFamily="34" charset="-120"/>
               </a:rPr>
-              <a:t>Notes: College-graduate teachers aged 18+ whose longest job last year was K–12 teaching; ASEC supplement weights. Thin gray lines are annual values; blue lines are centered 3-year averages, with endpoint values printed. “Public school,” “part-time,” and “pension plan” refer to the longest job held last year; the open circle marks 2013, a year with a reduced sample due to the ASEC redesign. Source: author’s calculations from March CPS supplements, survey years 2006–2025.</a:t>
-            </a:r>
-            <a:endParaRPr lang="en-US" sz="950" dirty="0"/>
+              <a:t>July 2026</a:t>
+            </a:r>
+            <a:endParaRPr lang="en-US" sz="1300" dirty="0"/>
           </a:p>
         </p:txBody>
       </p:sp>
@@ -2110,7 +2253,7 @@
                 <a:ea typeface="Garamond" pitchFamily="34" charset="-122"/>
                 <a:cs typeface="Garamond" pitchFamily="34" charset="-120"/>
               </a:rPr>
-              <a:t>Figure 10. The Distribution of Earnings Changes: Stayers and Leavers</a:t>
+              <a:t>Figure 9. Leaving and State Unemployment: Two Examples</a:t>
             </a:r>
             <a:endParaRPr lang="en-US" sz="2100" dirty="0"/>
           </a:p>
@@ -2118,7 +2261,7 @@
       </p:sp>
       <p:pic>
         <p:nvPicPr>
-          <p:cNvPr id="3" name="Image 0" descr="figs_png/g5b_earnings_density.png">    </p:cNvPr>
+          <p:cNvPr id="3" name="Image 0" descr="figs_png/n5b_states_trio.png">    </p:cNvPr>
           <p:cNvPicPr>
             <a:picLocks noChangeAspect="1"/>
           </p:cNvPicPr>
@@ -2132,8 +2275,8 @@
         </p:blipFill>
         <p:spPr>
           <a:xfrm>
-            <a:off x="1590062" y="804672"/>
-            <a:ext cx="9008828" cy="4709160"/>
+            <a:off x="899307" y="804672"/>
+            <a:ext cx="10390339" cy="4709160"/>
           </a:xfrm>
           <a:prstGeom prst="rect">
             <a:avLst/>
@@ -2142,7 +2285,7 @@
       </p:pic>
       <p:sp>
         <p:nvSpPr>
-          <p:cNvPr id="4" name="Text 1"/>
+          <p:cNvPr id="5" name="Text 1"/>
           <p:cNvSpPr/>
           <p:nvPr/>
         </p:nvSpPr>
@@ -2173,7 +2316,7 @@
                 <a:ea typeface="Garamond" pitchFamily="34" charset="-122"/>
                 <a:cs typeface="Garamond" pitchFamily="34" charset="-120"/>
               </a:rPr>
-              <a:t>Notes: Kernel densities of the person-level change in annual wage and salary earnings (log points ×100) between the teaching year and the next, for teachers linked across consecutive supplements (rotation-group links, survey years 2011–2025; identity validated on sex and age). Navy: stayers (12,195 links; median +3). Red: leavers employed the following year (225 links; median +15). “Lose big”/“win big” denote changes beyond ±30 log points. The sample conditions on positive earnings in both years; 47 percent of all leavers report zero earnings the following year. Bandwidth 0.25. Source: author’s calculations from March CPS supplements.</a:t>
+              <a:t>Notes: Annual state leaving rates of college-graduate teachers (dots; one per year, 1997–2024) against the state unemployment rate in the survey month (BLS Local Area Unemployment Statistics), with OLS fits. North Carolina and New Jersey are shown as examples of the two signs. State of residence is recovered from the household records of the raw files. Source: author’s calculations from March CPS supplements.</a:t>
             </a:r>
             <a:endParaRPr lang="en-US" sz="950" dirty="0"/>
           </a:p>
@@ -2244,7 +2387,7 @@
                 <a:ea typeface="Garamond" pitchFamily="34" charset="-122"/>
                 <a:cs typeface="Garamond" pitchFamily="34" charset="-120"/>
               </a:rPr>
-              <a:t>Figure 11. Real Median Earnings by Profession, 2004–2014 and 2015–2025</a:t>
+              <a:t>Figure 10. The Distribution of Earnings Changes: Stayers and Leavers</a:t>
             </a:r>
             <a:endParaRPr lang="en-US" sz="2100" dirty="0"/>
           </a:p>
@@ -2252,7 +2395,7 @@
       </p:sp>
       <p:pic>
         <p:nvPicPr>
-          <p:cNvPr id="3" name="Image 0" descr="figs_png/n6b_pay_windows.png">    </p:cNvPr>
+          <p:cNvPr id="3" name="Image 0" descr="figs_png/g5b_earnings_density.png">    </p:cNvPr>
           <p:cNvPicPr>
             <a:picLocks noChangeAspect="1"/>
           </p:cNvPicPr>
@@ -2266,8 +2409,8 @@
         </p:blipFill>
         <p:spPr>
           <a:xfrm>
-            <a:off x="1609562" y="804672"/>
-            <a:ext cx="8969829" cy="4709160"/>
+            <a:off x="1590062" y="804672"/>
+            <a:ext cx="9008828" cy="4709160"/>
           </a:xfrm>
           <a:prstGeom prst="rect">
             <a:avLst/>
@@ -2276,7 +2419,7 @@
       </p:pic>
       <p:sp>
         <p:nvSpPr>
-          <p:cNvPr id="4" name="Text 1"/>
+          <p:cNvPr id="5" name="Text 1"/>
           <p:cNvSpPr/>
           <p:nvPr/>
         </p:nvSpPr>
@@ -2307,7 +2450,7 @@
                 <a:ea typeface="Garamond" pitchFamily="34" charset="-122"/>
                 <a:cs typeface="Garamond" pitchFamily="34" charset="-120"/>
               </a:rPr>
-              <a:t>Notes: Weighted median annual wage and salary earnings of full-time, full-year college graduates aged 25–60, in each profession and overall, deflated to 2024 dollars with the CPI-U; the two windows pool survey years 2004–2014 and 2015–2025. Filled dots (with values): recent window. Source: author’s calculations from March CPS supplements; CPI: BLS via FRED.</a:t>
+              <a:t>Notes: Kernel densities of the person-level change in annual wage and salary earnings (log points ×100) between the teaching year and the next, for teachers linked across consecutive supplements (rotation-group links, survey years 2011–2025; identity validated on sex and age). Navy: stayers (12,195 links; median +3). Red: leavers employed the following year (225 links; median +15). “Lose big”/“win big” denote changes beyond ±30 log points. The sample conditions on positive earnings in both years; 47 percent of all leavers report zero earnings the following year. Bandwidth 0.25. Source: author’s calculations from March CPS supplements.</a:t>
             </a:r>
             <a:endParaRPr lang="en-US" sz="950" dirty="0"/>
           </a:p>
@@ -2378,7 +2521,7 @@
                 <a:ea typeface="Garamond" pitchFamily="34" charset="-122"/>
                 <a:cs typeface="Garamond" pitchFamily="34" charset="-120"/>
               </a:rPr>
-              <a:t>Figure 12. Average Marginal Effects on the Probability of Leaving Teaching</a:t>
+              <a:t>Figure 11. Real Median Earnings by Profession, 2004–2014 and 2015–2025</a:t>
             </a:r>
             <a:endParaRPr lang="en-US" sz="2100" dirty="0"/>
           </a:p>
@@ -2386,7 +2529,7 @@
       </p:sp>
       <p:pic>
         <p:nvPicPr>
-          <p:cNvPr id="3" name="Image 0" descr="figs_png/g6_ame.png">    </p:cNvPr>
+          <p:cNvPr id="3" name="Image 0" descr="figs_png/n6b_pay_windows.png">    </p:cNvPr>
           <p:cNvPicPr>
             <a:picLocks noChangeAspect="1"/>
           </p:cNvPicPr>
@@ -2400,8 +2543,8 @@
         </p:blipFill>
         <p:spPr>
           <a:xfrm>
-            <a:off x="2955036" y="804672"/>
-            <a:ext cx="6278880" cy="4709160"/>
+            <a:off x="1609562" y="804672"/>
+            <a:ext cx="8969829" cy="4709160"/>
           </a:xfrm>
           <a:prstGeom prst="rect">
             <a:avLst/>
@@ -2410,7 +2553,7 @@
       </p:pic>
       <p:sp>
         <p:nvSpPr>
-          <p:cNvPr id="4" name="Text 1"/>
+          <p:cNvPr id="5" name="Text 1"/>
           <p:cNvSpPr/>
           <p:nvPr/>
         </p:nvSpPr>
@@ -2441,7 +2584,7 @@
                 <a:ea typeface="Garamond" pitchFamily="34" charset="-122"/>
                 <a:cs typeface="Garamond" pitchFamily="34" charset="-120"/>
               </a:rPr>
-              <a:t>Notes: Average marginal effects (percentage points) on the probability of leaving teaching, from a probit on college-graduate teachers pooled over calendar 2015–2024 with year effects; whiskers are 95 percent confidence intervals; filled markers are significant at 5 percent. “Worked full year” is 50+ weeks at the last-year job; “part-time” is under 35 weekly hours. n = 28,900. Source: author’s calculations from March CPS supplements.</a:t>
+              <a:t>Notes: Weighted median annual wage and salary earnings of full-time, full-year college graduates aged 25–60, in each profession and overall, deflated to 2024 dollars with the CPI-U; the two windows pool survey years 2004–2014 and 2015–2025. Filled dots (with values): recent window. Source: author’s calculations from March CPS supplements; CPI: BLS via FRED.</a:t>
             </a:r>
             <a:endParaRPr lang="en-US" sz="950" dirty="0"/>
           </a:p>
@@ -2512,6 +2655,140 @@
                 <a:ea typeface="Garamond" pitchFamily="34" charset="-122"/>
                 <a:cs typeface="Garamond" pitchFamily="34" charset="-120"/>
               </a:rPr>
+              <a:t>Figure 12. Average Marginal Effects on the Probability of Leaving Teaching</a:t>
+            </a:r>
+            <a:endParaRPr lang="en-US" sz="2100" dirty="0"/>
+          </a:p>
+        </p:txBody>
+      </p:sp>
+      <p:pic>
+        <p:nvPicPr>
+          <p:cNvPr id="3" name="Image 0" descr="figs_png/g6_ame.png">    </p:cNvPr>
+          <p:cNvPicPr>
+            <a:picLocks noChangeAspect="1"/>
+          </p:cNvPicPr>
+          <p:nvPr/>
+        </p:nvPicPr>
+        <p:blipFill>
+          <a:blip r:embed="rId1"/>
+          <a:stretch>
+            <a:fillRect/>
+          </a:stretch>
+        </p:blipFill>
+        <p:spPr>
+          <a:xfrm>
+            <a:off x="2955036" y="804672"/>
+            <a:ext cx="6278880" cy="4709160"/>
+          </a:xfrm>
+          <a:prstGeom prst="rect">
+            <a:avLst/>
+          </a:prstGeom>
+        </p:spPr>
+      </p:pic>
+      <p:sp>
+        <p:nvSpPr>
+          <p:cNvPr id="5" name="Text 1"/>
+          <p:cNvSpPr/>
+          <p:nvPr/>
+        </p:nvSpPr>
+        <p:spPr>
+          <a:xfrm>
+            <a:off x="457200" y="5650992"/>
+            <a:ext cx="11274552" cy="1097280"/>
+          </a:xfrm>
+          <a:prstGeom prst="rect">
+            <a:avLst/>
+          </a:prstGeom>
+          <a:noFill/>
+          <a:ln/>
+        </p:spPr>
+        <p:txBody>
+          <a:bodyPr wrap="square" lIns="0" tIns="0" rIns="0" bIns="0" rtlCol="0" anchor="t"/>
+          <a:lstStyle/>
+          <a:p>
+            <a:pPr algn="just" indent="0" marL="0">
+              <a:buNone/>
+            </a:pPr>
+            <a:r>
+              <a:rPr lang="en-US" sz="950" dirty="0">
+                <a:solidFill>
+                  <a:srgbClr val="5A6572"/>
+                </a:solidFill>
+                <a:latin typeface="Garamond" pitchFamily="34" charset="0"/>
+                <a:ea typeface="Garamond" pitchFamily="34" charset="-122"/>
+                <a:cs typeface="Garamond" pitchFamily="34" charset="-120"/>
+              </a:rPr>
+              <a:t>Notes: Average marginal effects (percentage points) on the probability of leaving teaching, from a probit on college-graduate teachers pooled over calendar 2015–2024 with year effects; whiskers are 95 percent confidence intervals; filled markers are significant at 5 percent. “Worked full year” is 50+ weeks at the last-year job; “part-time” is under 35 weekly hours. n = 28,900. Source: author’s calculations from March CPS supplements.</a:t>
+            </a:r>
+            <a:endParaRPr lang="en-US" sz="950" dirty="0"/>
+          </a:p>
+        </p:txBody>
+      </p:sp>
+    </p:spTree>
+  </p:cSld>
+  <p:clrMapOvr>
+    <a:masterClrMapping/>
+  </p:clrMapOvr>
+</p:sld>
+</file>
+
+<file path=ppt/slides/slide14.xml><?xml version="1.0" encoding="utf-8"?>
+<p:sld xmlns:a="http://schemas.openxmlformats.org/drawingml/2006/main" xmlns:r="http://schemas.openxmlformats.org/officeDocument/2006/relationships" xmlns:p="http://schemas.openxmlformats.org/presentationml/2006/main">
+  <p:cSld name="Slide 14">
+    <p:bg>
+      <p:bgPr>
+        <a:solidFill>
+          <a:srgbClr val="FFFFFF"/>
+        </a:solidFill>
+      </p:bgPr>
+    </p:bg>
+    <p:spTree>
+      <p:nvGrpSpPr>
+        <p:cNvPr id="1" name=""/>
+        <p:cNvGrpSpPr/>
+        <p:nvPr/>
+      </p:nvGrpSpPr>
+      <p:grpSpPr>
+        <a:xfrm>
+          <a:off x="0" y="0"/>
+          <a:ext cx="0" cy="0"/>
+          <a:chOff x="0" y="0"/>
+          <a:chExt cx="0" cy="0"/>
+        </a:xfrm>
+      </p:grpSpPr>
+      <p:sp>
+        <p:nvSpPr>
+          <p:cNvPr id="2" name="Text 0"/>
+          <p:cNvSpPr/>
+          <p:nvPr/>
+        </p:nvSpPr>
+        <p:spPr>
+          <a:xfrm>
+            <a:off x="457200" y="201168"/>
+            <a:ext cx="11274552" cy="502920"/>
+          </a:xfrm>
+          <a:prstGeom prst="rect">
+            <a:avLst/>
+          </a:prstGeom>
+          <a:noFill/>
+          <a:ln/>
+        </p:spPr>
+        <p:txBody>
+          <a:bodyPr wrap="square" lIns="0" tIns="0" rIns="0" bIns="0" rtlCol="0" anchor="ctr"/>
+          <a:lstStyle/>
+          <a:p>
+            <a:pPr algn="ctr" indent="0" marL="0">
+              <a:buNone/>
+            </a:pPr>
+            <a:r>
+              <a:rPr lang="en-US" sz="2100" dirty="0">
+                <a:solidFill>
+                  <a:srgbClr val="1A2430"/>
+                </a:solidFill>
+                <a:latin typeface="Garamond" pitchFamily="34" charset="0"/>
+                <a:ea typeface="Garamond" pitchFamily="34" charset="-122"/>
+                <a:cs typeface="Garamond" pitchFamily="34" charset="-120"/>
+              </a:rPr>
               <a:t>Figure 13. Rates of Leaving by Profession, 2004–2014 and 2015–2025</a:t>
             </a:r>
             <a:endParaRPr lang="en-US" sz="2100" dirty="0"/>
@@ -2544,7 +2821,7 @@
       </p:pic>
       <p:sp>
         <p:nvSpPr>
-          <p:cNvPr id="4" name="Text 1"/>
+          <p:cNvPr id="5" name="Text 1"/>
           <p:cNvSpPr/>
           <p:nvPr/>
         </p:nvSpPr>
@@ -2646,7 +2923,7 @@
                 <a:ea typeface="Garamond" pitchFamily="34" charset="-122"/>
                 <a:cs typeface="Garamond" pitchFamily="34" charset="-120"/>
               </a:rPr>
-              <a:t>Figure 2. Leaving Teaching, 1997–2024</a:t>
+              <a:t>Figure 1. Composition of the Teaching Workforce, 2005–2024</a:t>
             </a:r>
             <a:endParaRPr lang="en-US" sz="2100" dirty="0"/>
           </a:p>
@@ -2654,7 +2931,7 @@
       </p:sp>
       <p:pic>
         <p:nvPicPr>
-          <p:cNvPr id="3" name="Image 0" descr="figs_png/g2_evolution.png">    </p:cNvPr>
+          <p:cNvPr id="3" name="Image 0" descr="figs_png/g1_workforce.png">    </p:cNvPr>
           <p:cNvPicPr>
             <a:picLocks noChangeAspect="1"/>
           </p:cNvPicPr>
@@ -2668,8 +2945,8 @@
         </p:blipFill>
         <p:spPr>
           <a:xfrm>
-            <a:off x="1385316" y="804672"/>
-            <a:ext cx="9418320" cy="4709160"/>
+            <a:off x="1133040" y="804672"/>
+            <a:ext cx="9922873" cy="4709160"/>
           </a:xfrm>
           <a:prstGeom prst="rect">
             <a:avLst/>
@@ -2678,7 +2955,7 @@
       </p:pic>
       <p:sp>
         <p:nvSpPr>
-          <p:cNvPr id="4" name="Text 1"/>
+          <p:cNvPr id="5" name="Text 1"/>
           <p:cNvSpPr/>
           <p:nvPr/>
         </p:nvSpPr>
@@ -2709,7 +2986,7 @@
                 <a:ea typeface="Garamond" pitchFamily="34" charset="-122"/>
                 <a:cs typeface="Garamond" pitchFamily="34" charset="-120"/>
               </a:rPr>
-              <a:t>Notes: Share of college-graduate teachers (longest job last calendar year) not employed in a teaching occupation the following March; ASEC weights. Shaded band: 95 percent confidence interval using a design factor of 1.5. Dotted line: the 1997–2024 mean (8.6). The gray band marks the Covid supplements. Source: author’s calculations from March CPS supplements, survey years 1998–2025.</a:t>
+              <a:t>Notes: College-graduate teachers aged 18+ whose longest job last year was K–12 teaching; ASEC supplement weights. Thin gray lines are annual values; blue lines are centered 3-year averages, with endpoint values printed. “Public school,” “part-time,” and “pension plan” refer to the longest job held last year; the open circle marks 2013, a year with a reduced sample due to the ASEC redesign. Source: author’s calculations from March CPS supplements, survey years 2006–2025.</a:t>
             </a:r>
             <a:endParaRPr lang="en-US" sz="950" dirty="0"/>
           </a:p>
@@ -2780,7 +3057,7 @@
                 <a:ea typeface="Garamond" pitchFamily="34" charset="-122"/>
                 <a:cs typeface="Garamond" pitchFamily="34" charset="-120"/>
               </a:rPr>
-              <a:t>Figure 3. Destinations of Teachers Who Leave the Profession</a:t>
+              <a:t>Figure 2. Leaving Teaching, 1997–2024</a:t>
             </a:r>
             <a:endParaRPr lang="en-US" sz="2100" dirty="0"/>
           </a:p>
@@ -2788,7 +3065,7 @@
       </p:sp>
       <p:pic>
         <p:nvPicPr>
-          <p:cNvPr id="3" name="Image 0" descr="figs_png/g3_flow100.png">    </p:cNvPr>
+          <p:cNvPr id="3" name="Image 0" descr="figs_png/g2_evolution.png">    </p:cNvPr>
           <p:cNvPicPr>
             <a:picLocks noChangeAspect="1"/>
           </p:cNvPicPr>
@@ -2802,8 +3079,8 @@
         </p:blipFill>
         <p:spPr>
           <a:xfrm>
-            <a:off x="1180570" y="804672"/>
-            <a:ext cx="9827812" cy="4709160"/>
+            <a:off x="1385316" y="804672"/>
+            <a:ext cx="9418320" cy="4709160"/>
           </a:xfrm>
           <a:prstGeom prst="rect">
             <a:avLst/>
@@ -2812,7 +3089,7 @@
       </p:pic>
       <p:sp>
         <p:nvSpPr>
-          <p:cNvPr id="4" name="Text 1"/>
+          <p:cNvPr id="5" name="Text 1"/>
           <p:cNvSpPr/>
           <p:nvPr/>
         </p:nvSpPr>
@@ -2843,7 +3120,7 @@
                 <a:ea typeface="Garamond" pitchFamily="34" charset="-122"/>
                 <a:cs typeface="Garamond" pitchFamily="34" charset="-120"/>
               </a:rPr>
-              <a:t>Notes: College-graduate leavers pooled over calendar 2015–2024, ASEC weights. Top bar: labor force status the March after the teaching year; “out of the labor force” is split at age 55. Bottom bar: the occupational destination of the 26 employed leavers, rescaled to sum to their total. Source: author’s calculations from March CPS supplements.</a:t>
+              <a:t>Notes: Share of college-graduate teachers (longest job last calendar year) not employed in a teaching occupation the following March; ASEC weights. Shaded band: 95 percent confidence interval using a design factor of 1.5. Dotted line: the 1997–2024 mean (8.6). The gray band marks the Covid supplements. Source: author’s calculations from March CPS supplements, survey years 1998–2025.</a:t>
             </a:r>
             <a:endParaRPr lang="en-US" sz="950" dirty="0"/>
           </a:p>
@@ -2914,7 +3191,7 @@
                 <a:ea typeface="Garamond" pitchFamily="34" charset="-122"/>
                 <a:cs typeface="Garamond" pitchFamily="34" charset="-120"/>
               </a:rPr>
-              <a:t>Figure 4. Leaving Teaching by Age and Route</a:t>
+              <a:t>Figure 3. Destinations of Teachers Who Leave the Profession</a:t>
             </a:r>
             <a:endParaRPr lang="en-US" sz="2100" dirty="0"/>
           </a:p>
@@ -2922,7 +3199,7 @@
       </p:sp>
       <p:pic>
         <p:nvPicPr>
-          <p:cNvPr id="3" name="Image 0" descr="figs_png/g4_routes_age.png">    </p:cNvPr>
+          <p:cNvPr id="3" name="Image 0" descr="figs_png/g3_flow100.png">    </p:cNvPr>
           <p:cNvPicPr>
             <a:picLocks noChangeAspect="1"/>
           </p:cNvPicPr>
@@ -2936,8 +3213,8 @@
         </p:blipFill>
         <p:spPr>
           <a:xfrm>
-            <a:off x="1497439" y="804672"/>
-            <a:ext cx="9194074" cy="4709160"/>
+            <a:off x="1180570" y="804672"/>
+            <a:ext cx="9827812" cy="4709160"/>
           </a:xfrm>
           <a:prstGeom prst="rect">
             <a:avLst/>
@@ -2946,7 +3223,7 @@
       </p:pic>
       <p:sp>
         <p:nvSpPr>
-          <p:cNvPr id="4" name="Text 1"/>
+          <p:cNvPr id="5" name="Text 1"/>
           <p:cNvSpPr/>
           <p:nvPr/>
         </p:nvSpPr>
@@ -2977,7 +3254,7 @@
                 <a:ea typeface="Garamond" pitchFamily="34" charset="-122"/>
                 <a:cs typeface="Garamond" pitchFamily="34" charset="-120"/>
               </a:rPr>
-              <a:t>Notes: College-graduate teachers pooled over calendar 2015–2024, ASEC weights; ten age groups. The black line is the total leaving rate; stacked areas decompose it into exits to another job, unemployment, and out of the labor force. Source: author’s calculations from March CPS supplements.</a:t>
+              <a:t>Notes: College-graduate leavers pooled over calendar 2015–2024, ASEC weights. Top bar: labor force status the March after the teaching year; “out of the labor force” is split at age 55. Bottom bar: the occupational destination of the 26 employed leavers, rescaled to sum to their total. Source: author’s calculations from March CPS supplements.</a:t>
             </a:r>
             <a:endParaRPr lang="en-US" sz="950" dirty="0"/>
           </a:p>
@@ -3048,7 +3325,7 @@
                 <a:ea typeface="Garamond" pitchFamily="34" charset="-122"/>
                 <a:cs typeface="Garamond" pitchFamily="34" charset="-120"/>
               </a:rPr>
-              <a:t>Figure 5. Exit Routes by School Sector</a:t>
+              <a:t>Figure 4. Leaving Teaching by Age and Route</a:t>
             </a:r>
             <a:endParaRPr lang="en-US" sz="2100" dirty="0"/>
           </a:p>
@@ -3056,7 +3333,7 @@
       </p:sp>
       <p:pic>
         <p:nvPicPr>
-          <p:cNvPr id="3" name="Image 0" descr="figs_png/g10_sector_routes.png">    </p:cNvPr>
+          <p:cNvPr id="3" name="Image 0" descr="figs_png/g4_routes_age.png">    </p:cNvPr>
           <p:cNvPicPr>
             <a:picLocks noChangeAspect="1"/>
           </p:cNvPicPr>
@@ -3070,8 +3347,8 @@
         </p:blipFill>
         <p:spPr>
           <a:xfrm>
-            <a:off x="2109802" y="804672"/>
-            <a:ext cx="7969348" cy="4709160"/>
+            <a:off x="1497439" y="804672"/>
+            <a:ext cx="9194074" cy="4709160"/>
           </a:xfrm>
           <a:prstGeom prst="rect">
             <a:avLst/>
@@ -3080,7 +3357,7 @@
       </p:pic>
       <p:sp>
         <p:nvSpPr>
-          <p:cNvPr id="4" name="Text 1"/>
+          <p:cNvPr id="5" name="Text 1"/>
           <p:cNvSpPr/>
           <p:nvPr/>
         </p:nvSpPr>
@@ -3111,7 +3388,7 @@
                 <a:ea typeface="Garamond" pitchFamily="34" charset="-122"/>
                 <a:cs typeface="Garamond" pitchFamily="34" charset="-120"/>
               </a:rPr>
-              <a:t>Notes: Route-specific annual exit rates of college-graduate teachers by sector of the last-year job (class of worker: government vs. private), pooled 2015–2024, ASEC weights. A private-school teacher who moves to a public school—or vice versa—remains a teacher and is not a leaver here. Source: author’s calculations from March CPS supplements.</a:t>
+              <a:t>Notes: College-graduate teachers pooled over calendar 2015–2024, ASEC weights; ten age groups. The black line is the total leaving rate; stacked areas decompose it into exits to another job, unemployment, and out of the labor force. Source: author’s calculations from March CPS supplements.</a:t>
             </a:r>
             <a:endParaRPr lang="en-US" sz="950" dirty="0"/>
           </a:p>
@@ -3182,7 +3459,7 @@
                 <a:ea typeface="Garamond" pitchFamily="34" charset="-122"/>
                 <a:cs typeface="Garamond" pitchFamily="34" charset="-120"/>
               </a:rPr>
-              <a:t>Figure 6. The Effect of a New Baby on Leaving, by Profession</a:t>
+              <a:t>Figure 5. Exit Routes by School Sector</a:t>
             </a:r>
             <a:endParaRPr lang="en-US" sz="2100" dirty="0"/>
           </a:p>
@@ -3190,7 +3467,7 @@
       </p:sp>
       <p:pic>
         <p:nvPicPr>
-          <p:cNvPr id="3" name="Image 0" descr="figs_png/g8_newbaby.png">    </p:cNvPr>
+          <p:cNvPr id="3" name="Image 0" descr="figs_png/g10_sector_routes.png">    </p:cNvPr>
           <p:cNvPicPr>
             <a:picLocks noChangeAspect="1"/>
           </p:cNvPicPr>
@@ -3204,8 +3481,8 @@
         </p:blipFill>
         <p:spPr>
           <a:xfrm>
-            <a:off x="2024799" y="804672"/>
-            <a:ext cx="8139355" cy="4709160"/>
+            <a:off x="2109802" y="804672"/>
+            <a:ext cx="7969348" cy="4709160"/>
           </a:xfrm>
           <a:prstGeom prst="rect">
             <a:avLst/>
@@ -3214,7 +3491,7 @@
       </p:pic>
       <p:sp>
         <p:nvSpPr>
-          <p:cNvPr id="4" name="Text 1"/>
+          <p:cNvPr id="5" name="Text 1"/>
           <p:cNvSpPr/>
           <p:nvPr/>
         </p:nvSpPr>
@@ -3245,7 +3522,7 @@
                 <a:ea typeface="Garamond" pitchFamily="34" charset="-122"/>
                 <a:cs typeface="Garamond" pitchFamily="34" charset="-120"/>
               </a:rPr>
-              <a:t>Notes: Average marginal effect of a new baby (own child aged 0 in the household) on the probability that a woman leaves each profession, from profession-specific probits with age, age squared, marital status, education, and year effects; whiskers are 95 percent confidence intervals. Solid bars are significant at 5 percent; light bars are not. Samples pool 2010–2024. Source: author’s calculations from March CPS supplements.</a:t>
+              <a:t>Notes: Route-specific annual exit rates of college-graduate teachers by sector of the last-year job (class of worker: government vs. private), pooled 2015–2024, ASEC weights. A private-school teacher who moves to a public school—or vice versa—remains a teacher and is not a leaver here. Source: author’s calculations from March CPS supplements.</a:t>
             </a:r>
             <a:endParaRPr lang="en-US" sz="950" dirty="0"/>
           </a:p>
@@ -3316,7 +3593,7 @@
                 <a:ea typeface="Garamond" pitchFamily="34" charset="-122"/>
                 <a:cs typeface="Garamond" pitchFamily="34" charset="-120"/>
               </a:rPr>
-              <a:t>Figure 7. Labor Force Exit of Women Teachers, With and Without Young Children</a:t>
+              <a:t>Figure 6. The Effect of a New Baby on Leaving, by Profession</a:t>
             </a:r>
             <a:endParaRPr lang="en-US" sz="2100" dirty="0"/>
           </a:p>
@@ -3324,7 +3601,7 @@
       </p:sp>
       <p:pic>
         <p:nvPicPr>
-          <p:cNvPr id="3" name="Image 0" descr="figs_png/g9_mothers.png">    </p:cNvPr>
+          <p:cNvPr id="3" name="Image 0" descr="figs_png/g8_newbaby.png">    </p:cNvPr>
           <p:cNvPicPr>
             <a:picLocks noChangeAspect="1"/>
           </p:cNvPicPr>
@@ -3338,8 +3615,8 @@
         </p:blipFill>
         <p:spPr>
           <a:xfrm>
-            <a:off x="1385316" y="804672"/>
-            <a:ext cx="9418320" cy="4709160"/>
+            <a:off x="2024799" y="804672"/>
+            <a:ext cx="8139355" cy="4709160"/>
           </a:xfrm>
           <a:prstGeom prst="rect">
             <a:avLst/>
@@ -3348,7 +3625,7 @@
       </p:pic>
       <p:sp>
         <p:nvSpPr>
-          <p:cNvPr id="4" name="Text 1"/>
+          <p:cNvPr id="5" name="Text 1"/>
           <p:cNvSpPr/>
           <p:nvPr/>
         </p:nvSpPr>
@@ -3379,7 +3656,7 @@
                 <a:ea typeface="Garamond" pitchFamily="34" charset="-122"/>
                 <a:cs typeface="Garamond" pitchFamily="34" charset="-120"/>
               </a:rPr>
-              <a:t>Notes: Women teachers aged 22–45, college graduates; annual probability of leaving the labor force (thin lines) and centered 3-year averages (bold), separately for those with and without an own child under 6 at home. Endpoint values printed. Source: author’s calculations from March CPS supplements, survey years 1998–2025.</a:t>
+              <a:t>Notes: Average marginal effect of a new baby (own child aged 0 in the household) on the probability that a woman leaves each profession, from profession-specific probits with age, age squared, marital status, education, and year effects; whiskers are 95 percent confidence intervals. Solid bars are significant at 5 percent; light bars are not. Samples pool 2010–2024. Source: author’s calculations from March CPS supplements.</a:t>
             </a:r>
             <a:endParaRPr lang="en-US" sz="950" dirty="0"/>
           </a:p>
@@ -3450,7 +3727,7 @@
                 <a:ea typeface="Garamond" pitchFamily="34" charset="-122"/>
                 <a:cs typeface="Garamond" pitchFamily="34" charset="-120"/>
               </a:rPr>
-              <a:t>Figure 8. Leaving Teaching and the Unemployment Rate, 1997–2024</a:t>
+              <a:t>Figure 7. Labor Force Exit of Women Teachers, With and Without Young Children</a:t>
             </a:r>
             <a:endParaRPr lang="en-US" sz="2100" dirty="0"/>
           </a:p>
@@ -3458,7 +3735,7 @@
       </p:sp>
       <p:pic>
         <p:nvPicPr>
-          <p:cNvPr id="3" name="Image 0" descr="figs_png/n5_cyclicality.png">    </p:cNvPr>
+          <p:cNvPr id="3" name="Image 0" descr="figs_png/g9_mothers.png">    </p:cNvPr>
           <p:cNvPicPr>
             <a:picLocks noChangeAspect="1"/>
           </p:cNvPicPr>
@@ -3472,8 +3749,8 @@
         </p:blipFill>
         <p:spPr>
           <a:xfrm>
-            <a:off x="470916" y="1072233"/>
-            <a:ext cx="11247120" cy="4174039"/>
+            <a:off x="1385316" y="804672"/>
+            <a:ext cx="9418320" cy="4709160"/>
           </a:xfrm>
           <a:prstGeom prst="rect">
             <a:avLst/>
@@ -3482,7 +3759,7 @@
       </p:pic>
       <p:sp>
         <p:nvSpPr>
-          <p:cNvPr id="4" name="Text 1"/>
+          <p:cNvPr id="5" name="Text 1"/>
           <p:cNvSpPr/>
           <p:nvPr/>
         </p:nvSpPr>
@@ -3513,7 +3790,7 @@
                 <a:ea typeface="Garamond" pitchFamily="34" charset="-122"/>
                 <a:cs typeface="Garamond" pitchFamily="34" charset="-120"/>
               </a:rPr>
-              <a:t>Notes: Left: the leaving series (annual, from calendar 2000) against the BLS national unemployment rate (annual average). Right: binned scatter (deciles of the unemployment rate in the survey month, March of t+1, when the exit is observed) of the two labor-market routes, with OLS fits on the underlying annual data; correlations are −0.16 (to another job) and +0.29 (out of the labor force). Unemployment: BLS via FRED (UNRATE). Source: author’s calculations from March CPS supplements.</a:t>
+              <a:t>Notes: Women teachers aged 22–45, college graduates; annual probability of leaving the labor force (thin lines) and centered 3-year averages (bold), separately for those with and without an own child under 6 at home. Endpoint values printed. Source: author’s calculations from March CPS supplements, survey years 1998–2025.</a:t>
             </a:r>
             <a:endParaRPr lang="en-US" sz="950" dirty="0"/>
           </a:p>
@@ -3584,7 +3861,7 @@
                 <a:ea typeface="Garamond" pitchFamily="34" charset="-122"/>
                 <a:cs typeface="Garamond" pitchFamily="34" charset="-120"/>
               </a:rPr>
-              <a:t>Figure 9. Leaving and State Unemployment: Two Examples</a:t>
+              <a:t>Figure 8. Leaving Teaching and the Unemployment Rate, 1997–2024</a:t>
             </a:r>
             <a:endParaRPr lang="en-US" sz="2100" dirty="0"/>
           </a:p>
@@ -3592,7 +3869,7 @@
       </p:sp>
       <p:pic>
         <p:nvPicPr>
-          <p:cNvPr id="3" name="Image 0" descr="figs_png/n5b_states_trio.png">    </p:cNvPr>
+          <p:cNvPr id="3" name="Image 0" descr="figs_png/n5_cyclicality.png">    </p:cNvPr>
           <p:cNvPicPr>
             <a:picLocks noChangeAspect="1"/>
           </p:cNvPicPr>
@@ -3606,8 +3883,8 @@
         </p:blipFill>
         <p:spPr>
           <a:xfrm>
-            <a:off x="899307" y="804672"/>
-            <a:ext cx="10390339" cy="4709160"/>
+            <a:off x="470916" y="1072233"/>
+            <a:ext cx="11247120" cy="4174039"/>
           </a:xfrm>
           <a:prstGeom prst="rect">
             <a:avLst/>
@@ -3616,7 +3893,7 @@
       </p:pic>
       <p:sp>
         <p:nvSpPr>
-          <p:cNvPr id="4" name="Text 1"/>
+          <p:cNvPr id="5" name="Text 1"/>
           <p:cNvSpPr/>
           <p:nvPr/>
         </p:nvSpPr>
@@ -3647,7 +3924,7 @@
                 <a:ea typeface="Garamond" pitchFamily="34" charset="-122"/>
                 <a:cs typeface="Garamond" pitchFamily="34" charset="-120"/>
               </a:rPr>
-              <a:t>Notes: Annual state leaving rates of college-graduate teachers (dots; one per year, 1997–2024) against the state unemployment rate in the survey month (BLS Local Area Unemployment Statistics), with OLS fits. North Carolina and New Jersey are shown as examples of the two signs. State of residence is recovered from the household records of the raw files. Source: author’s calculations from March CPS supplements.</a:t>
+              <a:t>Notes: Left: the leaving series (annual, from calendar 2000) against the BLS national unemployment rate (annual average). Right: binned scatter (deciles of the unemployment rate in the survey month, March of t+1, when the exit is observed) of the two labor-market routes, with OLS fits on the underlying annual data; correlations are −0.16 (to another job) and +0.29 (out of the labor force). Unemployment: BLS via FRED (UNRATE). Source: author’s calculations from March CPS supplements.</a:t>
             </a:r>
             <a:endParaRPr lang="en-US" sz="950" dirty="0"/>
           </a:p>

</xml_diff>

<commit_message>
Slide deck: add data and context slide after the cover
Co-Authored-By: Claude Fable 5 <noreply@anthropic.com>
Claude-Session: https://claude.ai/code/session_01DNzQPDcr3zfLTraMHUHqUn
</commit_message>
<xml_diff>
--- a/report/teacher_attrition_figures.pptx
+++ b/report/teacher_attrition_figures.pptx
@@ -19,9 +19,10 @@
     <p:sldId id="267" r:id="rId13"/>
     <p:sldId id="268" r:id="rId14"/>
     <p:sldId id="269" r:id="rId15"/>
+    <p:sldId id="270" r:id="rId16"/>
   </p:sldIdLst>
   <p:notesMasterIdLst>
-    <p:notesMasterId r:id="rId16"/>
+    <p:notesMasterId r:id="rId17"/>
   </p:notesMasterIdLst>
   <p:sldSz cx="12192000" cy="6858000"/>
   <p:notesSz cx="6858000" cy="12192000"/>
@@ -603,7 +604,7 @@
           <a:p>
             <a:r>
               <a:rPr lang="en-US" dirty="0"/>
-              <a:t>Fifty-one regressions, four significant slopes, all on the recession side. Not one state shows teachers leaving when the economy heats up.</a:t>
+              <a:t>Booms do not poach teachers. Where exits respond to the cycle at all, recessions push them out. The poaching story has no support in the data.</a:t>
             </a:r>
             <a:endParaRPr lang="en-US" dirty="0"/>
           </a:p>
@@ -691,7 +692,7 @@
           <a:p>
             <a:r>
               <a:rPr lang="en-US" dirty="0"/>
-              <a:t>Switching pays a median of 15 log points, with enormous tails. A quarter lose big, and 47 percent of all leavers earn nothing at all. Leaving is a gamble, and teachers act accordingly.</a:t>
+              <a:t>Fifty-one regressions, four significant slopes, all on the recession side. Not one state shows teachers leaving when the economy heats up.</a:t>
             </a:r>
             <a:endParaRPr lang="en-US" dirty="0"/>
           </a:p>
@@ -779,7 +780,7 @@
           <a:p>
             <a:r>
               <a:rPr lang="en-US" dirty="0"/>
-              <a:t>Teacher pay is flat at 66,000 dollars while every comparison profession moved up. The penalty grew from 20 to 28 percent of the college median.</a:t>
+              <a:t>Switching pays a median of 15 log points, with enormous tails. A quarter lose big, and 47 percent of all leavers earn nothing at all. Leaving is a gamble, and teachers act accordingly.</a:t>
             </a:r>
             <a:endParaRPr lang="en-US" dirty="0"/>
           </a:p>
@@ -867,7 +868,7 @@
           <a:p>
             <a:r>
               <a:rPr lang="en-US" dirty="0"/>
-              <a:t>The contract predicts exit, the person barely does. Full-year work, hours and pension coverage dwarf every demographic. The one personal event that matters is a birth.</a:t>
+              <a:t>Teacher pay is flat at 66,000 dollars while every comparison profession moved up. The penalty grew from 20 to 28 percent of the college median.</a:t>
             </a:r>
             <a:endParaRPr lang="en-US" dirty="0"/>
           </a:p>
@@ -955,7 +956,7 @@
           <a:p>
             <a:r>
               <a:rPr lang="en-US" dirty="0"/>
-              <a:t>Teaching is the only profession here whose attrition fell across decades. Whatever is pushing pharmacists and therapists up is economy-wide, not a crisis of schools.</a:t>
+              <a:t>The contract predicts exit, the person barely does. Full-year work, hours and pension coverage dwarf every demographic. The one personal event that matters is a birth.</a:t>
             </a:r>
             <a:endParaRPr lang="en-US" dirty="0"/>
           </a:p>
@@ -979,6 +980,94 @@
             <a:fld id="{F7021451-1387-4CA6-816F-3879F97B5CBC}" type="slidenum">
               <a:rPr lang="en-US"/>
               <a:t>14</a:t>
+            </a:fld>
+            <a:endParaRPr lang="en-US"/>
+          </a:p>
+        </p:txBody>
+      </p:sp>
+    </p:spTree>
+    <p:extLst>
+      <p:ext uri="{BB962C8B-B14F-4D97-AF65-F5344CB8AC3E}">
+        <p14:creationId xmlns:p14="http://schemas.microsoft.com/office/powerpoint/2010/main" val="1024086991"/>
+      </p:ext>
+    </p:extLst>
+  </p:cSld>
+  <p:clrMapOvr>
+    <a:masterClrMapping/>
+  </p:clrMapOvr>
+</p:notes>
+</file>
+
+<file path=ppt/notesSlides/notesSlide15.xml><?xml version="1.0" encoding="utf-8"?>
+<p:notes xmlns:a="http://schemas.openxmlformats.org/drawingml/2006/main" xmlns:r="http://schemas.openxmlformats.org/officeDocument/2006/relationships" xmlns:p="http://schemas.openxmlformats.org/presentationml/2006/main">
+  <p:cSld>
+    <p:spTree>
+      <p:nvGrpSpPr>
+        <p:cNvPr id="1" name=""/>
+        <p:cNvGrpSpPr/>
+        <p:nvPr/>
+      </p:nvGrpSpPr>
+      <p:grpSpPr>
+        <a:xfrm>
+          <a:off x="0" y="0"/>
+          <a:ext cx="0" cy="0"/>
+          <a:chOff x="0" y="0"/>
+          <a:chExt cx="0" cy="0"/>
+        </a:xfrm>
+      </p:grpSpPr>
+      <p:sp>
+        <p:nvSpPr>
+          <p:cNvPr id="2" name="Slide Image Placeholder 1"/>
+          <p:cNvSpPr>
+            <a:spLocks noGrp="1" noRot="1" noChangeAspect="1"/>
+          </p:cNvSpPr>
+          <p:nvPr>
+            <p:ph type="sldImg"/>
+          </p:nvPr>
+        </p:nvSpPr>
+        <p:spPr/>
+      </p:sp>
+      <p:sp>
+        <p:nvSpPr>
+          <p:cNvPr id="3" name="Notes Placeholder 2"/>
+          <p:cNvSpPr>
+            <a:spLocks noGrp="1"/>
+          </p:cNvSpPr>
+          <p:nvPr>
+            <p:ph type="body" idx="1"/>
+          </p:nvPr>
+        </p:nvSpPr>
+        <p:spPr/>
+        <p:txBody>
+          <a:bodyPr/>
+          <a:lstStyle/>
+          <a:p>
+            <a:r>
+              <a:rPr lang="en-US" dirty="0"/>
+              <a:t>Teaching is the only profession here whose attrition fell across decades. Whatever is pushing pharmacists and therapists up is economy-wide, not a crisis of schools.</a:t>
+            </a:r>
+            <a:endParaRPr lang="en-US" dirty="0"/>
+          </a:p>
+        </p:txBody>
+      </p:sp>
+      <p:sp>
+        <p:nvSpPr>
+          <p:cNvPr id="4" name="Slide Number Placeholder 3"/>
+          <p:cNvSpPr>
+            <a:spLocks noGrp="1"/>
+          </p:cNvSpPr>
+          <p:nvPr>
+            <p:ph type="sldNum" sz="quarter" idx="10"/>
+          </p:nvPr>
+        </p:nvSpPr>
+        <p:spPr/>
+        <p:txBody>
+          <a:bodyPr/>
+          <a:lstStyle/>
+          <a:p>
+            <a:fld id="{F7021451-1387-4CA6-816F-3879F97B5CBC}" type="slidenum">
+              <a:rPr lang="en-US"/>
+              <a:t>15</a:t>
             </a:fld>
             <a:endParaRPr lang="en-US"/>
           </a:p>
@@ -1043,7 +1132,7 @@
           <a:p>
             <a:r>
               <a:rPr lang="en-US" dirty="0"/>
-              <a:t>The workforce is aging and its pension coverage has fallen from 80 to 66 percent. The contract is deteriorating on exactly the margin that predicts exit.</a:t>
+              <a:t>The instrument sees professions, not schools. One question asked the same way for twenty-eight years beats any patchwork of administrative sources. Calendar 2025 enters the series the day the Census releases the 2026 supplement in the fall.</a:t>
             </a:r>
             <a:endParaRPr lang="en-US" dirty="0"/>
           </a:p>
@@ -1131,7 +1220,7 @@
           <a:p>
             <a:r>
               <a:rPr lang="en-US" dirty="0"/>
-              <a:t>Twenty-eight years, no trend. The two worst years are 2001 and 2019, a generation apart. Any exodus narrative starts from a fact this series does not contain.</a:t>
+              <a:t>The workforce is aging and its pension coverage has fallen from 80 to 66 percent. The contract is deteriorating on exactly the margin that predicts exit.</a:t>
             </a:r>
             <a:endParaRPr lang="en-US" dirty="0"/>
           </a:p>
@@ -1219,7 +1308,7 @@
           <a:p>
             <a:r>
               <a:rPr lang="en-US" dirty="0"/>
-              <a:t>Of every 100 leavers, only 26 hold another job the next March. The exodus scenario, a working-age teacher productively employed elsewhere, is barely one leaver in six.</a:t>
+              <a:t>Twenty-eight years, no trend. The two worst years are 2001 and 2019, a generation apart. Any exodus narrative starts from a fact this series does not contain.</a:t>
             </a:r>
             <a:endParaRPr lang="en-US" dirty="0"/>
           </a:p>
@@ -1307,7 +1396,7 @@
           <a:p>
             <a:r>
               <a:rPr lang="en-US" dirty="0"/>
-              <a:t>The age profile is a U. The left arm is career search, the right arm is retirement. Mid-career teachers, the ones schools most need to keep, are the least mobile workers in the figure.</a:t>
+              <a:t>Of every 100 leavers, only 26 hold another job the next March. The exodus scenario, a working-age teacher productively employed elsewhere, is barely one leaver in six.</a:t>
             </a:r>
             <a:endParaRPr lang="en-US" dirty="0"/>
           </a:p>
@@ -1395,7 +1484,7 @@
           <a:p>
             <a:r>
               <a:rPr lang="en-US" dirty="0"/>
-              <a:t>Private schools lose teachers at twice the public rate, through every route. Tenure, salary schedules and pensions are retention policy that already works.</a:t>
+              <a:t>The age profile is a U. The left arm is career search, the right arm is retirement. Mid-career teachers, the ones schools most need to keep, are the least mobile workers in the figure.</a:t>
             </a:r>
             <a:endParaRPr lang="en-US" dirty="0"/>
           </a:p>
@@ -1483,7 +1572,7 @@
           <a:p>
             <a:r>
               <a:rPr lang="en-US" dirty="0"/>
-              <a:t>A birth raises a teacher's exit by twice as much as a nurse's. Teaching is the college profession where a classroom cannot be covered part time.</a:t>
+              <a:t>Private schools lose teachers at twice the public rate, through every route. Tenure, salary schedules and pensions are retention policy that already works.</a:t>
             </a:r>
             <a:endParaRPr lang="en-US" dirty="0"/>
           </a:p>
@@ -1571,7 +1660,7 @@
           <a:p>
             <a:r>
               <a:rPr lang="en-US" dirty="0"/>
-              <a:t>The classic exit to home is disappearing. The gap between mothers and other young women teachers went from seven points to under two in twenty-five years.</a:t>
+              <a:t>A birth raises a teacher's exit by twice as much as a nurse's. Teaching is the college profession where a classroom cannot be covered part time.</a:t>
             </a:r>
             <a:endParaRPr lang="en-US" dirty="0"/>
           </a:p>
@@ -1659,7 +1748,7 @@
           <a:p>
             <a:r>
               <a:rPr lang="en-US" dirty="0"/>
-              <a:t>Booms do not poach teachers. Where exits respond to the cycle at all, recessions push them out. The poaching story has no support in the data.</a:t>
+              <a:t>The classic exit to home is disappearing. The gap between mothers and other young women teachers went from seven points to under two in twenty-five years.</a:t>
             </a:r>
             <a:endParaRPr lang="en-US" dirty="0"/>
           </a:p>
@@ -2253,7 +2342,7 @@
                 <a:ea typeface="Garamond" pitchFamily="34" charset="-122"/>
                 <a:cs typeface="Garamond" pitchFamily="34" charset="-120"/>
               </a:rPr>
-              <a:t>Figure 9. Leaving and State Unemployment: Two Examples</a:t>
+              <a:t>Figure 8. Leaving Teaching and the Unemployment Rate, 1997–2024</a:t>
             </a:r>
             <a:endParaRPr lang="en-US" sz="2100" dirty="0"/>
           </a:p>
@@ -2261,7 +2350,7 @@
       </p:sp>
       <p:pic>
         <p:nvPicPr>
-          <p:cNvPr id="3" name="Image 0" descr="figs_png/n5b_states_trio.png">    </p:cNvPr>
+          <p:cNvPr id="3" name="Image 0" descr="figs_png/n5_cyclicality.png">    </p:cNvPr>
           <p:cNvPicPr>
             <a:picLocks noChangeAspect="1"/>
           </p:cNvPicPr>
@@ -2275,8 +2364,8 @@
         </p:blipFill>
         <p:spPr>
           <a:xfrm>
-            <a:off x="899307" y="804672"/>
-            <a:ext cx="10390339" cy="4709160"/>
+            <a:off x="470916" y="1072233"/>
+            <a:ext cx="11247120" cy="4174039"/>
           </a:xfrm>
           <a:prstGeom prst="rect">
             <a:avLst/>
@@ -2316,7 +2405,7 @@
                 <a:ea typeface="Garamond" pitchFamily="34" charset="-122"/>
                 <a:cs typeface="Garamond" pitchFamily="34" charset="-120"/>
               </a:rPr>
-              <a:t>Notes: Annual state leaving rates of college-graduate teachers (dots; one per year, 1997–2024) against the state unemployment rate in the survey month (BLS Local Area Unemployment Statistics), with OLS fits. North Carolina and New Jersey are shown as examples of the two signs. State of residence is recovered from the household records of the raw files. Source: author’s calculations from March CPS supplements.</a:t>
+              <a:t>Notes: Left: the leaving series (annual, from calendar 2000) against the BLS national unemployment rate (annual average). Right: binned scatter (deciles of the unemployment rate in the survey month, March of t+1, when the exit is observed) of the two labor-market routes, with OLS fits on the underlying annual data; correlations are −0.16 (to another job) and +0.29 (out of the labor force). Unemployment: BLS via FRED (UNRATE). Source: author’s calculations from March CPS supplements.</a:t>
             </a:r>
             <a:endParaRPr lang="en-US" sz="950" dirty="0"/>
           </a:p>
@@ -2387,7 +2476,7 @@
                 <a:ea typeface="Garamond" pitchFamily="34" charset="-122"/>
                 <a:cs typeface="Garamond" pitchFamily="34" charset="-120"/>
               </a:rPr>
-              <a:t>Figure 10. The Distribution of Earnings Changes: Stayers and Leavers</a:t>
+              <a:t>Figure 9. Leaving and State Unemployment: Two Examples</a:t>
             </a:r>
             <a:endParaRPr lang="en-US" sz="2100" dirty="0"/>
           </a:p>
@@ -2395,7 +2484,7 @@
       </p:sp>
       <p:pic>
         <p:nvPicPr>
-          <p:cNvPr id="3" name="Image 0" descr="figs_png/g5b_earnings_density.png">    </p:cNvPr>
+          <p:cNvPr id="3" name="Image 0" descr="figs_png/n5b_states_trio.png">    </p:cNvPr>
           <p:cNvPicPr>
             <a:picLocks noChangeAspect="1"/>
           </p:cNvPicPr>
@@ -2409,8 +2498,8 @@
         </p:blipFill>
         <p:spPr>
           <a:xfrm>
-            <a:off x="1590062" y="804672"/>
-            <a:ext cx="9008828" cy="4709160"/>
+            <a:off x="899307" y="804672"/>
+            <a:ext cx="10390339" cy="4709160"/>
           </a:xfrm>
           <a:prstGeom prst="rect">
             <a:avLst/>
@@ -2450,7 +2539,7 @@
                 <a:ea typeface="Garamond" pitchFamily="34" charset="-122"/>
                 <a:cs typeface="Garamond" pitchFamily="34" charset="-120"/>
               </a:rPr>
-              <a:t>Notes: Kernel densities of the person-level change in annual wage and salary earnings (log points ×100) between the teaching year and the next, for teachers linked across consecutive supplements (rotation-group links, survey years 2011–2025; identity validated on sex and age). Navy: stayers (12,195 links; median +3). Red: leavers employed the following year (225 links; median +15). “Lose big”/“win big” denote changes beyond ±30 log points. The sample conditions on positive earnings in both years; 47 percent of all leavers report zero earnings the following year. Bandwidth 0.25. Source: author’s calculations from March CPS supplements.</a:t>
+              <a:t>Notes: Annual state leaving rates of college-graduate teachers (dots; one per year, 1997–2024) against the state unemployment rate in the survey month (BLS Local Area Unemployment Statistics), with OLS fits. North Carolina and New Jersey are shown as examples of the two signs. State of residence is recovered from the household records of the raw files. Source: author’s calculations from March CPS supplements.</a:t>
             </a:r>
             <a:endParaRPr lang="en-US" sz="950" dirty="0"/>
           </a:p>
@@ -2521,7 +2610,7 @@
                 <a:ea typeface="Garamond" pitchFamily="34" charset="-122"/>
                 <a:cs typeface="Garamond" pitchFamily="34" charset="-120"/>
               </a:rPr>
-              <a:t>Figure 11. Real Median Earnings by Profession, 2004–2014 and 2015–2025</a:t>
+              <a:t>Figure 10. The Distribution of Earnings Changes: Stayers and Leavers</a:t>
             </a:r>
             <a:endParaRPr lang="en-US" sz="2100" dirty="0"/>
           </a:p>
@@ -2529,7 +2618,7 @@
       </p:sp>
       <p:pic>
         <p:nvPicPr>
-          <p:cNvPr id="3" name="Image 0" descr="figs_png/n6b_pay_windows.png">    </p:cNvPr>
+          <p:cNvPr id="3" name="Image 0" descr="figs_png/g5b_earnings_density.png">    </p:cNvPr>
           <p:cNvPicPr>
             <a:picLocks noChangeAspect="1"/>
           </p:cNvPicPr>
@@ -2543,8 +2632,8 @@
         </p:blipFill>
         <p:spPr>
           <a:xfrm>
-            <a:off x="1609562" y="804672"/>
-            <a:ext cx="8969829" cy="4709160"/>
+            <a:off x="1590062" y="804672"/>
+            <a:ext cx="9008828" cy="4709160"/>
           </a:xfrm>
           <a:prstGeom prst="rect">
             <a:avLst/>
@@ -2584,7 +2673,7 @@
                 <a:ea typeface="Garamond" pitchFamily="34" charset="-122"/>
                 <a:cs typeface="Garamond" pitchFamily="34" charset="-120"/>
               </a:rPr>
-              <a:t>Notes: Weighted median annual wage and salary earnings of full-time, full-year college graduates aged 25–60, in each profession and overall, deflated to 2024 dollars with the CPI-U; the two windows pool survey years 2004–2014 and 2015–2025. Filled dots (with values): recent window. Source: author’s calculations from March CPS supplements; CPI: BLS via FRED.</a:t>
+              <a:t>Notes: Kernel densities of the person-level change in annual wage and salary earnings (log points ×100) between the teaching year and the next, for teachers linked across consecutive supplements (rotation-group links, survey years 2011–2025; identity validated on sex and age). Navy: stayers (12,195 links; median +3). Red: leavers employed the following year (225 links; median +15). “Lose big”/“win big” denote changes beyond ±30 log points. The sample conditions on positive earnings in both years; 47 percent of all leavers report zero earnings the following year. Bandwidth 0.25. Source: author’s calculations from March CPS supplements.</a:t>
             </a:r>
             <a:endParaRPr lang="en-US" sz="950" dirty="0"/>
           </a:p>
@@ -2655,7 +2744,7 @@
                 <a:ea typeface="Garamond" pitchFamily="34" charset="-122"/>
                 <a:cs typeface="Garamond" pitchFamily="34" charset="-120"/>
               </a:rPr>
-              <a:t>Figure 12. Average Marginal Effects on the Probability of Leaving Teaching</a:t>
+              <a:t>Figure 11. Real Median Earnings by Profession, 2004–2014 and 2015–2025</a:t>
             </a:r>
             <a:endParaRPr lang="en-US" sz="2100" dirty="0"/>
           </a:p>
@@ -2663,7 +2752,7 @@
       </p:sp>
       <p:pic>
         <p:nvPicPr>
-          <p:cNvPr id="3" name="Image 0" descr="figs_png/g6_ame.png">    </p:cNvPr>
+          <p:cNvPr id="3" name="Image 0" descr="figs_png/n6b_pay_windows.png">    </p:cNvPr>
           <p:cNvPicPr>
             <a:picLocks noChangeAspect="1"/>
           </p:cNvPicPr>
@@ -2677,8 +2766,8 @@
         </p:blipFill>
         <p:spPr>
           <a:xfrm>
-            <a:off x="2955036" y="804672"/>
-            <a:ext cx="6278880" cy="4709160"/>
+            <a:off x="1609562" y="804672"/>
+            <a:ext cx="8969829" cy="4709160"/>
           </a:xfrm>
           <a:prstGeom prst="rect">
             <a:avLst/>
@@ -2718,7 +2807,7 @@
                 <a:ea typeface="Garamond" pitchFamily="34" charset="-122"/>
                 <a:cs typeface="Garamond" pitchFamily="34" charset="-120"/>
               </a:rPr>
-              <a:t>Notes: Average marginal effects (percentage points) on the probability of leaving teaching, from a probit on college-graduate teachers pooled over calendar 2015–2024 with year effects; whiskers are 95 percent confidence intervals; filled markers are significant at 5 percent. “Worked full year” is 50+ weeks at the last-year job; “part-time” is under 35 weekly hours. n = 28,900. Source: author’s calculations from March CPS supplements.</a:t>
+              <a:t>Notes: Weighted median annual wage and salary earnings of full-time, full-year college graduates aged 25–60, in each profession and overall, deflated to 2024 dollars with the CPI-U; the two windows pool survey years 2004–2014 and 2015–2025. Filled dots (with values): recent window. Source: author’s calculations from March CPS supplements; CPI: BLS via FRED.</a:t>
             </a:r>
             <a:endParaRPr lang="en-US" sz="950" dirty="0"/>
           </a:p>
@@ -2789,6 +2878,140 @@
                 <a:ea typeface="Garamond" pitchFamily="34" charset="-122"/>
                 <a:cs typeface="Garamond" pitchFamily="34" charset="-120"/>
               </a:rPr>
+              <a:t>Figure 12. Average Marginal Effects on the Probability of Leaving Teaching</a:t>
+            </a:r>
+            <a:endParaRPr lang="en-US" sz="2100" dirty="0"/>
+          </a:p>
+        </p:txBody>
+      </p:sp>
+      <p:pic>
+        <p:nvPicPr>
+          <p:cNvPr id="3" name="Image 0" descr="figs_png/g6_ame.png">    </p:cNvPr>
+          <p:cNvPicPr>
+            <a:picLocks noChangeAspect="1"/>
+          </p:cNvPicPr>
+          <p:nvPr/>
+        </p:nvPicPr>
+        <p:blipFill>
+          <a:blip r:embed="rId1"/>
+          <a:stretch>
+            <a:fillRect/>
+          </a:stretch>
+        </p:blipFill>
+        <p:spPr>
+          <a:xfrm>
+            <a:off x="2955036" y="804672"/>
+            <a:ext cx="6278880" cy="4709160"/>
+          </a:xfrm>
+          <a:prstGeom prst="rect">
+            <a:avLst/>
+          </a:prstGeom>
+        </p:spPr>
+      </p:pic>
+      <p:sp>
+        <p:nvSpPr>
+          <p:cNvPr id="5" name="Text 1"/>
+          <p:cNvSpPr/>
+          <p:nvPr/>
+        </p:nvSpPr>
+        <p:spPr>
+          <a:xfrm>
+            <a:off x="457200" y="5650992"/>
+            <a:ext cx="11274552" cy="1097280"/>
+          </a:xfrm>
+          <a:prstGeom prst="rect">
+            <a:avLst/>
+          </a:prstGeom>
+          <a:noFill/>
+          <a:ln/>
+        </p:spPr>
+        <p:txBody>
+          <a:bodyPr wrap="square" lIns="0" tIns="0" rIns="0" bIns="0" rtlCol="0" anchor="t"/>
+          <a:lstStyle/>
+          <a:p>
+            <a:pPr algn="just" indent="0" marL="0">
+              <a:buNone/>
+            </a:pPr>
+            <a:r>
+              <a:rPr lang="en-US" sz="950" dirty="0">
+                <a:solidFill>
+                  <a:srgbClr val="5A6572"/>
+                </a:solidFill>
+                <a:latin typeface="Garamond" pitchFamily="34" charset="0"/>
+                <a:ea typeface="Garamond" pitchFamily="34" charset="-122"/>
+                <a:cs typeface="Garamond" pitchFamily="34" charset="-120"/>
+              </a:rPr>
+              <a:t>Notes: Average marginal effects (percentage points) on the probability of leaving teaching, from a probit on college-graduate teachers pooled over calendar 2015–2024 with year effects; whiskers are 95 percent confidence intervals; filled markers are significant at 5 percent. “Worked full year” is 50+ weeks at the last-year job; “part-time” is under 35 weekly hours. n = 28,900. Source: author’s calculations from March CPS supplements.</a:t>
+            </a:r>
+            <a:endParaRPr lang="en-US" sz="950" dirty="0"/>
+          </a:p>
+        </p:txBody>
+      </p:sp>
+    </p:spTree>
+  </p:cSld>
+  <p:clrMapOvr>
+    <a:masterClrMapping/>
+  </p:clrMapOvr>
+</p:sld>
+</file>
+
+<file path=ppt/slides/slide15.xml><?xml version="1.0" encoding="utf-8"?>
+<p:sld xmlns:a="http://schemas.openxmlformats.org/drawingml/2006/main" xmlns:r="http://schemas.openxmlformats.org/officeDocument/2006/relationships" xmlns:p="http://schemas.openxmlformats.org/presentationml/2006/main">
+  <p:cSld name="Slide 15">
+    <p:bg>
+      <p:bgPr>
+        <a:solidFill>
+          <a:srgbClr val="FFFFFF"/>
+        </a:solidFill>
+      </p:bgPr>
+    </p:bg>
+    <p:spTree>
+      <p:nvGrpSpPr>
+        <p:cNvPr id="1" name=""/>
+        <p:cNvGrpSpPr/>
+        <p:nvPr/>
+      </p:nvGrpSpPr>
+      <p:grpSpPr>
+        <a:xfrm>
+          <a:off x="0" y="0"/>
+          <a:ext cx="0" cy="0"/>
+          <a:chOff x="0" y="0"/>
+          <a:chExt cx="0" cy="0"/>
+        </a:xfrm>
+      </p:grpSpPr>
+      <p:sp>
+        <p:nvSpPr>
+          <p:cNvPr id="2" name="Text 0"/>
+          <p:cNvSpPr/>
+          <p:nvPr/>
+        </p:nvSpPr>
+        <p:spPr>
+          <a:xfrm>
+            <a:off x="457200" y="201168"/>
+            <a:ext cx="11274552" cy="502920"/>
+          </a:xfrm>
+          <a:prstGeom prst="rect">
+            <a:avLst/>
+          </a:prstGeom>
+          <a:noFill/>
+          <a:ln/>
+        </p:spPr>
+        <p:txBody>
+          <a:bodyPr wrap="square" lIns="0" tIns="0" rIns="0" bIns="0" rtlCol="0" anchor="ctr"/>
+          <a:lstStyle/>
+          <a:p>
+            <a:pPr algn="ctr" indent="0" marL="0">
+              <a:buNone/>
+            </a:pPr>
+            <a:r>
+              <a:rPr lang="en-US" sz="2100" dirty="0">
+                <a:solidFill>
+                  <a:srgbClr val="1A2430"/>
+                </a:solidFill>
+                <a:latin typeface="Garamond" pitchFamily="34" charset="0"/>
+                <a:ea typeface="Garamond" pitchFamily="34" charset="-122"/>
+                <a:cs typeface="Garamond" pitchFamily="34" charset="-120"/>
+              </a:rPr>
               <a:t>Figure 13. Rates of Leaving by Profession, 2004–2014 and 2015–2025</a:t>
             </a:r>
             <a:endParaRPr lang="en-US" sz="2100" dirty="0"/>
@@ -2898,8 +3121,8 @@
         </p:nvSpPr>
         <p:spPr>
           <a:xfrm>
-            <a:off x="457200" y="201168"/>
-            <a:ext cx="11274552" cy="502920"/>
+            <a:off x="457200" y="320040"/>
+            <a:ext cx="11274552" cy="548640"/>
           </a:xfrm>
           <a:prstGeom prst="rect">
             <a:avLst/>
@@ -2915,7 +3138,7 @@
               <a:buNone/>
             </a:pPr>
             <a:r>
-              <a:rPr lang="en-US" sz="2100" dirty="0">
+              <a:rPr lang="en-US" sz="2600" dirty="0">
                 <a:solidFill>
                   <a:srgbClr val="1A2430"/>
                 </a:solidFill>
@@ -2923,46 +3146,22 @@
                 <a:ea typeface="Garamond" pitchFamily="34" charset="-122"/>
                 <a:cs typeface="Garamond" pitchFamily="34" charset="-120"/>
               </a:rPr>
-              <a:t>Figure 1. Composition of the Teaching Workforce, 2005–2024</a:t>
-            </a:r>
-            <a:endParaRPr lang="en-US" sz="2100" dirty="0"/>
-          </a:p>
-        </p:txBody>
-      </p:sp>
-      <p:pic>
-        <p:nvPicPr>
-          <p:cNvPr id="3" name="Image 0" descr="figs_png/g1_workforce.png">    </p:cNvPr>
-          <p:cNvPicPr>
-            <a:picLocks noChangeAspect="1"/>
-          </p:cNvPicPr>
-          <p:nvPr/>
-        </p:nvPicPr>
-        <p:blipFill>
-          <a:blip r:embed="rId1"/>
-          <a:stretch>
-            <a:fillRect/>
-          </a:stretch>
-        </p:blipFill>
-        <p:spPr>
-          <a:xfrm>
-            <a:off x="1133040" y="804672"/>
-            <a:ext cx="9922873" cy="4709160"/>
-          </a:xfrm>
-          <a:prstGeom prst="rect">
-            <a:avLst/>
-          </a:prstGeom>
-        </p:spPr>
-      </p:pic>
-      <p:sp>
-        <p:nvSpPr>
-          <p:cNvPr id="5" name="Text 1"/>
+              <a:t>Data</a:t>
+            </a:r>
+            <a:endParaRPr lang="en-US" sz="2600" dirty="0"/>
+          </a:p>
+        </p:txBody>
+      </p:sp>
+      <p:sp>
+        <p:nvSpPr>
+          <p:cNvPr id="3" name="Text 1"/>
           <p:cNvSpPr/>
           <p:nvPr/>
         </p:nvSpPr>
         <p:spPr>
           <a:xfrm>
-            <a:off x="457200" y="5650992"/>
-            <a:ext cx="11274552" cy="1097280"/>
+            <a:off x="1005840" y="1234440"/>
+            <a:ext cx="10177272" cy="384048"/>
           </a:xfrm>
           <a:prstGeom prst="rect">
             <a:avLst/>
@@ -2971,24 +3170,219 @@
           <a:ln/>
         </p:spPr>
         <p:txBody>
-          <a:bodyPr wrap="square" lIns="0" tIns="0" rIns="0" bIns="0" rtlCol="0" anchor="t"/>
-          <a:lstStyle/>
-          <a:p>
-            <a:pPr algn="just" indent="0" marL="0">
+          <a:bodyPr wrap="square" lIns="0" tIns="0" rIns="0" bIns="0" rtlCol="0" anchor="ctr"/>
+          <a:lstStyle/>
+          <a:p>
+            <a:pPr algn="l" indent="0" marL="0">
               <a:buNone/>
             </a:pPr>
             <a:r>
-              <a:rPr lang="en-US" sz="950" dirty="0">
+              <a:rPr lang="en-US" sz="1650" dirty="0">
                 <a:solidFill>
-                  <a:srgbClr val="5A6572"/>
+                  <a:srgbClr val="2A5DB0"/>
                 </a:solidFill>
                 <a:latin typeface="Garamond" pitchFamily="34" charset="0"/>
                 <a:ea typeface="Garamond" pitchFamily="34" charset="-122"/>
                 <a:cs typeface="Garamond" pitchFamily="34" charset="-120"/>
               </a:rPr>
-              <a:t>Notes: College-graduate teachers aged 18+ whose longest job last year was K–12 teaching; ASEC supplement weights. Thin gray lines are annual values; blue lines are centered 3-year averages, with endpoint values printed. “Public school,” “part-time,” and “pension plan” refer to the longest job held last year; the open circle marks 2013, a year with a reduced sample due to the ASEC redesign. Source: author’s calculations from March CPS supplements, survey years 2006–2025.</a:t>
-            </a:r>
-            <a:endParaRPr lang="en-US" sz="950" dirty="0"/>
+              <a:t>The question</a:t>
+            </a:r>
+            <a:endParaRPr lang="en-US" sz="1650" dirty="0"/>
+          </a:p>
+        </p:txBody>
+      </p:sp>
+      <p:sp>
+        <p:nvSpPr>
+          <p:cNvPr id="4" name="Text 2"/>
+          <p:cNvSpPr/>
+          <p:nvPr/>
+        </p:nvSpPr>
+        <p:spPr>
+          <a:xfrm>
+            <a:off x="1005840" y="1636776"/>
+            <a:ext cx="10177272" cy="1170432"/>
+          </a:xfrm>
+          <a:prstGeom prst="rect">
+            <a:avLst/>
+          </a:prstGeom>
+          <a:noFill/>
+          <a:ln/>
+        </p:spPr>
+        <p:txBody>
+          <a:bodyPr wrap="square" lIns="0" tIns="0" rIns="0" bIns="0" rtlCol="0" anchor="t"/>
+          <a:lstStyle/>
+          <a:p>
+            <a:pPr algn="just" indent="0" marL="0">
+              <a:buNone/>
+            </a:pPr>
+            <a:r>
+              <a:rPr lang="en-US" sz="1350" dirty="0">
+                <a:solidFill>
+                  <a:srgbClr val="1A2430"/>
+                </a:solidFill>
+                <a:latin typeface="Garamond" pitchFamily="34" charset="0"/>
+                <a:ea typeface="Garamond" pitchFamily="34" charset="-122"/>
+                <a:cs typeface="Garamond" pitchFamily="34" charset="-120"/>
+              </a:rPr>
+              <a:t>One in six American teachers is said to leave every year. That number mixes teachers who change schools with teachers who leave the classroom for good. Everything that follows tracks only the second group, the one the word exodus refers to.</a:t>
+            </a:r>
+            <a:endParaRPr lang="en-US" sz="1350" dirty="0"/>
+          </a:p>
+        </p:txBody>
+      </p:sp>
+      <p:sp>
+        <p:nvSpPr>
+          <p:cNvPr id="5" name="Text 3"/>
+          <p:cNvSpPr/>
+          <p:nvPr/>
+        </p:nvSpPr>
+        <p:spPr>
+          <a:xfrm>
+            <a:off x="1005840" y="3017520"/>
+            <a:ext cx="10177272" cy="384048"/>
+          </a:xfrm>
+          <a:prstGeom prst="rect">
+            <a:avLst/>
+          </a:prstGeom>
+          <a:noFill/>
+          <a:ln/>
+        </p:spPr>
+        <p:txBody>
+          <a:bodyPr wrap="square" lIns="0" tIns="0" rIns="0" bIns="0" rtlCol="0" anchor="ctr"/>
+          <a:lstStyle/>
+          <a:p>
+            <a:pPr algn="l" indent="0" marL="0">
+              <a:buNone/>
+            </a:pPr>
+            <a:r>
+              <a:rPr lang="en-US" sz="1650" dirty="0">
+                <a:solidFill>
+                  <a:srgbClr val="2A5DB0"/>
+                </a:solidFill>
+                <a:latin typeface="Garamond" pitchFamily="34" charset="0"/>
+                <a:ea typeface="Garamond" pitchFamily="34" charset="-122"/>
+                <a:cs typeface="Garamond" pitchFamily="34" charset="-120"/>
+              </a:rPr>
+              <a:t>The instrument</a:t>
+            </a:r>
+            <a:endParaRPr lang="en-US" sz="1650" dirty="0"/>
+          </a:p>
+        </p:txBody>
+      </p:sp>
+      <p:sp>
+        <p:nvSpPr>
+          <p:cNvPr id="6" name="Text 4"/>
+          <p:cNvSpPr/>
+          <p:nvPr/>
+        </p:nvSpPr>
+        <p:spPr>
+          <a:xfrm>
+            <a:off x="1005840" y="3419856"/>
+            <a:ext cx="10177272" cy="1170432"/>
+          </a:xfrm>
+          <a:prstGeom prst="rect">
+            <a:avLst/>
+          </a:prstGeom>
+          <a:noFill/>
+          <a:ln/>
+        </p:spPr>
+        <p:txBody>
+          <a:bodyPr wrap="square" lIns="0" tIns="0" rIns="0" bIns="0" rtlCol="0" anchor="t"/>
+          <a:lstStyle/>
+          <a:p>
+            <a:pPr algn="just" indent="0" marL="0">
+              <a:buNone/>
+            </a:pPr>
+            <a:r>
+              <a:rPr lang="en-US" sz="1350" dirty="0">
+                <a:solidFill>
+                  <a:srgbClr val="1A2430"/>
+                </a:solidFill>
+                <a:latin typeface="Garamond" pitchFamily="34" charset="0"/>
+                <a:ea typeface="Garamond" pitchFamily="34" charset="-122"/>
+                <a:cs typeface="Garamond" pitchFamily="34" charset="-120"/>
+              </a:rPr>
+              <a:t>The March supplement of the Current Population Survey asks two questions of every household: the longest job held last calendar year, and the occupation this week. Whoever taught last year and no longer teaches this March has left the profession within fifteen months. The survey also records where they landed and what they earn.</a:t>
+            </a:r>
+            <a:endParaRPr lang="en-US" sz="1350" dirty="0"/>
+          </a:p>
+        </p:txBody>
+      </p:sp>
+      <p:sp>
+        <p:nvSpPr>
+          <p:cNvPr id="7" name="Text 5"/>
+          <p:cNvSpPr/>
+          <p:nvPr/>
+        </p:nvSpPr>
+        <p:spPr>
+          <a:xfrm>
+            <a:off x="1005840" y="4800600"/>
+            <a:ext cx="10177272" cy="384048"/>
+          </a:xfrm>
+          <a:prstGeom prst="rect">
+            <a:avLst/>
+          </a:prstGeom>
+          <a:noFill/>
+          <a:ln/>
+        </p:spPr>
+        <p:txBody>
+          <a:bodyPr wrap="square" lIns="0" tIns="0" rIns="0" bIns="0" rtlCol="0" anchor="ctr"/>
+          <a:lstStyle/>
+          <a:p>
+            <a:pPr algn="l" indent="0" marL="0">
+              <a:buNone/>
+            </a:pPr>
+            <a:r>
+              <a:rPr lang="en-US" sz="1650" dirty="0">
+                <a:solidFill>
+                  <a:srgbClr val="2A5DB0"/>
+                </a:solidFill>
+                <a:latin typeface="Garamond" pitchFamily="34" charset="0"/>
+                <a:ea typeface="Garamond" pitchFamily="34" charset="-122"/>
+                <a:cs typeface="Garamond" pitchFamily="34" charset="-120"/>
+              </a:rPr>
+              <a:t>The database</a:t>
+            </a:r>
+            <a:endParaRPr lang="en-US" sz="1650" dirty="0"/>
+          </a:p>
+        </p:txBody>
+      </p:sp>
+      <p:sp>
+        <p:nvSpPr>
+          <p:cNvPr id="8" name="Text 6"/>
+          <p:cNvSpPr/>
+          <p:nvPr/>
+        </p:nvSpPr>
+        <p:spPr>
+          <a:xfrm>
+            <a:off x="1005840" y="5202936"/>
+            <a:ext cx="10177272" cy="1170432"/>
+          </a:xfrm>
+          <a:prstGeom prst="rect">
+            <a:avLst/>
+          </a:prstGeom>
+          <a:noFill/>
+          <a:ln/>
+        </p:spPr>
+        <p:txBody>
+          <a:bodyPr wrap="square" lIns="0" tIns="0" rIns="0" bIns="0" rtlCol="0" anchor="t"/>
+          <a:lstStyle/>
+          <a:p>
+            <a:pPr algn="just" indent="0" marL="0">
+              <a:buNone/>
+            </a:pPr>
+            <a:r>
+              <a:rPr lang="en-US" sz="1350" dirty="0">
+                <a:solidFill>
+                  <a:srgbClr val="1A2430"/>
+                </a:solidFill>
+                <a:latin typeface="Garamond" pitchFamily="34" charset="0"/>
+                <a:ea typeface="Garamond" pitchFamily="34" charset="-122"/>
+                <a:cs typeface="Garamond" pitchFamily="34" charset="-120"/>
+              </a:rPr>
+              <a:t>All twenty-eight supplements, survey years 1998 to 2025, read from the raw Census files at their officially documented positions. 5,009,129 person-year records, 104,545 of them teacher-years, covering calendar years 1997 to 2024. All estimates use ASEC supplement weights. The 2026 supplement, which will add calendar 2025, is not yet public.</a:t>
+            </a:r>
+            <a:endParaRPr lang="en-US" sz="1350" dirty="0"/>
           </a:p>
         </p:txBody>
       </p:sp>
@@ -3057,7 +3451,7 @@
                 <a:ea typeface="Garamond" pitchFamily="34" charset="-122"/>
                 <a:cs typeface="Garamond" pitchFamily="34" charset="-120"/>
               </a:rPr>
-              <a:t>Figure 2. Leaving Teaching, 1997–2024</a:t>
+              <a:t>Figure 1. Composition of the Teaching Workforce, 2005–2024</a:t>
             </a:r>
             <a:endParaRPr lang="en-US" sz="2100" dirty="0"/>
           </a:p>
@@ -3065,7 +3459,7 @@
       </p:sp>
       <p:pic>
         <p:nvPicPr>
-          <p:cNvPr id="3" name="Image 0" descr="figs_png/g2_evolution.png">    </p:cNvPr>
+          <p:cNvPr id="3" name="Image 0" descr="figs_png/g1_workforce.png">    </p:cNvPr>
           <p:cNvPicPr>
             <a:picLocks noChangeAspect="1"/>
           </p:cNvPicPr>
@@ -3079,8 +3473,8 @@
         </p:blipFill>
         <p:spPr>
           <a:xfrm>
-            <a:off x="1385316" y="804672"/>
-            <a:ext cx="9418320" cy="4709160"/>
+            <a:off x="1133040" y="804672"/>
+            <a:ext cx="9922873" cy="4709160"/>
           </a:xfrm>
           <a:prstGeom prst="rect">
             <a:avLst/>
@@ -3120,7 +3514,7 @@
                 <a:ea typeface="Garamond" pitchFamily="34" charset="-122"/>
                 <a:cs typeface="Garamond" pitchFamily="34" charset="-120"/>
               </a:rPr>
-              <a:t>Notes: Share of college-graduate teachers (longest job last calendar year) not employed in a teaching occupation the following March; ASEC weights. Shaded band: 95 percent confidence interval using a design factor of 1.5. Dotted line: the 1997–2024 mean (8.6). The gray band marks the Covid supplements. Source: author’s calculations from March CPS supplements, survey years 1998–2025.</a:t>
+              <a:t>Notes: College-graduate teachers aged 18+ whose longest job last year was K–12 teaching; ASEC supplement weights. Thin gray lines are annual values; blue lines are centered 3-year averages, with endpoint values printed. “Public school,” “part-time,” and “pension plan” refer to the longest job held last year; the open circle marks 2013, a year with a reduced sample due to the ASEC redesign. Source: author’s calculations from March CPS supplements, survey years 2006–2025.</a:t>
             </a:r>
             <a:endParaRPr lang="en-US" sz="950" dirty="0"/>
           </a:p>
@@ -3191,7 +3585,7 @@
                 <a:ea typeface="Garamond" pitchFamily="34" charset="-122"/>
                 <a:cs typeface="Garamond" pitchFamily="34" charset="-120"/>
               </a:rPr>
-              <a:t>Figure 3. Destinations of Teachers Who Leave the Profession</a:t>
+              <a:t>Figure 2. Leaving Teaching, 1997–2024</a:t>
             </a:r>
             <a:endParaRPr lang="en-US" sz="2100" dirty="0"/>
           </a:p>
@@ -3199,7 +3593,7 @@
       </p:sp>
       <p:pic>
         <p:nvPicPr>
-          <p:cNvPr id="3" name="Image 0" descr="figs_png/g3_flow100.png">    </p:cNvPr>
+          <p:cNvPr id="3" name="Image 0" descr="figs_png/g2_evolution.png">    </p:cNvPr>
           <p:cNvPicPr>
             <a:picLocks noChangeAspect="1"/>
           </p:cNvPicPr>
@@ -3213,8 +3607,8 @@
         </p:blipFill>
         <p:spPr>
           <a:xfrm>
-            <a:off x="1180570" y="804672"/>
-            <a:ext cx="9827812" cy="4709160"/>
+            <a:off x="1385316" y="804672"/>
+            <a:ext cx="9418320" cy="4709160"/>
           </a:xfrm>
           <a:prstGeom prst="rect">
             <a:avLst/>
@@ -3254,7 +3648,7 @@
                 <a:ea typeface="Garamond" pitchFamily="34" charset="-122"/>
                 <a:cs typeface="Garamond" pitchFamily="34" charset="-120"/>
               </a:rPr>
-              <a:t>Notes: College-graduate leavers pooled over calendar 2015–2024, ASEC weights. Top bar: labor force status the March after the teaching year; “out of the labor force” is split at age 55. Bottom bar: the occupational destination of the 26 employed leavers, rescaled to sum to their total. Source: author’s calculations from March CPS supplements.</a:t>
+              <a:t>Notes: Share of college-graduate teachers (longest job last calendar year) not employed in a teaching occupation the following March; ASEC weights. Shaded band: 95 percent confidence interval using a design factor of 1.5. Dotted line: the 1997–2024 mean (8.6). The gray band marks the Covid supplements. Source: author’s calculations from March CPS supplements, survey years 1998–2025.</a:t>
             </a:r>
             <a:endParaRPr lang="en-US" sz="950" dirty="0"/>
           </a:p>
@@ -3325,7 +3719,7 @@
                 <a:ea typeface="Garamond" pitchFamily="34" charset="-122"/>
                 <a:cs typeface="Garamond" pitchFamily="34" charset="-120"/>
               </a:rPr>
-              <a:t>Figure 4. Leaving Teaching by Age and Route</a:t>
+              <a:t>Figure 3. Destinations of Teachers Who Leave the Profession</a:t>
             </a:r>
             <a:endParaRPr lang="en-US" sz="2100" dirty="0"/>
           </a:p>
@@ -3333,7 +3727,7 @@
       </p:sp>
       <p:pic>
         <p:nvPicPr>
-          <p:cNvPr id="3" name="Image 0" descr="figs_png/g4_routes_age.png">    </p:cNvPr>
+          <p:cNvPr id="3" name="Image 0" descr="figs_png/g3_flow100.png">    </p:cNvPr>
           <p:cNvPicPr>
             <a:picLocks noChangeAspect="1"/>
           </p:cNvPicPr>
@@ -3347,8 +3741,8 @@
         </p:blipFill>
         <p:spPr>
           <a:xfrm>
-            <a:off x="1497439" y="804672"/>
-            <a:ext cx="9194074" cy="4709160"/>
+            <a:off x="1180570" y="804672"/>
+            <a:ext cx="9827812" cy="4709160"/>
           </a:xfrm>
           <a:prstGeom prst="rect">
             <a:avLst/>
@@ -3388,7 +3782,7 @@
                 <a:ea typeface="Garamond" pitchFamily="34" charset="-122"/>
                 <a:cs typeface="Garamond" pitchFamily="34" charset="-120"/>
               </a:rPr>
-              <a:t>Notes: College-graduate teachers pooled over calendar 2015–2024, ASEC weights; ten age groups. The black line is the total leaving rate; stacked areas decompose it into exits to another job, unemployment, and out of the labor force. Source: author’s calculations from March CPS supplements.</a:t>
+              <a:t>Notes: College-graduate leavers pooled over calendar 2015–2024, ASEC weights. Top bar: labor force status the March after the teaching year; “out of the labor force” is split at age 55. Bottom bar: the occupational destination of the 26 employed leavers, rescaled to sum to their total. Source: author’s calculations from March CPS supplements.</a:t>
             </a:r>
             <a:endParaRPr lang="en-US" sz="950" dirty="0"/>
           </a:p>
@@ -3459,7 +3853,7 @@
                 <a:ea typeface="Garamond" pitchFamily="34" charset="-122"/>
                 <a:cs typeface="Garamond" pitchFamily="34" charset="-120"/>
               </a:rPr>
-              <a:t>Figure 5. Exit Routes by School Sector</a:t>
+              <a:t>Figure 4. Leaving Teaching by Age and Route</a:t>
             </a:r>
             <a:endParaRPr lang="en-US" sz="2100" dirty="0"/>
           </a:p>
@@ -3467,7 +3861,7 @@
       </p:sp>
       <p:pic>
         <p:nvPicPr>
-          <p:cNvPr id="3" name="Image 0" descr="figs_png/g10_sector_routes.png">    </p:cNvPr>
+          <p:cNvPr id="3" name="Image 0" descr="figs_png/g4_routes_age.png">    </p:cNvPr>
           <p:cNvPicPr>
             <a:picLocks noChangeAspect="1"/>
           </p:cNvPicPr>
@@ -3481,8 +3875,8 @@
         </p:blipFill>
         <p:spPr>
           <a:xfrm>
-            <a:off x="2109802" y="804672"/>
-            <a:ext cx="7969348" cy="4709160"/>
+            <a:off x="1497439" y="804672"/>
+            <a:ext cx="9194074" cy="4709160"/>
           </a:xfrm>
           <a:prstGeom prst="rect">
             <a:avLst/>
@@ -3522,7 +3916,7 @@
                 <a:ea typeface="Garamond" pitchFamily="34" charset="-122"/>
                 <a:cs typeface="Garamond" pitchFamily="34" charset="-120"/>
               </a:rPr>
-              <a:t>Notes: Route-specific annual exit rates of college-graduate teachers by sector of the last-year job (class of worker: government vs. private), pooled 2015–2024, ASEC weights. A private-school teacher who moves to a public school—or vice versa—remains a teacher and is not a leaver here. Source: author’s calculations from March CPS supplements.</a:t>
+              <a:t>Notes: College-graduate teachers pooled over calendar 2015–2024, ASEC weights; ten age groups. The black line is the total leaving rate; stacked areas decompose it into exits to another job, unemployment, and out of the labor force. Source: author’s calculations from March CPS supplements.</a:t>
             </a:r>
             <a:endParaRPr lang="en-US" sz="950" dirty="0"/>
           </a:p>
@@ -3593,7 +3987,7 @@
                 <a:ea typeface="Garamond" pitchFamily="34" charset="-122"/>
                 <a:cs typeface="Garamond" pitchFamily="34" charset="-120"/>
               </a:rPr>
-              <a:t>Figure 6. The Effect of a New Baby on Leaving, by Profession</a:t>
+              <a:t>Figure 5. Exit Routes by School Sector</a:t>
             </a:r>
             <a:endParaRPr lang="en-US" sz="2100" dirty="0"/>
           </a:p>
@@ -3601,7 +3995,7 @@
       </p:sp>
       <p:pic>
         <p:nvPicPr>
-          <p:cNvPr id="3" name="Image 0" descr="figs_png/g8_newbaby.png">    </p:cNvPr>
+          <p:cNvPr id="3" name="Image 0" descr="figs_png/g10_sector_routes.png">    </p:cNvPr>
           <p:cNvPicPr>
             <a:picLocks noChangeAspect="1"/>
           </p:cNvPicPr>
@@ -3615,8 +4009,8 @@
         </p:blipFill>
         <p:spPr>
           <a:xfrm>
-            <a:off x="2024799" y="804672"/>
-            <a:ext cx="8139355" cy="4709160"/>
+            <a:off x="2109802" y="804672"/>
+            <a:ext cx="7969348" cy="4709160"/>
           </a:xfrm>
           <a:prstGeom prst="rect">
             <a:avLst/>
@@ -3656,7 +4050,7 @@
                 <a:ea typeface="Garamond" pitchFamily="34" charset="-122"/>
                 <a:cs typeface="Garamond" pitchFamily="34" charset="-120"/>
               </a:rPr>
-              <a:t>Notes: Average marginal effect of a new baby (own child aged 0 in the household) on the probability that a woman leaves each profession, from profession-specific probits with age, age squared, marital status, education, and year effects; whiskers are 95 percent confidence intervals. Solid bars are significant at 5 percent; light bars are not. Samples pool 2010–2024. Source: author’s calculations from March CPS supplements.</a:t>
+              <a:t>Notes: Route-specific annual exit rates of college-graduate teachers by sector of the last-year job (class of worker: government vs. private), pooled 2015–2024, ASEC weights. A private-school teacher who moves to a public school—or vice versa—remains a teacher and is not a leaver here. Source: author’s calculations from March CPS supplements.</a:t>
             </a:r>
             <a:endParaRPr lang="en-US" sz="950" dirty="0"/>
           </a:p>
@@ -3727,7 +4121,7 @@
                 <a:ea typeface="Garamond" pitchFamily="34" charset="-122"/>
                 <a:cs typeface="Garamond" pitchFamily="34" charset="-120"/>
               </a:rPr>
-              <a:t>Figure 7. Labor Force Exit of Women Teachers, With and Without Young Children</a:t>
+              <a:t>Figure 6. The Effect of a New Baby on Leaving, by Profession</a:t>
             </a:r>
             <a:endParaRPr lang="en-US" sz="2100" dirty="0"/>
           </a:p>
@@ -3735,7 +4129,7 @@
       </p:sp>
       <p:pic>
         <p:nvPicPr>
-          <p:cNvPr id="3" name="Image 0" descr="figs_png/g9_mothers.png">    </p:cNvPr>
+          <p:cNvPr id="3" name="Image 0" descr="figs_png/g8_newbaby.png">    </p:cNvPr>
           <p:cNvPicPr>
             <a:picLocks noChangeAspect="1"/>
           </p:cNvPicPr>
@@ -3749,8 +4143,8 @@
         </p:blipFill>
         <p:spPr>
           <a:xfrm>
-            <a:off x="1385316" y="804672"/>
-            <a:ext cx="9418320" cy="4709160"/>
+            <a:off x="2024799" y="804672"/>
+            <a:ext cx="8139355" cy="4709160"/>
           </a:xfrm>
           <a:prstGeom prst="rect">
             <a:avLst/>
@@ -3790,7 +4184,7 @@
                 <a:ea typeface="Garamond" pitchFamily="34" charset="-122"/>
                 <a:cs typeface="Garamond" pitchFamily="34" charset="-120"/>
               </a:rPr>
-              <a:t>Notes: Women teachers aged 22–45, college graduates; annual probability of leaving the labor force (thin lines) and centered 3-year averages (bold), separately for those with and without an own child under 6 at home. Endpoint values printed. Source: author’s calculations from March CPS supplements, survey years 1998–2025.</a:t>
+              <a:t>Notes: Average marginal effect of a new baby (own child aged 0 in the household) on the probability that a woman leaves each profession, from profession-specific probits with age, age squared, marital status, education, and year effects; whiskers are 95 percent confidence intervals. Solid bars are significant at 5 percent; light bars are not. Samples pool 2010–2024. Source: author’s calculations from March CPS supplements.</a:t>
             </a:r>
             <a:endParaRPr lang="en-US" sz="950" dirty="0"/>
           </a:p>
@@ -3861,7 +4255,7 @@
                 <a:ea typeface="Garamond" pitchFamily="34" charset="-122"/>
                 <a:cs typeface="Garamond" pitchFamily="34" charset="-120"/>
               </a:rPr>
-              <a:t>Figure 8. Leaving Teaching and the Unemployment Rate, 1997–2024</a:t>
+              <a:t>Figure 7. Labor Force Exit of Women Teachers, With and Without Young Children</a:t>
             </a:r>
             <a:endParaRPr lang="en-US" sz="2100" dirty="0"/>
           </a:p>
@@ -3869,7 +4263,7 @@
       </p:sp>
       <p:pic>
         <p:nvPicPr>
-          <p:cNvPr id="3" name="Image 0" descr="figs_png/n5_cyclicality.png">    </p:cNvPr>
+          <p:cNvPr id="3" name="Image 0" descr="figs_png/g9_mothers.png">    </p:cNvPr>
           <p:cNvPicPr>
             <a:picLocks noChangeAspect="1"/>
           </p:cNvPicPr>
@@ -3883,8 +4277,8 @@
         </p:blipFill>
         <p:spPr>
           <a:xfrm>
-            <a:off x="470916" y="1072233"/>
-            <a:ext cx="11247120" cy="4174039"/>
+            <a:off x="1385316" y="804672"/>
+            <a:ext cx="9418320" cy="4709160"/>
           </a:xfrm>
           <a:prstGeom prst="rect">
             <a:avLst/>
@@ -3924,7 +4318,7 @@
                 <a:ea typeface="Garamond" pitchFamily="34" charset="-122"/>
                 <a:cs typeface="Garamond" pitchFamily="34" charset="-120"/>
               </a:rPr>
-              <a:t>Notes: Left: the leaving series (annual, from calendar 2000) against the BLS national unemployment rate (annual average). Right: binned scatter (deciles of the unemployment rate in the survey month, March of t+1, when the exit is observed) of the two labor-market routes, with OLS fits on the underlying annual data; correlations are −0.16 (to another job) and +0.29 (out of the labor force). Unemployment: BLS via FRED (UNRATE). Source: author’s calculations from March CPS supplements.</a:t>
+              <a:t>Notes: Women teachers aged 22–45, college graduates; annual probability of leaving the labor force (thin lines) and centered 3-year averages (bold), separately for those with and without an own child under 6 at home. Endpoint values printed. Source: author’s calculations from March CPS supplements, survey years 1998–2025.</a:t>
             </a:r>
             <a:endParaRPr lang="en-US" sz="950" dirty="0"/>
           </a:p>

</xml_diff>

<commit_message>
Slide deck: minimalist cover with affiliation, sparse data slide
Co-Authored-By: Claude Fable 5 <noreply@anthropic.com>
Claude-Session: https://claude.ai/code/session_01DNzQPDcr3zfLTraMHUHqUn
</commit_message>
<xml_diff>
--- a/report/teacher_attrition_figures.pptx
+++ b/report/teacher_attrition_figures.pptx
@@ -2129,8 +2129,8 @@
         </p:nvSpPr>
         <p:spPr>
           <a:xfrm>
-            <a:off x="731520" y="1965960"/>
-            <a:ext cx="10725912" cy="914400"/>
+            <a:off x="914400" y="2103120"/>
+            <a:ext cx="10360152" cy="777240"/>
           </a:xfrm>
           <a:prstGeom prst="rect">
             <a:avLst/>
@@ -2146,7 +2146,7 @@
               <a:buNone/>
             </a:pPr>
             <a:r>
-              <a:rPr lang="en-US" sz="4000" dirty="0">
+              <a:rPr lang="en-US" sz="3700" dirty="0">
                 <a:solidFill>
                   <a:srgbClr val="1A2430"/>
                 </a:solidFill>
@@ -2156,7 +2156,7 @@
               </a:rPr>
               <a:t>Who Leaves Teaching, and Why?</a:t>
             </a:r>
-            <a:endParaRPr lang="en-US" sz="4000" dirty="0"/>
+            <a:endParaRPr lang="en-US" sz="3700" dirty="0"/>
           </a:p>
         </p:txBody>
       </p:sp>
@@ -2168,8 +2168,8 @@
         </p:nvSpPr>
         <p:spPr>
           <a:xfrm>
-            <a:off x="731520" y="2971800"/>
-            <a:ext cx="10725912" cy="548640"/>
+            <a:off x="914400" y="2907792"/>
+            <a:ext cx="10360152" cy="457200"/>
           </a:xfrm>
           <a:prstGeom prst="rect">
             <a:avLst/>
@@ -2185,9 +2185,9 @@
               <a:buNone/>
             </a:pPr>
             <a:r>
-              <a:rPr lang="en-US" sz="2200" dirty="0">
+              <a:rPr lang="en-US" sz="1800" i="1" dirty="0">
                 <a:solidFill>
-                  <a:srgbClr val="1A2430"/>
+                  <a:srgbClr val="5A6572"/>
                 </a:solidFill>
                 <a:latin typeface="Garamond" pitchFamily="34" charset="0"/>
                 <a:ea typeface="Garamond" pitchFamily="34" charset="-122"/>
@@ -2195,7 +2195,7 @@
               </a:rPr>
               <a:t>The Anatomy of Teacher Attrition in the United States, 1997–2024</a:t>
             </a:r>
-            <a:endParaRPr lang="en-US" sz="2200" dirty="0"/>
+            <a:endParaRPr lang="en-US" sz="1800" dirty="0"/>
           </a:p>
         </p:txBody>
       </p:sp>
@@ -2207,8 +2207,8 @@
         </p:nvSpPr>
         <p:spPr>
           <a:xfrm>
-            <a:off x="731520" y="3977640"/>
-            <a:ext cx="10725912" cy="411480"/>
+            <a:off x="914400" y="4069080"/>
+            <a:ext cx="10360152" cy="365760"/>
           </a:xfrm>
           <a:prstGeom prst="rect">
             <a:avLst/>
@@ -2224,7 +2224,7 @@
               <a:buNone/>
             </a:pPr>
             <a:r>
-              <a:rPr lang="en-US" sz="1700" dirty="0">
+              <a:rPr lang="en-US" sz="1600" dirty="0">
                 <a:solidFill>
                   <a:srgbClr val="1A2430"/>
                 </a:solidFill>
@@ -2234,7 +2234,7 @@
               </a:rPr>
               <a:t>José Elías Durán Roa</a:t>
             </a:r>
-            <a:endParaRPr lang="en-US" sz="1700" dirty="0"/>
+            <a:endParaRPr lang="en-US" sz="1600" dirty="0"/>
           </a:p>
         </p:txBody>
       </p:sp>
@@ -2246,8 +2246,8 @@
         </p:nvSpPr>
         <p:spPr>
           <a:xfrm>
-            <a:off x="731520" y="4434840"/>
-            <a:ext cx="10725912" cy="365760"/>
+            <a:off x="914400" y="4462272"/>
+            <a:ext cx="10360152" cy="320040"/>
           </a:xfrm>
           <a:prstGeom prst="rect">
             <a:avLst/>
@@ -2263,7 +2263,46 @@
               <a:buNone/>
             </a:pPr>
             <a:r>
-              <a:rPr lang="en-US" sz="1300" dirty="0">
+              <a:rPr lang="en-US" sz="1250" dirty="0">
+                <a:solidFill>
+                  <a:srgbClr val="5A6572"/>
+                </a:solidFill>
+                <a:latin typeface="Garamond" pitchFamily="34" charset="0"/>
+                <a:ea typeface="Garamond" pitchFamily="34" charset="-122"/>
+                <a:cs typeface="Garamond" pitchFamily="34" charset="-120"/>
+              </a:rPr>
+              <a:t>University of Alicante · OECD Directorate for Education and Skills</a:t>
+            </a:r>
+            <a:endParaRPr lang="en-US" sz="1250" dirty="0"/>
+          </a:p>
+        </p:txBody>
+      </p:sp>
+      <p:sp>
+        <p:nvSpPr>
+          <p:cNvPr id="6" name="Text 4"/>
+          <p:cNvSpPr/>
+          <p:nvPr/>
+        </p:nvSpPr>
+        <p:spPr>
+          <a:xfrm>
+            <a:off x="914400" y="4892040"/>
+            <a:ext cx="10360152" cy="292608"/>
+          </a:xfrm>
+          <a:prstGeom prst="rect">
+            <a:avLst/>
+          </a:prstGeom>
+          <a:noFill/>
+          <a:ln/>
+        </p:spPr>
+        <p:txBody>
+          <a:bodyPr wrap="square" lIns="0" tIns="0" rIns="0" bIns="0" rtlCol="0" anchor="ctr"/>
+          <a:lstStyle/>
+          <a:p>
+            <a:pPr algn="ctr" indent="0" marL="0">
+              <a:buNone/>
+            </a:pPr>
+            <a:r>
+              <a:rPr lang="en-US" sz="1150" dirty="0">
                 <a:solidFill>
                   <a:srgbClr val="5A6572"/>
                 </a:solidFill>
@@ -2273,7 +2312,7 @@
               </a:rPr>
               <a:t>July 2026</a:t>
             </a:r>
-            <a:endParaRPr lang="en-US" sz="1300" dirty="0"/>
+            <a:endParaRPr lang="en-US" sz="1150" dirty="0"/>
           </a:p>
         </p:txBody>
       </p:sp>
@@ -3121,8 +3160,8 @@
         </p:nvSpPr>
         <p:spPr>
           <a:xfrm>
-            <a:off x="457200" y="320040"/>
-            <a:ext cx="11274552" cy="548640"/>
+            <a:off x="1051560" y="685800"/>
+            <a:ext cx="10058400" cy="502920"/>
           </a:xfrm>
           <a:prstGeom prst="rect">
             <a:avLst/>
@@ -3134,11 +3173,11 @@
           <a:bodyPr wrap="square" lIns="0" tIns="0" rIns="0" bIns="0" rtlCol="0" anchor="ctr"/>
           <a:lstStyle/>
           <a:p>
-            <a:pPr algn="ctr" indent="0" marL="0">
+            <a:pPr algn="l" indent="0" marL="0">
               <a:buNone/>
             </a:pPr>
             <a:r>
-              <a:rPr lang="en-US" sz="2600" dirty="0">
+              <a:rPr lang="en-US" sz="2400" dirty="0">
                 <a:solidFill>
                   <a:srgbClr val="1A2430"/>
                 </a:solidFill>
@@ -3148,7 +3187,7 @@
               </a:rPr>
               <a:t>Data</a:t>
             </a:r>
-            <a:endParaRPr lang="en-US" sz="2600" dirty="0"/>
+            <a:endParaRPr lang="en-US" sz="2400" dirty="0"/>
           </a:p>
         </p:txBody>
       </p:sp>
@@ -3160,8 +3199,8 @@
         </p:nvSpPr>
         <p:spPr>
           <a:xfrm>
-            <a:off x="1005840" y="1234440"/>
-            <a:ext cx="10177272" cy="384048"/>
+            <a:off x="1051560" y="1828800"/>
+            <a:ext cx="10058400" cy="868680"/>
           </a:xfrm>
           <a:prstGeom prst="rect">
             <a:avLst/>
@@ -3170,53 +3209,17 @@
           <a:ln/>
         </p:spPr>
         <p:txBody>
-          <a:bodyPr wrap="square" lIns="0" tIns="0" rIns="0" bIns="0" rtlCol="0" anchor="ctr"/>
+          <a:bodyPr wrap="square" lIns="0" tIns="0" rIns="0" bIns="0" rtlCol="0" anchor="t"/>
           <a:lstStyle/>
           <a:p>
             <a:pPr algn="l" indent="0" marL="0">
+              <a:lnSpc>
+                <a:spcPts val="2200"/>
+              </a:lnSpc>
               <a:buNone/>
             </a:pPr>
             <a:r>
-              <a:rPr lang="en-US" sz="1650" dirty="0">
-                <a:solidFill>
-                  <a:srgbClr val="2A5DB0"/>
-                </a:solidFill>
-                <a:latin typeface="Garamond" pitchFamily="34" charset="0"/>
-                <a:ea typeface="Garamond" pitchFamily="34" charset="-122"/>
-                <a:cs typeface="Garamond" pitchFamily="34" charset="-120"/>
-              </a:rPr>
-              <a:t>The question</a:t>
-            </a:r>
-            <a:endParaRPr lang="en-US" sz="1650" dirty="0"/>
-          </a:p>
-        </p:txBody>
-      </p:sp>
-      <p:sp>
-        <p:nvSpPr>
-          <p:cNvPr id="4" name="Text 2"/>
-          <p:cNvSpPr/>
-          <p:nvPr/>
-        </p:nvSpPr>
-        <p:spPr>
-          <a:xfrm>
-            <a:off x="1005840" y="1636776"/>
-            <a:ext cx="10177272" cy="1170432"/>
-          </a:xfrm>
-          <a:prstGeom prst="rect">
-            <a:avLst/>
-          </a:prstGeom>
-          <a:noFill/>
-          <a:ln/>
-        </p:spPr>
-        <p:txBody>
-          <a:bodyPr wrap="square" lIns="0" tIns="0" rIns="0" bIns="0" rtlCol="0" anchor="t"/>
-          <a:lstStyle/>
-          <a:p>
-            <a:pPr algn="just" indent="0" marL="0">
-              <a:buNone/>
-            </a:pPr>
-            <a:r>
-              <a:rPr lang="en-US" sz="1350" dirty="0">
+              <a:rPr lang="en-US" sz="1550" dirty="0">
                 <a:solidFill>
                   <a:srgbClr val="1A2430"/>
                 </a:solidFill>
@@ -3224,22 +3227,22 @@
                 <a:ea typeface="Garamond" pitchFamily="34" charset="-122"/>
                 <a:cs typeface="Garamond" pitchFamily="34" charset="-120"/>
               </a:rPr>
-              <a:t>One in six American teachers is said to leave every year. That number mixes teachers who change schools with teachers who leave the classroom for good. Everything that follows tracks only the second group, the one the word exodus refers to.</a:t>
-            </a:r>
-            <a:endParaRPr lang="en-US" sz="1350" dirty="0"/>
-          </a:p>
-        </p:txBody>
-      </p:sp>
-      <p:sp>
-        <p:nvSpPr>
-          <p:cNvPr id="5" name="Text 3"/>
+              <a:t>March supplement of the Current Population Survey, survey years 1998 to 2025.</a:t>
+            </a:r>
+            <a:endParaRPr lang="en-US" sz="1550" dirty="0"/>
+          </a:p>
+        </p:txBody>
+      </p:sp>
+      <p:sp>
+        <p:nvSpPr>
+          <p:cNvPr id="4" name="Text 2"/>
           <p:cNvSpPr/>
           <p:nvPr/>
         </p:nvSpPr>
         <p:spPr>
           <a:xfrm>
-            <a:off x="1005840" y="3017520"/>
-            <a:ext cx="10177272" cy="384048"/>
+            <a:off x="1051560" y="2514600"/>
+            <a:ext cx="10058400" cy="868680"/>
           </a:xfrm>
           <a:prstGeom prst="rect">
             <a:avLst/>
@@ -3248,53 +3251,17 @@
           <a:ln/>
         </p:spPr>
         <p:txBody>
-          <a:bodyPr wrap="square" lIns="0" tIns="0" rIns="0" bIns="0" rtlCol="0" anchor="ctr"/>
+          <a:bodyPr wrap="square" lIns="0" tIns="0" rIns="0" bIns="0" rtlCol="0" anchor="t"/>
           <a:lstStyle/>
           <a:p>
             <a:pPr algn="l" indent="0" marL="0">
+              <a:lnSpc>
+                <a:spcPts val="2200"/>
+              </a:lnSpc>
               <a:buNone/>
             </a:pPr>
             <a:r>
-              <a:rPr lang="en-US" sz="1650" dirty="0">
-                <a:solidFill>
-                  <a:srgbClr val="2A5DB0"/>
-                </a:solidFill>
-                <a:latin typeface="Garamond" pitchFamily="34" charset="0"/>
-                <a:ea typeface="Garamond" pitchFamily="34" charset="-122"/>
-                <a:cs typeface="Garamond" pitchFamily="34" charset="-120"/>
-              </a:rPr>
-              <a:t>The instrument</a:t>
-            </a:r>
-            <a:endParaRPr lang="en-US" sz="1650" dirty="0"/>
-          </a:p>
-        </p:txBody>
-      </p:sp>
-      <p:sp>
-        <p:nvSpPr>
-          <p:cNvPr id="6" name="Text 4"/>
-          <p:cNvSpPr/>
-          <p:nvPr/>
-        </p:nvSpPr>
-        <p:spPr>
-          <a:xfrm>
-            <a:off x="1005840" y="3419856"/>
-            <a:ext cx="10177272" cy="1170432"/>
-          </a:xfrm>
-          <a:prstGeom prst="rect">
-            <a:avLst/>
-          </a:prstGeom>
-          <a:noFill/>
-          <a:ln/>
-        </p:spPr>
-        <p:txBody>
-          <a:bodyPr wrap="square" lIns="0" tIns="0" rIns="0" bIns="0" rtlCol="0" anchor="t"/>
-          <a:lstStyle/>
-          <a:p>
-            <a:pPr algn="just" indent="0" marL="0">
-              <a:buNone/>
-            </a:pPr>
-            <a:r>
-              <a:rPr lang="en-US" sz="1350" dirty="0">
+              <a:rPr lang="en-US" sz="1550" dirty="0">
                 <a:solidFill>
                   <a:srgbClr val="1A2430"/>
                 </a:solidFill>
@@ -3302,22 +3269,22 @@
                 <a:ea typeface="Garamond" pitchFamily="34" charset="-122"/>
                 <a:cs typeface="Garamond" pitchFamily="34" charset="-120"/>
               </a:rPr>
-              <a:t>The March supplement of the Current Population Survey asks two questions of every household: the longest job held last calendar year, and the occupation this week. Whoever taught last year and no longer teaches this March has left the profession within fifteen months. The survey also records where they landed and what they earn.</a:t>
-            </a:r>
-            <a:endParaRPr lang="en-US" sz="1350" dirty="0"/>
-          </a:p>
-        </p:txBody>
-      </p:sp>
-      <p:sp>
-        <p:nvSpPr>
-          <p:cNvPr id="7" name="Text 5"/>
+              <a:t>One retrospective question: the longest job held last calendar year, compared with the occupation held this week. Whoever taught last year and no longer teaches this March has left the profession.</a:t>
+            </a:r>
+            <a:endParaRPr lang="en-US" sz="1550" dirty="0"/>
+          </a:p>
+        </p:txBody>
+      </p:sp>
+      <p:sp>
+        <p:nvSpPr>
+          <p:cNvPr id="5" name="Text 3"/>
           <p:cNvSpPr/>
           <p:nvPr/>
         </p:nvSpPr>
         <p:spPr>
           <a:xfrm>
-            <a:off x="1005840" y="4800600"/>
-            <a:ext cx="10177272" cy="384048"/>
+            <a:off x="1051560" y="3566160"/>
+            <a:ext cx="10058400" cy="868680"/>
           </a:xfrm>
           <a:prstGeom prst="rect">
             <a:avLst/>
@@ -3326,53 +3293,17 @@
           <a:ln/>
         </p:spPr>
         <p:txBody>
-          <a:bodyPr wrap="square" lIns="0" tIns="0" rIns="0" bIns="0" rtlCol="0" anchor="ctr"/>
+          <a:bodyPr wrap="square" lIns="0" tIns="0" rIns="0" bIns="0" rtlCol="0" anchor="t"/>
           <a:lstStyle/>
           <a:p>
             <a:pPr algn="l" indent="0" marL="0">
+              <a:lnSpc>
+                <a:spcPts val="2200"/>
+              </a:lnSpc>
               <a:buNone/>
             </a:pPr>
             <a:r>
-              <a:rPr lang="en-US" sz="1650" dirty="0">
-                <a:solidFill>
-                  <a:srgbClr val="2A5DB0"/>
-                </a:solidFill>
-                <a:latin typeface="Garamond" pitchFamily="34" charset="0"/>
-                <a:ea typeface="Garamond" pitchFamily="34" charset="-122"/>
-                <a:cs typeface="Garamond" pitchFamily="34" charset="-120"/>
-              </a:rPr>
-              <a:t>The database</a:t>
-            </a:r>
-            <a:endParaRPr lang="en-US" sz="1650" dirty="0"/>
-          </a:p>
-        </p:txBody>
-      </p:sp>
-      <p:sp>
-        <p:nvSpPr>
-          <p:cNvPr id="8" name="Text 6"/>
-          <p:cNvSpPr/>
-          <p:nvPr/>
-        </p:nvSpPr>
-        <p:spPr>
-          <a:xfrm>
-            <a:off x="1005840" y="5202936"/>
-            <a:ext cx="10177272" cy="1170432"/>
-          </a:xfrm>
-          <a:prstGeom prst="rect">
-            <a:avLst/>
-          </a:prstGeom>
-          <a:noFill/>
-          <a:ln/>
-        </p:spPr>
-        <p:txBody>
-          <a:bodyPr wrap="square" lIns="0" tIns="0" rIns="0" bIns="0" rtlCol="0" anchor="t"/>
-          <a:lstStyle/>
-          <a:p>
-            <a:pPr algn="just" indent="0" marL="0">
-              <a:buNone/>
-            </a:pPr>
-            <a:r>
-              <a:rPr lang="en-US" sz="1350" dirty="0">
+              <a:rPr lang="en-US" sz="1550" dirty="0">
                 <a:solidFill>
                   <a:srgbClr val="1A2430"/>
                 </a:solidFill>
@@ -3380,9 +3311,90 @@
                 <a:ea typeface="Garamond" pitchFamily="34" charset="-122"/>
                 <a:cs typeface="Garamond" pitchFamily="34" charset="-120"/>
               </a:rPr>
-              <a:t>All twenty-eight supplements, survey years 1998 to 2025, read from the raw Census files at their officially documented positions. 5,009,129 person-year records, 104,545 of them teacher-years, covering calendar years 1997 to 2024. All estimates use ASEC supplement weights. The 2026 supplement, which will add calendar 2025, is not yet public.</a:t>
-            </a:r>
-            <a:endParaRPr lang="en-US" sz="1350" dirty="0"/>
+              <a:t>5,009,129 person-year records, 104,545 of them teacher-years, covering calendar years 1997 to 2024.</a:t>
+            </a:r>
+            <a:endParaRPr lang="en-US" sz="1550" dirty="0"/>
+          </a:p>
+        </p:txBody>
+      </p:sp>
+      <p:sp>
+        <p:nvSpPr>
+          <p:cNvPr id="6" name="Text 4"/>
+          <p:cNvSpPr/>
+          <p:nvPr/>
+        </p:nvSpPr>
+        <p:spPr>
+          <a:xfrm>
+            <a:off x="1051560" y="4251960"/>
+            <a:ext cx="10058400" cy="868680"/>
+          </a:xfrm>
+          <a:prstGeom prst="rect">
+            <a:avLst/>
+          </a:prstGeom>
+          <a:noFill/>
+          <a:ln/>
+        </p:spPr>
+        <p:txBody>
+          <a:bodyPr wrap="square" lIns="0" tIns="0" rIns="0" bIns="0" rtlCol="0" anchor="t"/>
+          <a:lstStyle/>
+          <a:p>
+            <a:pPr algn="l" indent="0" marL="0">
+              <a:lnSpc>
+                <a:spcPts val="2200"/>
+              </a:lnSpc>
+              <a:buNone/>
+            </a:pPr>
+            <a:r>
+              <a:rPr lang="en-US" sz="1550" dirty="0">
+                <a:solidFill>
+                  <a:srgbClr val="1A2430"/>
+                </a:solidFill>
+                <a:latin typeface="Garamond" pitchFamily="34" charset="0"/>
+                <a:ea typeface="Garamond" pitchFamily="34" charset="-122"/>
+                <a:cs typeface="Garamond" pitchFamily="34" charset="-120"/>
+              </a:rPr>
+              <a:t>Read from the raw Census files at their officially documented record positions. All estimates use ASEC supplement weights.</a:t>
+            </a:r>
+            <a:endParaRPr lang="en-US" sz="1550" dirty="0"/>
+          </a:p>
+        </p:txBody>
+      </p:sp>
+      <p:sp>
+        <p:nvSpPr>
+          <p:cNvPr id="7" name="Text 5"/>
+          <p:cNvSpPr/>
+          <p:nvPr/>
+        </p:nvSpPr>
+        <p:spPr>
+          <a:xfrm>
+            <a:off x="1051560" y="5989320"/>
+            <a:ext cx="10058400" cy="320040"/>
+          </a:xfrm>
+          <a:prstGeom prst="rect">
+            <a:avLst/>
+          </a:prstGeom>
+          <a:noFill/>
+          <a:ln/>
+        </p:spPr>
+        <p:txBody>
+          <a:bodyPr wrap="square" lIns="0" tIns="0" rIns="0" bIns="0" rtlCol="0" anchor="ctr"/>
+          <a:lstStyle/>
+          <a:p>
+            <a:pPr algn="l" indent="0" marL="0">
+              <a:buNone/>
+            </a:pPr>
+            <a:r>
+              <a:rPr lang="en-US" sz="1150" i="1" dirty="0">
+                <a:solidFill>
+                  <a:srgbClr val="5A6572"/>
+                </a:solidFill>
+                <a:latin typeface="Garamond" pitchFamily="34" charset="0"/>
+                <a:ea typeface="Garamond" pitchFamily="34" charset="-122"/>
+                <a:cs typeface="Garamond" pitchFamily="34" charset="-120"/>
+              </a:rPr>
+              <a:t>The March 2026 supplement, covering calendar 2025, is not yet public.</a:t>
+            </a:r>
+            <a:endParaRPr lang="en-US" sz="1150" dirty="0"/>
           </a:p>
         </p:txBody>
       </p:sp>

</xml_diff>

<commit_message>
Slide deck: economics-workshop cover and frame styling
Co-Authored-By: Claude Fable 5 <noreply@anthropic.com>
Claude-Session: https://claude.ai/code/session_01DNzQPDcr3zfLTraMHUHqUn
</commit_message>
<xml_diff>
--- a/report/teacher_attrition_figures.pptx
+++ b/report/teacher_attrition_figures.pptx
@@ -2129,8 +2129,8 @@
         </p:nvSpPr>
         <p:spPr>
           <a:xfrm>
-            <a:off x="914400" y="2103120"/>
-            <a:ext cx="10360152" cy="777240"/>
+            <a:off x="1143000" y="2148840"/>
+            <a:ext cx="9875520" cy="731520"/>
           </a:xfrm>
           <a:prstGeom prst="rect">
             <a:avLst/>
@@ -2142,11 +2142,11 @@
           <a:bodyPr wrap="square" lIns="0" tIns="0" rIns="0" bIns="0" rtlCol="0" anchor="ctr"/>
           <a:lstStyle/>
           <a:p>
-            <a:pPr algn="ctr" indent="0" marL="0">
+            <a:pPr algn="l" indent="0" marL="0">
               <a:buNone/>
             </a:pPr>
             <a:r>
-              <a:rPr lang="en-US" sz="3700" dirty="0">
+              <a:rPr lang="en-US" sz="3400" dirty="0">
                 <a:solidFill>
                   <a:srgbClr val="1A2430"/>
                 </a:solidFill>
@@ -2156,7 +2156,7 @@
               </a:rPr>
               <a:t>Who Leaves Teaching, and Why?</a:t>
             </a:r>
-            <a:endParaRPr lang="en-US" sz="3700" dirty="0"/>
+            <a:endParaRPr lang="en-US" sz="3400" dirty="0"/>
           </a:p>
         </p:txBody>
       </p:sp>
@@ -2168,8 +2168,8 @@
         </p:nvSpPr>
         <p:spPr>
           <a:xfrm>
-            <a:off x="914400" y="2907792"/>
-            <a:ext cx="10360152" cy="457200"/>
+            <a:off x="1143000" y="2880360"/>
+            <a:ext cx="9875520" cy="411480"/>
           </a:xfrm>
           <a:prstGeom prst="rect">
             <a:avLst/>
@@ -2181,11 +2181,11 @@
           <a:bodyPr wrap="square" lIns="0" tIns="0" rIns="0" bIns="0" rtlCol="0" anchor="ctr"/>
           <a:lstStyle/>
           <a:p>
-            <a:pPr algn="ctr" indent="0" marL="0">
+            <a:pPr algn="l" indent="0" marL="0">
               <a:buNone/>
             </a:pPr>
             <a:r>
-              <a:rPr lang="en-US" sz="1800" i="1" dirty="0">
+              <a:rPr lang="en-US" sz="1700" i="1" dirty="0">
                 <a:solidFill>
                   <a:srgbClr val="5A6572"/>
                 </a:solidFill>
@@ -2195,20 +2195,43 @@
               </a:rPr>
               <a:t>The Anatomy of Teacher Attrition in the United States, 1997–2024</a:t>
             </a:r>
-            <a:endParaRPr lang="en-US" sz="1800" dirty="0"/>
-          </a:p>
-        </p:txBody>
-      </p:sp>
-      <p:sp>
-        <p:nvSpPr>
-          <p:cNvPr id="4" name="Text 2"/>
+            <a:endParaRPr lang="en-US" sz="1700" dirty="0"/>
+          </a:p>
+        </p:txBody>
+      </p:sp>
+      <p:sp>
+        <p:nvSpPr>
+          <p:cNvPr id="4" name="Shape 2"/>
           <p:cNvSpPr/>
           <p:nvPr/>
         </p:nvSpPr>
         <p:spPr>
           <a:xfrm>
-            <a:off x="914400" y="4069080"/>
-            <a:ext cx="10360152" cy="365760"/>
+            <a:off x="1143000" y="3611880"/>
+            <a:ext cx="1920240" cy="0"/>
+          </a:xfrm>
+          <a:prstGeom prst="line">
+            <a:avLst/>
+          </a:prstGeom>
+          <a:noFill/>
+          <a:ln w="19050">
+            <a:solidFill>
+              <a:srgbClr val="2A5DB0"/>
+            </a:solidFill>
+            <a:prstDash val="solid"/>
+          </a:ln>
+        </p:spPr>
+      </p:sp>
+      <p:sp>
+        <p:nvSpPr>
+          <p:cNvPr id="5" name="Text 3"/>
+          <p:cNvSpPr/>
+          <p:nvPr/>
+        </p:nvSpPr>
+        <p:spPr>
+          <a:xfrm>
+            <a:off x="1143000" y="3977640"/>
+            <a:ext cx="9875520" cy="347472"/>
           </a:xfrm>
           <a:prstGeom prst="rect">
             <a:avLst/>
@@ -2220,11 +2243,11 @@
           <a:bodyPr wrap="square" lIns="0" tIns="0" rIns="0" bIns="0" rtlCol="0" anchor="ctr"/>
           <a:lstStyle/>
           <a:p>
-            <a:pPr algn="ctr" indent="0" marL="0">
+            <a:pPr algn="l" indent="0" marL="0">
               <a:buNone/>
             </a:pPr>
             <a:r>
-              <a:rPr lang="en-US" sz="1600" dirty="0">
+              <a:rPr lang="en-US" sz="1500" dirty="0">
                 <a:solidFill>
                   <a:srgbClr val="1A2430"/>
                 </a:solidFill>
@@ -2234,20 +2257,20 @@
               </a:rPr>
               <a:t>José Elías Durán Roa</a:t>
             </a:r>
-            <a:endParaRPr lang="en-US" sz="1600" dirty="0"/>
-          </a:p>
-        </p:txBody>
-      </p:sp>
-      <p:sp>
-        <p:nvSpPr>
-          <p:cNvPr id="5" name="Text 3"/>
+            <a:endParaRPr lang="en-US" sz="1500" dirty="0"/>
+          </a:p>
+        </p:txBody>
+      </p:sp>
+      <p:sp>
+        <p:nvSpPr>
+          <p:cNvPr id="6" name="Text 4"/>
           <p:cNvSpPr/>
           <p:nvPr/>
         </p:nvSpPr>
         <p:spPr>
           <a:xfrm>
-            <a:off x="914400" y="4462272"/>
-            <a:ext cx="10360152" cy="320040"/>
+            <a:off x="1143000" y="4334256"/>
+            <a:ext cx="9875520" cy="301752"/>
           </a:xfrm>
           <a:prstGeom prst="rect">
             <a:avLst/>
@@ -2259,11 +2282,11 @@
           <a:bodyPr wrap="square" lIns="0" tIns="0" rIns="0" bIns="0" rtlCol="0" anchor="ctr"/>
           <a:lstStyle/>
           <a:p>
-            <a:pPr algn="ctr" indent="0" marL="0">
+            <a:pPr algn="l" indent="0" marL="0">
               <a:buNone/>
             </a:pPr>
             <a:r>
-              <a:rPr lang="en-US" sz="1250" dirty="0">
+              <a:rPr lang="en-US" sz="1200" dirty="0">
                 <a:solidFill>
                   <a:srgbClr val="5A6572"/>
                 </a:solidFill>
@@ -2273,20 +2296,20 @@
               </a:rPr>
               <a:t>University of Alicante · OECD Directorate for Education and Skills</a:t>
             </a:r>
-            <a:endParaRPr lang="en-US" sz="1250" dirty="0"/>
-          </a:p>
-        </p:txBody>
-      </p:sp>
-      <p:sp>
-        <p:nvSpPr>
-          <p:cNvPr id="6" name="Text 4"/>
+            <a:endParaRPr lang="en-US" sz="1200" dirty="0"/>
+          </a:p>
+        </p:txBody>
+      </p:sp>
+      <p:sp>
+        <p:nvSpPr>
+          <p:cNvPr id="7" name="Text 5"/>
           <p:cNvSpPr/>
           <p:nvPr/>
         </p:nvSpPr>
         <p:spPr>
           <a:xfrm>
-            <a:off x="914400" y="4892040"/>
-            <a:ext cx="10360152" cy="292608"/>
+            <a:off x="1143000" y="4800600"/>
+            <a:ext cx="9875520" cy="274320"/>
           </a:xfrm>
           <a:prstGeom prst="rect">
             <a:avLst/>
@@ -2298,11 +2321,11 @@
           <a:bodyPr wrap="square" lIns="0" tIns="0" rIns="0" bIns="0" rtlCol="0" anchor="ctr"/>
           <a:lstStyle/>
           <a:p>
-            <a:pPr algn="ctr" indent="0" marL="0">
+            <a:pPr algn="l" indent="0" marL="0">
               <a:buNone/>
             </a:pPr>
             <a:r>
-              <a:rPr lang="en-US" sz="1150" dirty="0">
+              <a:rPr lang="en-US" sz="1100" dirty="0">
                 <a:solidFill>
                   <a:srgbClr val="5A6572"/>
                 </a:solidFill>
@@ -2312,7 +2335,7 @@
               </a:rPr>
               <a:t>July 2026</a:t>
             </a:r>
-            <a:endParaRPr lang="en-US" sz="1150" dirty="0"/>
+            <a:endParaRPr lang="en-US" sz="1100" dirty="0"/>
           </a:p>
         </p:txBody>
       </p:sp>
@@ -3160,8 +3183,8 @@
         </p:nvSpPr>
         <p:spPr>
           <a:xfrm>
-            <a:off x="1051560" y="685800"/>
-            <a:ext cx="10058400" cy="502920"/>
+            <a:off x="1143000" y="640080"/>
+            <a:ext cx="9875520" cy="502920"/>
           </a:xfrm>
           <a:prstGeom prst="rect">
             <a:avLst/>
@@ -3193,14 +3216,37 @@
       </p:sp>
       <p:sp>
         <p:nvSpPr>
-          <p:cNvPr id="3" name="Text 1"/>
+          <p:cNvPr id="3" name="Shape 1"/>
           <p:cNvSpPr/>
           <p:nvPr/>
         </p:nvSpPr>
         <p:spPr>
           <a:xfrm>
-            <a:off x="1051560" y="1828800"/>
-            <a:ext cx="10058400" cy="868680"/>
+            <a:off x="1143000" y="1261872"/>
+            <a:ext cx="9902952" cy="0"/>
+          </a:xfrm>
+          <a:prstGeom prst="line">
+            <a:avLst/>
+          </a:prstGeom>
+          <a:noFill/>
+          <a:ln w="9525">
+            <a:solidFill>
+              <a:srgbClr val="D8DBDE"/>
+            </a:solidFill>
+            <a:prstDash val="solid"/>
+          </a:ln>
+        </p:spPr>
+      </p:sp>
+      <p:sp>
+        <p:nvSpPr>
+          <p:cNvPr id="4" name="Text 2"/>
+          <p:cNvSpPr/>
+          <p:nvPr/>
+        </p:nvSpPr>
+        <p:spPr>
+          <a:xfrm>
+            <a:off x="1143000" y="1874520"/>
+            <a:ext cx="9902952" cy="868680"/>
           </a:xfrm>
           <a:prstGeom prst="rect">
             <a:avLst/>
@@ -3235,14 +3281,14 @@
       </p:sp>
       <p:sp>
         <p:nvSpPr>
-          <p:cNvPr id="4" name="Text 2"/>
+          <p:cNvPr id="5" name="Text 3"/>
           <p:cNvSpPr/>
           <p:nvPr/>
         </p:nvSpPr>
         <p:spPr>
           <a:xfrm>
-            <a:off x="1051560" y="2514600"/>
-            <a:ext cx="10058400" cy="868680"/>
+            <a:off x="1143000" y="2532888"/>
+            <a:ext cx="9902952" cy="868680"/>
           </a:xfrm>
           <a:prstGeom prst="rect">
             <a:avLst/>
@@ -3277,14 +3323,14 @@
       </p:sp>
       <p:sp>
         <p:nvSpPr>
-          <p:cNvPr id="5" name="Text 3"/>
+          <p:cNvPr id="6" name="Text 4"/>
           <p:cNvSpPr/>
           <p:nvPr/>
         </p:nvSpPr>
         <p:spPr>
           <a:xfrm>
-            <a:off x="1051560" y="3566160"/>
-            <a:ext cx="10058400" cy="868680"/>
+            <a:off x="1143000" y="3557016"/>
+            <a:ext cx="9902952" cy="868680"/>
           </a:xfrm>
           <a:prstGeom prst="rect">
             <a:avLst/>
@@ -3311,7 +3357,7 @@
                 <a:ea typeface="Garamond" pitchFamily="34" charset="-122"/>
                 <a:cs typeface="Garamond" pitchFamily="34" charset="-120"/>
               </a:rPr>
-              <a:t>5,009,129 person-year records, 104,545 of them teacher-years, covering calendar years 1997 to 2024.</a:t>
+              <a:t>The pooled file holds 5,009,129 person-year records, 104,545 of them teacher-years, covering calendar years 1997 to 2024.</a:t>
             </a:r>
             <a:endParaRPr lang="en-US" sz="1550" dirty="0"/>
           </a:p>
@@ -3319,14 +3365,14 @@
       </p:sp>
       <p:sp>
         <p:nvSpPr>
-          <p:cNvPr id="6" name="Text 4"/>
+          <p:cNvPr id="7" name="Text 5"/>
           <p:cNvSpPr/>
           <p:nvPr/>
         </p:nvSpPr>
         <p:spPr>
           <a:xfrm>
-            <a:off x="1051560" y="4251960"/>
-            <a:ext cx="10058400" cy="868680"/>
+            <a:off x="1143000" y="4581144"/>
+            <a:ext cx="9902952" cy="868680"/>
           </a:xfrm>
           <a:prstGeom prst="rect">
             <a:avLst/>
@@ -3353,7 +3399,7 @@
                 <a:ea typeface="Garamond" pitchFamily="34" charset="-122"/>
                 <a:cs typeface="Garamond" pitchFamily="34" charset="-120"/>
               </a:rPr>
-              <a:t>Read from the raw Census files at their officially documented record positions. All estimates use ASEC supplement weights.</a:t>
+              <a:t>Every variable is read from the raw Census files at its officially documented position. All estimates use ASEC supplement weights.</a:t>
             </a:r>
             <a:endParaRPr lang="en-US" sz="1550" dirty="0"/>
           </a:p>
@@ -3361,14 +3407,14 @@
       </p:sp>
       <p:sp>
         <p:nvSpPr>
-          <p:cNvPr id="7" name="Text 5"/>
+          <p:cNvPr id="8" name="Text 6"/>
           <p:cNvSpPr/>
           <p:nvPr/>
         </p:nvSpPr>
         <p:spPr>
           <a:xfrm>
-            <a:off x="1051560" y="5989320"/>
-            <a:ext cx="10058400" cy="320040"/>
+            <a:off x="1143000" y="6035040"/>
+            <a:ext cx="9902952" cy="292608"/>
           </a:xfrm>
           <a:prstGeom prst="rect">
             <a:avLst/>

</xml_diff>

<commit_message>
Slide deck: plain academic title page, centered, no decoration
Co-Authored-By: Claude Fable 5 <noreply@anthropic.com>
Claude-Session: https://claude.ai/code/session_01DNzQPDcr3zfLTraMHUHqUn
</commit_message>
<xml_diff>
--- a/report/teacher_attrition_figures.pptx
+++ b/report/teacher_attrition_figures.pptx
@@ -2129,8 +2129,8 @@
         </p:nvSpPr>
         <p:spPr>
           <a:xfrm>
-            <a:off x="914400" y="1600200"/>
-            <a:ext cx="9692640" cy="1143000"/>
+            <a:off x="1280160" y="2148840"/>
+            <a:ext cx="9628632" cy="731520"/>
           </a:xfrm>
           <a:prstGeom prst="rect">
             <a:avLst/>
@@ -2142,13 +2142,13 @@
           <a:bodyPr wrap="square" lIns="0" tIns="0" rIns="0" bIns="0" rtlCol="0" anchor="ctr"/>
           <a:lstStyle/>
           <a:p>
-            <a:pPr algn="l" indent="0" marL="0">
+            <a:pPr algn="ctr" indent="0" marL="0">
               <a:buNone/>
             </a:pPr>
             <a:r>
-              <a:rPr lang="en-US" sz="3300" b="1" dirty="0">
+              <a:rPr lang="en-US" sz="3000" b="1" dirty="0">
                 <a:solidFill>
-                  <a:srgbClr val="1F3B66"/>
+                  <a:srgbClr val="26456E"/>
                 </a:solidFill>
                 <a:latin typeface="Garamond" pitchFamily="34" charset="0"/>
                 <a:ea typeface="Garamond" pitchFamily="34" charset="-122"/>
@@ -2156,7 +2156,7 @@
               </a:rPr>
               <a:t>Who Leaves Teaching, and Why?</a:t>
             </a:r>
-            <a:endParaRPr lang="en-US" sz="3300" dirty="0"/>
+            <a:endParaRPr lang="en-US" sz="3000" dirty="0"/>
           </a:p>
         </p:txBody>
       </p:sp>
@@ -2168,8 +2168,8 @@
         </p:nvSpPr>
         <p:spPr>
           <a:xfrm>
-            <a:off x="914400" y="2743200"/>
-            <a:ext cx="9692640" cy="457200"/>
+            <a:off x="1280160" y="2907792"/>
+            <a:ext cx="9628632" cy="457200"/>
           </a:xfrm>
           <a:prstGeom prst="rect">
             <a:avLst/>
@@ -2181,13 +2181,13 @@
           <a:bodyPr wrap="square" lIns="0" tIns="0" rIns="0" bIns="0" rtlCol="0" anchor="ctr"/>
           <a:lstStyle/>
           <a:p>
-            <a:pPr algn="l" indent="0" marL="0">
+            <a:pPr algn="ctr" indent="0" marL="0">
               <a:buNone/>
             </a:pPr>
             <a:r>
-              <a:rPr lang="en-US" sz="1750" dirty="0">
+              <a:rPr lang="en-US" sz="1650" dirty="0">
                 <a:solidFill>
-                  <a:srgbClr val="1F3B66"/>
+                  <a:srgbClr val="1A2430"/>
                 </a:solidFill>
                 <a:latin typeface="Garamond" pitchFamily="34" charset="0"/>
                 <a:ea typeface="Garamond" pitchFamily="34" charset="-122"/>
@@ -2195,7 +2195,7 @@
               </a:rPr>
               <a:t>The Anatomy of Teacher Attrition in the United States, 1997–2024</a:t>
             </a:r>
-            <a:endParaRPr lang="en-US" sz="1750" dirty="0"/>
+            <a:endParaRPr lang="en-US" sz="1650" dirty="0"/>
           </a:p>
         </p:txBody>
       </p:sp>
@@ -2207,8 +2207,8 @@
         </p:nvSpPr>
         <p:spPr>
           <a:xfrm>
-            <a:off x="914400" y="3611880"/>
-            <a:ext cx="9692640" cy="365760"/>
+            <a:off x="1280160" y="4114800"/>
+            <a:ext cx="9628632" cy="384048"/>
           </a:xfrm>
           <a:prstGeom prst="rect">
             <a:avLst/>
@@ -2220,13 +2220,13 @@
           <a:bodyPr wrap="square" lIns="0" tIns="0" rIns="0" bIns="0" rtlCol="0" anchor="ctr"/>
           <a:lstStyle/>
           <a:p>
-            <a:pPr algn="l" indent="0" marL="0">
+            <a:pPr algn="ctr" indent="0" marL="0">
               <a:buNone/>
             </a:pPr>
             <a:r>
-              <a:rPr lang="en-US" sz="1550" dirty="0">
+              <a:rPr lang="en-US" sz="1600" dirty="0">
                 <a:solidFill>
-                  <a:srgbClr val="2B2F33"/>
+                  <a:srgbClr val="1A2430"/>
                 </a:solidFill>
                 <a:latin typeface="Garamond" pitchFamily="34" charset="0"/>
                 <a:ea typeface="Garamond" pitchFamily="34" charset="-122"/>
@@ -2234,7 +2234,7 @@
               </a:rPr>
               <a:t>José Elías Durán Roa</a:t>
             </a:r>
-            <a:endParaRPr lang="en-US" sz="1550" dirty="0"/>
+            <a:endParaRPr lang="en-US" sz="1600" dirty="0"/>
           </a:p>
         </p:txBody>
       </p:sp>
@@ -2246,8 +2246,8 @@
         </p:nvSpPr>
         <p:spPr>
           <a:xfrm>
-            <a:off x="914400" y="3986784"/>
-            <a:ext cx="9692640" cy="320040"/>
+            <a:off x="1280160" y="4517136"/>
+            <a:ext cx="9628632" cy="329184"/>
           </a:xfrm>
           <a:prstGeom prst="rect">
             <a:avLst/>
@@ -2259,19 +2259,19 @@
           <a:bodyPr wrap="square" lIns="0" tIns="0" rIns="0" bIns="0" rtlCol="0" anchor="ctr"/>
           <a:lstStyle/>
           <a:p>
-            <a:pPr algn="l" indent="0" marL="0">
+            <a:pPr algn="ctr" indent="0" marL="0">
               <a:buNone/>
             </a:pPr>
             <a:r>
-              <a:rPr lang="en-US" sz="1250" dirty="0">
+              <a:rPr lang="en-US" sz="1250" i="1" dirty="0">
                 <a:solidFill>
-                  <a:srgbClr val="6A7076"/>
+                  <a:srgbClr val="5A6572"/>
                 </a:solidFill>
                 <a:latin typeface="Garamond" pitchFamily="34" charset="0"/>
                 <a:ea typeface="Garamond" pitchFamily="34" charset="-122"/>
                 <a:cs typeface="Garamond" pitchFamily="34" charset="-120"/>
               </a:rPr>
-              <a:t>University of Alicante · OECD Directorate for Education and Skills</a:t>
+              <a:t>University of Alicante and OECD</a:t>
             </a:r>
             <a:endParaRPr lang="en-US" sz="1250" dirty="0"/>
           </a:p>
@@ -2285,8 +2285,8 @@
         </p:nvSpPr>
         <p:spPr>
           <a:xfrm>
-            <a:off x="914400" y="5989320"/>
-            <a:ext cx="4572000" cy="320040"/>
+            <a:off x="1280160" y="5257800"/>
+            <a:ext cx="9628632" cy="310896"/>
           </a:xfrm>
           <a:prstGeom prst="rect">
             <a:avLst/>
@@ -2298,13 +2298,13 @@
           <a:bodyPr wrap="square" lIns="0" tIns="0" rIns="0" bIns="0" rtlCol="0" anchor="ctr"/>
           <a:lstStyle/>
           <a:p>
-            <a:pPr algn="l" indent="0" marL="0">
+            <a:pPr algn="ctr" indent="0" marL="0">
               <a:buNone/>
             </a:pPr>
             <a:r>
               <a:rPr lang="en-US" sz="1200" dirty="0">
                 <a:solidFill>
-                  <a:srgbClr val="6A7076"/>
+                  <a:srgbClr val="5A6572"/>
                 </a:solidFill>
                 <a:latin typeface="Garamond" pitchFamily="34" charset="0"/>
                 <a:ea typeface="Garamond" pitchFamily="34" charset="-122"/>
@@ -2315,26 +2315,6 @@
             <a:endParaRPr lang="en-US" sz="1200" dirty="0"/>
           </a:p>
         </p:txBody>
-      </p:sp>
-      <p:sp>
-        <p:nvSpPr>
-          <p:cNvPr id="7" name="Shape 5"/>
-          <p:cNvSpPr/>
-          <p:nvPr/>
-        </p:nvSpPr>
-        <p:spPr>
-          <a:xfrm>
-            <a:off x="0" y="6620256"/>
-            <a:ext cx="12188952" cy="237744"/>
-          </a:xfrm>
-          <a:prstGeom prst="rect">
-            <a:avLst/>
-          </a:prstGeom>
-          <a:solidFill>
-            <a:srgbClr val="1F3B66"/>
-          </a:solidFill>
-          <a:ln/>
-        </p:spPr>
       </p:sp>
     </p:spTree>
   </p:cSld>

</xml_diff>

<commit_message>
Figures-and-appendix companion PDF; motivation slide in the deck
The companion PDF collects the thirteen main figures, the five
appendix figures, and the seven appendix tables with their notes, one
exhibit per page. The deck gains a motivation slide before the data
slide, positioning the work relative to Harris and Adams (2007),
Aldeman and Yi (2025), and the NCES Teacher Follow-up Survey.

Co-Authored-By: Claude Fable 5 <noreply@anthropic.com>
Claude-Session: https://claude.ai/code/session_01DNzQPDcr3zfLTraMHUHqUn
</commit_message>
<xml_diff>
--- a/report/teacher_attrition_figures.pptx
+++ b/report/teacher_attrition_figures.pptx
@@ -20,9 +20,10 @@
     <p:sldId id="268" r:id="rId14"/>
     <p:sldId id="269" r:id="rId15"/>
     <p:sldId id="270" r:id="rId16"/>
+    <p:sldId id="271" r:id="rId17"/>
   </p:sldIdLst>
   <p:notesMasterIdLst>
-    <p:notesMasterId r:id="rId17"/>
+    <p:notesMasterId r:id="rId18"/>
   </p:notesMasterIdLst>
   <p:sldSz cx="12192000" cy="6858000"/>
   <p:notesSz cx="6858000" cy="12192000"/>
@@ -604,7 +605,7 @@
           <a:p>
             <a:r>
               <a:rPr lang="en-US" dirty="0"/>
-              <a:t>Booms do not poach teachers. Where exits respond to the cycle at all, recessions push them out. The poaching story has no support in the data.</a:t>
+              <a:t>The classic exit to home is disappearing. The gap between mothers and other young women teachers went from seven points to under two in twenty-five years.</a:t>
             </a:r>
             <a:endParaRPr lang="en-US" dirty="0"/>
           </a:p>
@@ -692,7 +693,7 @@
           <a:p>
             <a:r>
               <a:rPr lang="en-US" dirty="0"/>
-              <a:t>Fifty-one regressions, three significant slopes. Mississippi and Pennsylvania say recessions push exits up, New Jersey says the opposite, and the large states are precise zeros. No systematic poaching anywhere.</a:t>
+              <a:t>Booms do not poach teachers. Where exits respond to the cycle at all, recessions push them out. The poaching story has no support in the data.</a:t>
             </a:r>
             <a:endParaRPr lang="en-US" dirty="0"/>
           </a:p>
@@ -780,7 +781,7 @@
           <a:p>
             <a:r>
               <a:rPr lang="en-US" dirty="0"/>
-              <a:t>Switching pays a median of 15 log points, with enormous tails. A quarter lose big, and 47 percent of all leavers earn nothing at all. Leaving is a gamble, and teachers act accordingly.</a:t>
+              <a:t>Fifty-one regressions, three significant slopes. Mississippi and Pennsylvania say recessions push exits up, New Jersey says the opposite, and the large states are precise zeros. No systematic poaching anywhere.</a:t>
             </a:r>
             <a:endParaRPr lang="en-US" dirty="0"/>
           </a:p>
@@ -868,7 +869,7 @@
           <a:p>
             <a:r>
               <a:rPr lang="en-US" dirty="0"/>
-              <a:t>Teacher real pay slipped from 68,000 to 66,000 dollars while the college median rose to 90,000. The penalty now stands at 28 percent.</a:t>
+              <a:t>Switching pays a median of 15 log points, with enormous tails. A quarter lose big, and 47 percent of all leavers earn nothing at all. Leaving is a gamble, and teachers act accordingly.</a:t>
             </a:r>
             <a:endParaRPr lang="en-US" dirty="0"/>
           </a:p>
@@ -956,7 +957,7 @@
           <a:p>
             <a:r>
               <a:rPr lang="en-US" dirty="0"/>
-              <a:t>The contract predicts exit, the person barely does. Full-year work, hours and pension coverage dwarf every demographic. The one personal event that matters is a birth.</a:t>
+              <a:t>Teacher real pay slipped from 68,000 to 66,000 dollars while the college median rose to 90,000. The penalty now stands at 28 percent.</a:t>
             </a:r>
             <a:endParaRPr lang="en-US" dirty="0"/>
           </a:p>
@@ -1044,7 +1045,7 @@
           <a:p>
             <a:r>
               <a:rPr lang="en-US" dirty="0"/>
-              <a:t>Teaching and accounting are the only professions here whose attrition fell across decades. Every health and social profession rose. Whatever pushes pharmacists and therapists up is economy wide, not a crisis of schools.</a:t>
+              <a:t>The contract predicts exit, the person barely does. Full-year work, hours and pension coverage dwarf every demographic. The one personal event that matters is a birth.</a:t>
             </a:r>
             <a:endParaRPr lang="en-US" dirty="0"/>
           </a:p>
@@ -1068,6 +1069,94 @@
             <a:fld id="{F7021451-1387-4CA6-816F-3879F97B5CBC}" type="slidenum">
               <a:rPr lang="en-US"/>
               <a:t>15</a:t>
+            </a:fld>
+            <a:endParaRPr lang="en-US"/>
+          </a:p>
+        </p:txBody>
+      </p:sp>
+    </p:spTree>
+    <p:extLst>
+      <p:ext uri="{BB962C8B-B14F-4D97-AF65-F5344CB8AC3E}">
+        <p14:creationId xmlns:p14="http://schemas.microsoft.com/office/powerpoint/2010/main" val="1024086991"/>
+      </p:ext>
+    </p:extLst>
+  </p:cSld>
+  <p:clrMapOvr>
+    <a:masterClrMapping/>
+  </p:clrMapOvr>
+</p:notes>
+</file>
+
+<file path=ppt/notesSlides/notesSlide16.xml><?xml version="1.0" encoding="utf-8"?>
+<p:notes xmlns:a="http://schemas.openxmlformats.org/drawingml/2006/main" xmlns:r="http://schemas.openxmlformats.org/officeDocument/2006/relationships" xmlns:p="http://schemas.openxmlformats.org/presentationml/2006/main">
+  <p:cSld>
+    <p:spTree>
+      <p:nvGrpSpPr>
+        <p:cNvPr id="1" name=""/>
+        <p:cNvGrpSpPr/>
+        <p:nvPr/>
+      </p:nvGrpSpPr>
+      <p:grpSpPr>
+        <a:xfrm>
+          <a:off x="0" y="0"/>
+          <a:ext cx="0" cy="0"/>
+          <a:chOff x="0" y="0"/>
+          <a:chExt cx="0" cy="0"/>
+        </a:xfrm>
+      </p:grpSpPr>
+      <p:sp>
+        <p:nvSpPr>
+          <p:cNvPr id="2" name="Slide Image Placeholder 1"/>
+          <p:cNvSpPr>
+            <a:spLocks noGrp="1" noRot="1" noChangeAspect="1"/>
+          </p:cNvSpPr>
+          <p:nvPr>
+            <p:ph type="sldImg"/>
+          </p:nvPr>
+        </p:nvSpPr>
+        <p:spPr/>
+      </p:sp>
+      <p:sp>
+        <p:nvSpPr>
+          <p:cNvPr id="3" name="Notes Placeholder 2"/>
+          <p:cNvSpPr>
+            <a:spLocks noGrp="1"/>
+          </p:cNvSpPr>
+          <p:nvPr>
+            <p:ph type="body" idx="1"/>
+          </p:nvPr>
+        </p:nvSpPr>
+        <p:spPr/>
+        <p:txBody>
+          <a:bodyPr/>
+          <a:lstStyle/>
+          <a:p>
+            <a:r>
+              <a:rPr lang="en-US" dirty="0"/>
+              <a:t>Teaching and accounting are the only professions here whose attrition fell across decades. Every health and social profession rose. Whatever pushes pharmacists and therapists up is economy wide, not a crisis of schools.</a:t>
+            </a:r>
+            <a:endParaRPr lang="en-US" dirty="0"/>
+          </a:p>
+        </p:txBody>
+      </p:sp>
+      <p:sp>
+        <p:nvSpPr>
+          <p:cNvPr id="4" name="Slide Number Placeholder 3"/>
+          <p:cNvSpPr>
+            <a:spLocks noGrp="1"/>
+          </p:cNvSpPr>
+          <p:nvPr>
+            <p:ph type="sldNum" sz="quarter" idx="10"/>
+          </p:nvPr>
+        </p:nvSpPr>
+        <p:spPr/>
+        <p:txBody>
+          <a:bodyPr/>
+          <a:lstStyle/>
+          <a:p>
+            <a:fld id="{F7021451-1387-4CA6-816F-3879F97B5CBC}" type="slidenum">
+              <a:rPr lang="en-US"/>
+              <a:t>16</a:t>
             </a:fld>
             <a:endParaRPr lang="en-US"/>
           </a:p>
@@ -1132,7 +1221,7 @@
           <a:p>
             <a:r>
               <a:rPr lang="en-US" dirty="0"/>
-              <a:t>The instrument sees professions, not schools. One question asked the same way for twenty-eight years beats any patchwork of administrative sources. Calendar 2025 enters the series the day the Census releases the 2026 supplement in the fall.</a:t>
+              <a:t>Two literatures, one gap. The follow-up surveys have depth but no frequency, and the CPS papers have frequency but stop at the level. I take the CPS instrument all the way down: routes, ages, sectors, states, family events, and earnings.</a:t>
             </a:r>
             <a:endParaRPr lang="en-US" dirty="0"/>
           </a:p>
@@ -1220,7 +1309,7 @@
           <a:p>
             <a:r>
               <a:rPr lang="en-US" dirty="0"/>
-              <a:t>The workforce is aging and its pension coverage has fallen from 80 to 66 percent. The contract is deteriorating on exactly the margin that predicts exit.</a:t>
+              <a:t>The instrument sees professions, not schools. One question asked the same way for twenty-eight years beats any patchwork of administrative sources. Calendar 2025 enters the series the day the Census releases the 2026 supplement in the fall.</a:t>
             </a:r>
             <a:endParaRPr lang="en-US" dirty="0"/>
           </a:p>
@@ -1308,7 +1397,7 @@
           <a:p>
             <a:r>
               <a:rPr lang="en-US" dirty="0"/>
-              <a:t>Twenty-eight years, no trend. The two worst years are 2001 and 2019, a generation apart. Any exodus narrative starts from a fact this series does not contain.</a:t>
+              <a:t>The workforce is aging and its pension coverage has fallen from 80 to 66 percent. The contract is deteriorating on exactly the margin that predicts exit.</a:t>
             </a:r>
             <a:endParaRPr lang="en-US" dirty="0"/>
           </a:p>
@@ -1396,7 +1485,7 @@
           <a:p>
             <a:r>
               <a:rPr lang="en-US" dirty="0"/>
-              <a:t>Of every 100 leavers, only 26 hold another job the next March. The exodus scenario, a working-age teacher productively employed elsewhere, is barely one leaver in six.</a:t>
+              <a:t>Twenty-eight years, no trend. The two worst years are 2001 and 2019, a generation apart. Any exodus narrative starts from a fact this series does not contain.</a:t>
             </a:r>
             <a:endParaRPr lang="en-US" dirty="0"/>
           </a:p>
@@ -1484,7 +1573,7 @@
           <a:p>
             <a:r>
               <a:rPr lang="en-US" dirty="0"/>
-              <a:t>The age profile is a U. The left arm is career search, the right arm is retirement. Mid-career teachers, the ones schools most need to keep, are the least mobile workers in the figure.</a:t>
+              <a:t>Of every 100 leavers, only 26 hold another job the next March. The exodus scenario, a working-age teacher productively employed elsewhere, is barely one leaver in six.</a:t>
             </a:r>
             <a:endParaRPr lang="en-US" dirty="0"/>
           </a:p>
@@ -1572,7 +1661,7 @@
           <a:p>
             <a:r>
               <a:rPr lang="en-US" dirty="0"/>
-              <a:t>Private schools lose teachers at twice the public rate, through every route. Tenure, salary schedules and pensions are retention policy that already works.</a:t>
+              <a:t>The age profile is a U. The left arm is career search, the right arm is retirement. Mid-career teachers, the ones schools most need to keep, are the least mobile workers in the figure.</a:t>
             </a:r>
             <a:endParaRPr lang="en-US" dirty="0"/>
           </a:p>
@@ -1660,7 +1749,7 @@
           <a:p>
             <a:r>
               <a:rPr lang="en-US" dirty="0"/>
-              <a:t>A birth raises a teacher's exit by twice as much as a nurse's. Teaching is the college profession where a classroom cannot be covered part time.</a:t>
+              <a:t>Private schools lose teachers at twice the public rate, through every route. Tenure, salary schedules and pensions are retention policy that already works.</a:t>
             </a:r>
             <a:endParaRPr lang="en-US" dirty="0"/>
           </a:p>
@@ -1748,7 +1837,7 @@
           <a:p>
             <a:r>
               <a:rPr lang="en-US" dirty="0"/>
-              <a:t>The classic exit to home is disappearing. The gap between mothers and other young women teachers went from seven points to under two in twenty-five years.</a:t>
+              <a:t>A birth raises a teacher's exit by twice as much as a nurse's. Teaching is the college profession where a classroom cannot be covered part time.</a:t>
             </a:r>
             <a:endParaRPr lang="en-US" dirty="0"/>
           </a:p>
@@ -2381,7 +2470,7 @@
                 <a:ea typeface="Garamond" pitchFamily="34" charset="-122"/>
                 <a:cs typeface="Garamond" pitchFamily="34" charset="-120"/>
               </a:rPr>
-              <a:t>Figure 8. Leaving Teaching and the Unemployment Rate, 1997–2024</a:t>
+              <a:t>Figure 7. Labor Force Exit of Women Teachers, With and Without Young Children</a:t>
             </a:r>
             <a:endParaRPr lang="en-US" sz="2100" dirty="0"/>
           </a:p>
@@ -2389,7 +2478,7 @@
       </p:sp>
       <p:pic>
         <p:nvPicPr>
-          <p:cNvPr id="3" name="Image 0" descr="figs_png/n5_cyclicality.png">    </p:cNvPr>
+          <p:cNvPr id="3" name="Image 0" descr="figs_png/g9_mothers.png">    </p:cNvPr>
           <p:cNvPicPr>
             <a:picLocks noChangeAspect="1"/>
           </p:cNvPicPr>
@@ -2403,8 +2492,8 @@
         </p:blipFill>
         <p:spPr>
           <a:xfrm>
-            <a:off x="470916" y="1072233"/>
-            <a:ext cx="11247120" cy="4174039"/>
+            <a:off x="1385316" y="804672"/>
+            <a:ext cx="9418320" cy="4709160"/>
           </a:xfrm>
           <a:prstGeom prst="rect">
             <a:avLst/>
@@ -2444,7 +2533,7 @@
                 <a:ea typeface="Garamond" pitchFamily="34" charset="-122"/>
                 <a:cs typeface="Garamond" pitchFamily="34" charset="-120"/>
               </a:rPr>
-              <a:t>Notes: Left: the leaving series (annual, from calendar 2000) against the BLS national unemployment rate (annual average). Right: binned scatter (deciles of the unemployment rate in the survey month, March of t+1, when the exit is observed) of the two labor-market routes, with OLS fits on the underlying annual data; correlations are −0.16 (to another job) and +0.29 (out of the labor force). Unemployment: BLS via FRED (UNRATE). Source: author’s calculations from March CPS supplements.</a:t>
+              <a:t>Notes: Women teachers aged 22–45, college graduates; annual probability of leaving the labor force (thin lines) and centered 3-year averages (bold), separately for those with and without an own child under 6 at home. Endpoint values printed. Source: author’s calculations from March CPS supplements, survey years 1998–2025.</a:t>
             </a:r>
             <a:endParaRPr lang="en-US" sz="950" dirty="0"/>
           </a:p>
@@ -2515,7 +2604,7 @@
                 <a:ea typeface="Garamond" pitchFamily="34" charset="-122"/>
                 <a:cs typeface="Garamond" pitchFamily="34" charset="-120"/>
               </a:rPr>
-              <a:t>Figure 9. Leaving and State Unemployment: Two Examples</a:t>
+              <a:t>Figure 8. Leaving Teaching and the Unemployment Rate, 1997–2024</a:t>
             </a:r>
             <a:endParaRPr lang="en-US" sz="2100" dirty="0"/>
           </a:p>
@@ -2523,7 +2612,7 @@
       </p:sp>
       <p:pic>
         <p:nvPicPr>
-          <p:cNvPr id="3" name="Image 0" descr="figs_png/n5b_states_trio.png">    </p:cNvPr>
+          <p:cNvPr id="3" name="Image 0" descr="figs_png/n5_cyclicality.png">    </p:cNvPr>
           <p:cNvPicPr>
             <a:picLocks noChangeAspect="1"/>
           </p:cNvPicPr>
@@ -2537,8 +2626,8 @@
         </p:blipFill>
         <p:spPr>
           <a:xfrm>
-            <a:off x="899307" y="804672"/>
-            <a:ext cx="10390339" cy="4709160"/>
+            <a:off x="470916" y="1072233"/>
+            <a:ext cx="11247120" cy="4174039"/>
           </a:xfrm>
           <a:prstGeom prst="rect">
             <a:avLst/>
@@ -2578,7 +2667,7 @@
                 <a:ea typeface="Garamond" pitchFamily="34" charset="-122"/>
                 <a:cs typeface="Garamond" pitchFamily="34" charset="-120"/>
               </a:rPr>
-              <a:t>Notes: Annual state leaving rates of college-graduate teachers (dots; one per year, 1997–2024) against the state unemployment rate in the survey month (BLS Local Area Unemployment Statistics), with OLS fits. North Carolina and New Jersey are shown as examples of the two signs. State of residence is recovered from the household records of the raw files. Source: author’s calculations from March CPS supplements.</a:t>
+              <a:t>Notes: Left: the leaving series (annual, from calendar 2000) against the BLS national unemployment rate (annual average). Right: binned scatter (deciles of the unemployment rate in the survey month, March of t+1, when the exit is observed) of the two labor-market routes, with OLS fits on the underlying annual data; correlations are −0.16 (to another job) and +0.29 (out of the labor force). Unemployment: BLS via FRED (UNRATE). Source: author’s calculations from March CPS supplements.</a:t>
             </a:r>
             <a:endParaRPr lang="en-US" sz="950" dirty="0"/>
           </a:p>
@@ -2649,7 +2738,7 @@
                 <a:ea typeface="Garamond" pitchFamily="34" charset="-122"/>
                 <a:cs typeface="Garamond" pitchFamily="34" charset="-120"/>
               </a:rPr>
-              <a:t>Figure 10. The Distribution of Earnings Changes: Stayers and Leavers</a:t>
+              <a:t>Figure 9. Leaving and State Unemployment: Two Examples</a:t>
             </a:r>
             <a:endParaRPr lang="en-US" sz="2100" dirty="0"/>
           </a:p>
@@ -2657,7 +2746,7 @@
       </p:sp>
       <p:pic>
         <p:nvPicPr>
-          <p:cNvPr id="3" name="Image 0" descr="figs_png/g5b_earnings_density.png">    </p:cNvPr>
+          <p:cNvPr id="3" name="Image 0" descr="figs_png/n5b_states_trio.png">    </p:cNvPr>
           <p:cNvPicPr>
             <a:picLocks noChangeAspect="1"/>
           </p:cNvPicPr>
@@ -2671,8 +2760,8 @@
         </p:blipFill>
         <p:spPr>
           <a:xfrm>
-            <a:off x="1590062" y="804672"/>
-            <a:ext cx="9008828" cy="4709160"/>
+            <a:off x="899307" y="804672"/>
+            <a:ext cx="10390339" cy="4709160"/>
           </a:xfrm>
           <a:prstGeom prst="rect">
             <a:avLst/>
@@ -2712,7 +2801,7 @@
                 <a:ea typeface="Garamond" pitchFamily="34" charset="-122"/>
                 <a:cs typeface="Garamond" pitchFamily="34" charset="-120"/>
               </a:rPr>
-              <a:t>Notes: Kernel densities of the person-level change in annual wage and salary earnings (log points ×100) between the teaching year and the next, for teachers linked across consecutive supplements (rotation-group links, survey years 2011–2025; identity validated on sex and age). Navy: stayers (12,195 links; median +3). Red: leavers employed the following year (225 links; median +15). “Lose big”/“win big” denote changes beyond ±30 log points. The sample conditions on positive earnings in both years; 47 percent of all leavers report zero earnings the following year. Bandwidth 0.25. Source: author’s calculations from March CPS supplements.</a:t>
+              <a:t>Notes: Annual state leaving rates of college-graduate teachers (dots; one per year, 1997–2024) against the state unemployment rate in the survey month (BLS Local Area Unemployment Statistics), with OLS fits. North Carolina and New Jersey are shown as examples of the two signs. State of residence is recovered from the household records of the raw files. Source: author’s calculations from March CPS supplements.</a:t>
             </a:r>
             <a:endParaRPr lang="en-US" sz="950" dirty="0"/>
           </a:p>
@@ -2783,7 +2872,7 @@
                 <a:ea typeface="Garamond" pitchFamily="34" charset="-122"/>
                 <a:cs typeface="Garamond" pitchFamily="34" charset="-120"/>
               </a:rPr>
-              <a:t>Figure 11. Real Median Earnings by Profession, 2004–2014 and 2015–2025</a:t>
+              <a:t>Figure 10. The Distribution of Earnings Changes: Stayers and Leavers</a:t>
             </a:r>
             <a:endParaRPr lang="en-US" sz="2100" dirty="0"/>
           </a:p>
@@ -2791,7 +2880,7 @@
       </p:sp>
       <p:pic>
         <p:nvPicPr>
-          <p:cNvPr id="3" name="Image 0" descr="figs_png/n6b_pay_windows.png">    </p:cNvPr>
+          <p:cNvPr id="3" name="Image 0" descr="figs_png/g5b_earnings_density.png">    </p:cNvPr>
           <p:cNvPicPr>
             <a:picLocks noChangeAspect="1"/>
           </p:cNvPicPr>
@@ -2805,8 +2894,8 @@
         </p:blipFill>
         <p:spPr>
           <a:xfrm>
-            <a:off x="1609562" y="804672"/>
-            <a:ext cx="8969829" cy="4709160"/>
+            <a:off x="1590062" y="804672"/>
+            <a:ext cx="9008828" cy="4709160"/>
           </a:xfrm>
           <a:prstGeom prst="rect">
             <a:avLst/>
@@ -2846,7 +2935,7 @@
                 <a:ea typeface="Garamond" pitchFamily="34" charset="-122"/>
                 <a:cs typeface="Garamond" pitchFamily="34" charset="-120"/>
               </a:rPr>
-              <a:t>Notes: Weighted median annual wage and salary earnings of full-time, full-year college graduates aged 25–60, in each profession and overall, deflated to 2024 dollars with the CPI-U; the two windows pool survey years 2004–2014 and 2015–2025. Filled dots (with values): recent window. Source: author’s calculations from March CPS supplements; CPI: BLS via FRED.</a:t>
+              <a:t>Notes: Kernel densities of the person-level change in annual wage and salary earnings (log points ×100) between the teaching year and the next, for teachers linked across consecutive supplements (rotation-group links, survey years 2011–2025; identity validated on sex and age). Navy: stayers (12,195 links; median +3). Red: leavers employed the following year (225 links; median +15). “Lose big”/“win big” denote changes beyond ±30 log points. The sample conditions on positive earnings in both years; 47 percent of all leavers report zero earnings the following year. Bandwidth 0.25. Source: author’s calculations from March CPS supplements.</a:t>
             </a:r>
             <a:endParaRPr lang="en-US" sz="950" dirty="0"/>
           </a:p>
@@ -2917,7 +3006,7 @@
                 <a:ea typeface="Garamond" pitchFamily="34" charset="-122"/>
                 <a:cs typeface="Garamond" pitchFamily="34" charset="-120"/>
               </a:rPr>
-              <a:t>Figure 12. Average Marginal Effects on the Probability of Leaving Teaching</a:t>
+              <a:t>Figure 11. Real Median Earnings by Profession, 2004–2014 and 2015–2025</a:t>
             </a:r>
             <a:endParaRPr lang="en-US" sz="2100" dirty="0"/>
           </a:p>
@@ -2925,7 +3014,7 @@
       </p:sp>
       <p:pic>
         <p:nvPicPr>
-          <p:cNvPr id="3" name="Image 0" descr="figs_png/g6_ame.png">    </p:cNvPr>
+          <p:cNvPr id="3" name="Image 0" descr="figs_png/n6b_pay_windows.png">    </p:cNvPr>
           <p:cNvPicPr>
             <a:picLocks noChangeAspect="1"/>
           </p:cNvPicPr>
@@ -2939,8 +3028,8 @@
         </p:blipFill>
         <p:spPr>
           <a:xfrm>
-            <a:off x="2955036" y="804672"/>
-            <a:ext cx="6278880" cy="4709160"/>
+            <a:off x="1609562" y="804672"/>
+            <a:ext cx="8969829" cy="4709160"/>
           </a:xfrm>
           <a:prstGeom prst="rect">
             <a:avLst/>
@@ -2980,7 +3069,7 @@
                 <a:ea typeface="Garamond" pitchFamily="34" charset="-122"/>
                 <a:cs typeface="Garamond" pitchFamily="34" charset="-120"/>
               </a:rPr>
-              <a:t>Notes: Average marginal effects (percentage points) on the probability of leaving teaching, from a probit on college-graduate teachers pooled over calendar 2015–2024 with year effects; whiskers are 95 percent confidence intervals; filled markers are significant at 5 percent. “Worked full year” is 50+ weeks at the last-year job; “part-time” is under 35 weekly hours. n = 28,900. Source: author’s calculations from March CPS supplements.</a:t>
+              <a:t>Notes: Weighted median annual wage and salary earnings of full-time, full-year college graduates aged 25–60, in each profession and overall, deflated to 2024 dollars with the CPI-U; the two windows pool survey years 2004–2014 and 2015–2025. Filled dots (with values): recent window. Source: author’s calculations from March CPS supplements; CPI: BLS via FRED.</a:t>
             </a:r>
             <a:endParaRPr lang="en-US" sz="950" dirty="0"/>
           </a:p>
@@ -3051,6 +3140,140 @@
                 <a:ea typeface="Garamond" pitchFamily="34" charset="-122"/>
                 <a:cs typeface="Garamond" pitchFamily="34" charset="-120"/>
               </a:rPr>
+              <a:t>Figure 12. Average Marginal Effects on the Probability of Leaving Teaching</a:t>
+            </a:r>
+            <a:endParaRPr lang="en-US" sz="2100" dirty="0"/>
+          </a:p>
+        </p:txBody>
+      </p:sp>
+      <p:pic>
+        <p:nvPicPr>
+          <p:cNvPr id="3" name="Image 0" descr="figs_png/g6_ame.png">    </p:cNvPr>
+          <p:cNvPicPr>
+            <a:picLocks noChangeAspect="1"/>
+          </p:cNvPicPr>
+          <p:nvPr/>
+        </p:nvPicPr>
+        <p:blipFill>
+          <a:blip r:embed="rId1"/>
+          <a:stretch>
+            <a:fillRect/>
+          </a:stretch>
+        </p:blipFill>
+        <p:spPr>
+          <a:xfrm>
+            <a:off x="2955036" y="804672"/>
+            <a:ext cx="6278880" cy="4709160"/>
+          </a:xfrm>
+          <a:prstGeom prst="rect">
+            <a:avLst/>
+          </a:prstGeom>
+        </p:spPr>
+      </p:pic>
+      <p:sp>
+        <p:nvSpPr>
+          <p:cNvPr id="5" name="Text 1"/>
+          <p:cNvSpPr/>
+          <p:nvPr/>
+        </p:nvSpPr>
+        <p:spPr>
+          <a:xfrm>
+            <a:off x="457200" y="5650992"/>
+            <a:ext cx="11274552" cy="1097280"/>
+          </a:xfrm>
+          <a:prstGeom prst="rect">
+            <a:avLst/>
+          </a:prstGeom>
+          <a:noFill/>
+          <a:ln/>
+        </p:spPr>
+        <p:txBody>
+          <a:bodyPr wrap="square" lIns="0" tIns="0" rIns="0" bIns="0" rtlCol="0" anchor="t"/>
+          <a:lstStyle/>
+          <a:p>
+            <a:pPr algn="just" indent="0" marL="0">
+              <a:buNone/>
+            </a:pPr>
+            <a:r>
+              <a:rPr lang="en-US" sz="950" dirty="0">
+                <a:solidFill>
+                  <a:srgbClr val="5A6572"/>
+                </a:solidFill>
+                <a:latin typeface="Garamond" pitchFamily="34" charset="0"/>
+                <a:ea typeface="Garamond" pitchFamily="34" charset="-122"/>
+                <a:cs typeface="Garamond" pitchFamily="34" charset="-120"/>
+              </a:rPr>
+              <a:t>Notes: Average marginal effects (percentage points) on the probability of leaving teaching, from a probit on college-graduate teachers pooled over calendar 2015–2024 with year effects; whiskers are 95 percent confidence intervals; filled markers are significant at 5 percent. “Worked full year” is 50+ weeks at the last-year job; “part-time” is under 35 weekly hours. n = 28,900. Source: author’s calculations from March CPS supplements.</a:t>
+            </a:r>
+            <a:endParaRPr lang="en-US" sz="950" dirty="0"/>
+          </a:p>
+        </p:txBody>
+      </p:sp>
+    </p:spTree>
+  </p:cSld>
+  <p:clrMapOvr>
+    <a:masterClrMapping/>
+  </p:clrMapOvr>
+</p:sld>
+</file>
+
+<file path=ppt/slides/slide16.xml><?xml version="1.0" encoding="utf-8"?>
+<p:sld xmlns:a="http://schemas.openxmlformats.org/drawingml/2006/main" xmlns:r="http://schemas.openxmlformats.org/officeDocument/2006/relationships" xmlns:p="http://schemas.openxmlformats.org/presentationml/2006/main">
+  <p:cSld name="Slide 16">
+    <p:bg>
+      <p:bgPr>
+        <a:solidFill>
+          <a:srgbClr val="FFFFFF"/>
+        </a:solidFill>
+      </p:bgPr>
+    </p:bg>
+    <p:spTree>
+      <p:nvGrpSpPr>
+        <p:cNvPr id="1" name=""/>
+        <p:cNvGrpSpPr/>
+        <p:nvPr/>
+      </p:nvGrpSpPr>
+      <p:grpSpPr>
+        <a:xfrm>
+          <a:off x="0" y="0"/>
+          <a:ext cx="0" cy="0"/>
+          <a:chOff x="0" y="0"/>
+          <a:chExt cx="0" cy="0"/>
+        </a:xfrm>
+      </p:grpSpPr>
+      <p:sp>
+        <p:nvSpPr>
+          <p:cNvPr id="2" name="Text 0"/>
+          <p:cNvSpPr/>
+          <p:nvPr/>
+        </p:nvSpPr>
+        <p:spPr>
+          <a:xfrm>
+            <a:off x="457200" y="201168"/>
+            <a:ext cx="11274552" cy="502920"/>
+          </a:xfrm>
+          <a:prstGeom prst="rect">
+            <a:avLst/>
+          </a:prstGeom>
+          <a:noFill/>
+          <a:ln/>
+        </p:spPr>
+        <p:txBody>
+          <a:bodyPr wrap="square" lIns="0" tIns="0" rIns="0" bIns="0" rtlCol="0" anchor="ctr"/>
+          <a:lstStyle/>
+          <a:p>
+            <a:pPr algn="ctr" indent="0" marL="0">
+              <a:buNone/>
+            </a:pPr>
+            <a:r>
+              <a:rPr lang="en-US" sz="2100" dirty="0">
+                <a:solidFill>
+                  <a:srgbClr val="1A2430"/>
+                </a:solidFill>
+                <a:latin typeface="Garamond" pitchFamily="34" charset="0"/>
+                <a:ea typeface="Garamond" pitchFamily="34" charset="-122"/>
+                <a:cs typeface="Garamond" pitchFamily="34" charset="-120"/>
+              </a:rPr>
               <a:t>Figure 13. Rates of Leaving by Profession, 2004–2014 and 2015–2025</a:t>
             </a:r>
             <a:endParaRPr lang="en-US" sz="2100" dirty="0"/>
@@ -3179,13 +3402,13 @@
             <a:r>
               <a:rPr lang="en-US" sz="2400" b="1" dirty="0">
                 <a:solidFill>
-                  <a:srgbClr val="1F3B66"/>
+                  <a:srgbClr val="26456E"/>
                 </a:solidFill>
                 <a:latin typeface="Garamond" pitchFamily="34" charset="0"/>
                 <a:ea typeface="Garamond" pitchFamily="34" charset="-122"/>
                 <a:cs typeface="Garamond" pitchFamily="34" charset="-120"/>
               </a:rPr>
-              <a:t>Data</a:t>
+              <a:t>Motivation</a:t>
             </a:r>
             <a:endParaRPr lang="en-US" sz="2400" dirty="0"/>
           </a:p>
@@ -3199,8 +3422,8 @@
         </p:nvSpPr>
         <p:spPr>
           <a:xfrm>
-            <a:off x="1143000" y="1874520"/>
-            <a:ext cx="9902952" cy="868680"/>
+            <a:off x="914400" y="1554480"/>
+            <a:ext cx="10332720" cy="1005840"/>
           </a:xfrm>
           <a:prstGeom prst="rect">
             <a:avLst/>
@@ -3227,7 +3450,7 @@
                 <a:ea typeface="Garamond" pitchFamily="34" charset="-122"/>
                 <a:cs typeface="Garamond" pitchFamily="34" charset="-120"/>
               </a:rPr>
-              <a:t>March supplement of the Current Population Survey, survey years 1998 to 2025.</a:t>
+              <a:t>One in six American teachers is said to leave every year. That number mixes teachers who change schools with teachers who leave the classroom for good; only the second group is an exodus.</a:t>
             </a:r>
             <a:endParaRPr lang="en-US" sz="1550" dirty="0"/>
           </a:p>
@@ -3241,8 +3464,8 @@
         </p:nvSpPr>
         <p:spPr>
           <a:xfrm>
-            <a:off x="1143000" y="2532888"/>
-            <a:ext cx="9902952" cy="868680"/>
+            <a:off x="914400" y="2788920"/>
+            <a:ext cx="10332720" cy="1005840"/>
           </a:xfrm>
           <a:prstGeom prst="rect">
             <a:avLst/>
@@ -3269,7 +3492,7 @@
                 <a:ea typeface="Garamond" pitchFamily="34" charset="-122"/>
                 <a:cs typeface="Garamond" pitchFamily="34" charset="-120"/>
               </a:rPr>
-              <a:t>One retrospective question: the longest job held last calendar year, compared with the occupation held this week. Whoever taught last year and no longer teaches this March has left the profession.</a:t>
+              <a:t>The official measure of profession leaving, the NCES Teacher Follow-up Survey, runs only every few years, covers public schools only, and follows small samples.</a:t>
             </a:r>
             <a:endParaRPr lang="en-US" sz="1550" dirty="0"/>
           </a:p>
@@ -3283,8 +3506,8 @@
         </p:nvSpPr>
         <p:spPr>
           <a:xfrm>
-            <a:off x="1143000" y="3557016"/>
-            <a:ext cx="9902952" cy="868680"/>
+            <a:off x="914400" y="3749040"/>
+            <a:ext cx="10332720" cy="1005840"/>
           </a:xfrm>
           <a:prstGeom prst="rect">
             <a:avLst/>
@@ -3311,7 +3534,7 @@
                 <a:ea typeface="Garamond" pitchFamily="34" charset="-122"/>
                 <a:cs typeface="Garamond" pitchFamily="34" charset="-120"/>
               </a:rPr>
-              <a:t>The pooled file holds 5,009,129 person-year records, 104,545 of them teacher-years, covering calendar years 1997 to 2024.</a:t>
+              <a:t>Harris and Adams (2007) and Aldeman and Yi (2025) measure leaving instead with a single question of the March CPS. This deck takes their instrument to its full depth and length: every supplement since 1998, every exit routed, priced, and modeled.</a:t>
             </a:r>
             <a:endParaRPr lang="en-US" sz="1550" dirty="0"/>
           </a:p>
@@ -3325,8 +3548,8 @@
         </p:nvSpPr>
         <p:spPr>
           <a:xfrm>
-            <a:off x="1143000" y="4581144"/>
-            <a:ext cx="9902952" cy="868680"/>
+            <a:off x="914400" y="4983480"/>
+            <a:ext cx="10332720" cy="1005840"/>
           </a:xfrm>
           <a:prstGeom prst="rect">
             <a:avLst/>
@@ -3353,48 +3576,9 @@
                 <a:ea typeface="Garamond" pitchFamily="34" charset="-122"/>
                 <a:cs typeface="Garamond" pitchFamily="34" charset="-120"/>
               </a:rPr>
-              <a:t>Every variable is read from the raw Census files at its officially documented position. All estimates use ASEC supplement weights.</a:t>
+              <a:t>The result is an annual, all-sector, twenty-eight-year series that complements the NCES surveys and reconciles the numbers in the public debate.</a:t>
             </a:r>
             <a:endParaRPr lang="en-US" sz="1550" dirty="0"/>
-          </a:p>
-        </p:txBody>
-      </p:sp>
-      <p:sp>
-        <p:nvSpPr>
-          <p:cNvPr id="7" name="Text 5"/>
-          <p:cNvSpPr/>
-          <p:nvPr/>
-        </p:nvSpPr>
-        <p:spPr>
-          <a:xfrm>
-            <a:off x="1143000" y="6035040"/>
-            <a:ext cx="9902952" cy="292608"/>
-          </a:xfrm>
-          <a:prstGeom prst="rect">
-            <a:avLst/>
-          </a:prstGeom>
-          <a:noFill/>
-          <a:ln/>
-        </p:spPr>
-        <p:txBody>
-          <a:bodyPr wrap="square" lIns="0" tIns="0" rIns="0" bIns="0" rtlCol="0" anchor="ctr"/>
-          <a:lstStyle/>
-          <a:p>
-            <a:pPr algn="l" indent="0" marL="0">
-              <a:buNone/>
-            </a:pPr>
-            <a:r>
-              <a:rPr lang="en-US" sz="1150" i="1" dirty="0">
-                <a:solidFill>
-                  <a:srgbClr val="5A6572"/>
-                </a:solidFill>
-                <a:latin typeface="Garamond" pitchFamily="34" charset="0"/>
-                <a:ea typeface="Garamond" pitchFamily="34" charset="-122"/>
-                <a:cs typeface="Garamond" pitchFamily="34" charset="-120"/>
-              </a:rPr>
-              <a:t>The March 2026 supplement, covering calendar 2025, is not yet public.</a:t>
-            </a:r>
-            <a:endParaRPr lang="en-US" sz="1150" dirty="0"/>
           </a:p>
         </p:txBody>
       </p:sp>
@@ -3438,8 +3622,8 @@
         </p:nvSpPr>
         <p:spPr>
           <a:xfrm>
-            <a:off x="457200" y="201168"/>
-            <a:ext cx="11274552" cy="502920"/>
+            <a:off x="914400" y="502920"/>
+            <a:ext cx="9875520" cy="548640"/>
           </a:xfrm>
           <a:prstGeom prst="rect">
             <a:avLst/>
@@ -3451,11 +3635,53 @@
           <a:bodyPr wrap="square" lIns="0" tIns="0" rIns="0" bIns="0" rtlCol="0" anchor="ctr"/>
           <a:lstStyle/>
           <a:p>
-            <a:pPr algn="ctr" indent="0" marL="0">
+            <a:pPr algn="l" indent="0" marL="0">
               <a:buNone/>
             </a:pPr>
             <a:r>
-              <a:rPr lang="en-US" sz="2100" dirty="0">
+              <a:rPr lang="en-US" sz="2400" b="1" dirty="0">
+                <a:solidFill>
+                  <a:srgbClr val="1F3B66"/>
+                </a:solidFill>
+                <a:latin typeface="Garamond" pitchFamily="34" charset="0"/>
+                <a:ea typeface="Garamond" pitchFamily="34" charset="-122"/>
+                <a:cs typeface="Garamond" pitchFamily="34" charset="-120"/>
+              </a:rPr>
+              <a:t>Data</a:t>
+            </a:r>
+            <a:endParaRPr lang="en-US" sz="2400" dirty="0"/>
+          </a:p>
+        </p:txBody>
+      </p:sp>
+      <p:sp>
+        <p:nvSpPr>
+          <p:cNvPr id="3" name="Text 1"/>
+          <p:cNvSpPr/>
+          <p:nvPr/>
+        </p:nvSpPr>
+        <p:spPr>
+          <a:xfrm>
+            <a:off x="1143000" y="1874520"/>
+            <a:ext cx="9902952" cy="868680"/>
+          </a:xfrm>
+          <a:prstGeom prst="rect">
+            <a:avLst/>
+          </a:prstGeom>
+          <a:noFill/>
+          <a:ln/>
+        </p:spPr>
+        <p:txBody>
+          <a:bodyPr wrap="square" lIns="0" tIns="0" rIns="0" bIns="0" rtlCol="0" anchor="t"/>
+          <a:lstStyle/>
+          <a:p>
+            <a:pPr algn="l" indent="0" marL="0">
+              <a:lnSpc>
+                <a:spcPts val="2200"/>
+              </a:lnSpc>
+              <a:buNone/>
+            </a:pPr>
+            <a:r>
+              <a:rPr lang="en-US" sz="1550" dirty="0">
                 <a:solidFill>
                   <a:srgbClr val="1A2430"/>
                 </a:solidFill>
@@ -3463,46 +3689,22 @@
                 <a:ea typeface="Garamond" pitchFamily="34" charset="-122"/>
                 <a:cs typeface="Garamond" pitchFamily="34" charset="-120"/>
               </a:rPr>
-              <a:t>Figure 1. Composition of the Teaching Workforce, 2005–2024</a:t>
-            </a:r>
-            <a:endParaRPr lang="en-US" sz="2100" dirty="0"/>
-          </a:p>
-        </p:txBody>
-      </p:sp>
-      <p:pic>
-        <p:nvPicPr>
-          <p:cNvPr id="3" name="Image 0" descr="figs_png/g1_workforce.png">    </p:cNvPr>
-          <p:cNvPicPr>
-            <a:picLocks noChangeAspect="1"/>
-          </p:cNvPicPr>
-          <p:nvPr/>
-        </p:nvPicPr>
-        <p:blipFill>
-          <a:blip r:embed="rId1"/>
-          <a:stretch>
-            <a:fillRect/>
-          </a:stretch>
-        </p:blipFill>
-        <p:spPr>
-          <a:xfrm>
-            <a:off x="1133040" y="804672"/>
-            <a:ext cx="9922873" cy="4709160"/>
-          </a:xfrm>
-          <a:prstGeom prst="rect">
-            <a:avLst/>
-          </a:prstGeom>
-        </p:spPr>
-      </p:pic>
-      <p:sp>
-        <p:nvSpPr>
-          <p:cNvPr id="5" name="Text 1"/>
+              <a:t>March supplement of the Current Population Survey, survey years 1998 to 2025.</a:t>
+            </a:r>
+            <a:endParaRPr lang="en-US" sz="1550" dirty="0"/>
+          </a:p>
+        </p:txBody>
+      </p:sp>
+      <p:sp>
+        <p:nvSpPr>
+          <p:cNvPr id="4" name="Text 2"/>
           <p:cNvSpPr/>
           <p:nvPr/>
         </p:nvSpPr>
         <p:spPr>
           <a:xfrm>
-            <a:off x="457200" y="5650992"/>
-            <a:ext cx="11274552" cy="1097280"/>
+            <a:off x="1143000" y="2532888"/>
+            <a:ext cx="9902952" cy="868680"/>
           </a:xfrm>
           <a:prstGeom prst="rect">
             <a:avLst/>
@@ -3514,11 +3716,137 @@
           <a:bodyPr wrap="square" lIns="0" tIns="0" rIns="0" bIns="0" rtlCol="0" anchor="t"/>
           <a:lstStyle/>
           <a:p>
-            <a:pPr algn="just" indent="0" marL="0">
+            <a:pPr algn="l" indent="0" marL="0">
+              <a:lnSpc>
+                <a:spcPts val="2200"/>
+              </a:lnSpc>
               <a:buNone/>
             </a:pPr>
             <a:r>
-              <a:rPr lang="en-US" sz="950" dirty="0">
+              <a:rPr lang="en-US" sz="1550" dirty="0">
+                <a:solidFill>
+                  <a:srgbClr val="1A2430"/>
+                </a:solidFill>
+                <a:latin typeface="Garamond" pitchFamily="34" charset="0"/>
+                <a:ea typeface="Garamond" pitchFamily="34" charset="-122"/>
+                <a:cs typeface="Garamond" pitchFamily="34" charset="-120"/>
+              </a:rPr>
+              <a:t>One retrospective question: the longest job held last calendar year, compared with the occupation held this week. Whoever taught last year and no longer teaches this March has left the profession.</a:t>
+            </a:r>
+            <a:endParaRPr lang="en-US" sz="1550" dirty="0"/>
+          </a:p>
+        </p:txBody>
+      </p:sp>
+      <p:sp>
+        <p:nvSpPr>
+          <p:cNvPr id="5" name="Text 3"/>
+          <p:cNvSpPr/>
+          <p:nvPr/>
+        </p:nvSpPr>
+        <p:spPr>
+          <a:xfrm>
+            <a:off x="1143000" y="3557016"/>
+            <a:ext cx="9902952" cy="868680"/>
+          </a:xfrm>
+          <a:prstGeom prst="rect">
+            <a:avLst/>
+          </a:prstGeom>
+          <a:noFill/>
+          <a:ln/>
+        </p:spPr>
+        <p:txBody>
+          <a:bodyPr wrap="square" lIns="0" tIns="0" rIns="0" bIns="0" rtlCol="0" anchor="t"/>
+          <a:lstStyle/>
+          <a:p>
+            <a:pPr algn="l" indent="0" marL="0">
+              <a:lnSpc>
+                <a:spcPts val="2200"/>
+              </a:lnSpc>
+              <a:buNone/>
+            </a:pPr>
+            <a:r>
+              <a:rPr lang="en-US" sz="1550" dirty="0">
+                <a:solidFill>
+                  <a:srgbClr val="1A2430"/>
+                </a:solidFill>
+                <a:latin typeface="Garamond" pitchFamily="34" charset="0"/>
+                <a:ea typeface="Garamond" pitchFamily="34" charset="-122"/>
+                <a:cs typeface="Garamond" pitchFamily="34" charset="-120"/>
+              </a:rPr>
+              <a:t>The pooled file holds 5,009,129 person-year records, 104,545 of them teacher-years, covering calendar years 1997 to 2024.</a:t>
+            </a:r>
+            <a:endParaRPr lang="en-US" sz="1550" dirty="0"/>
+          </a:p>
+        </p:txBody>
+      </p:sp>
+      <p:sp>
+        <p:nvSpPr>
+          <p:cNvPr id="6" name="Text 4"/>
+          <p:cNvSpPr/>
+          <p:nvPr/>
+        </p:nvSpPr>
+        <p:spPr>
+          <a:xfrm>
+            <a:off x="1143000" y="4581144"/>
+            <a:ext cx="9902952" cy="868680"/>
+          </a:xfrm>
+          <a:prstGeom prst="rect">
+            <a:avLst/>
+          </a:prstGeom>
+          <a:noFill/>
+          <a:ln/>
+        </p:spPr>
+        <p:txBody>
+          <a:bodyPr wrap="square" lIns="0" tIns="0" rIns="0" bIns="0" rtlCol="0" anchor="t"/>
+          <a:lstStyle/>
+          <a:p>
+            <a:pPr algn="l" indent="0" marL="0">
+              <a:lnSpc>
+                <a:spcPts val="2200"/>
+              </a:lnSpc>
+              <a:buNone/>
+            </a:pPr>
+            <a:r>
+              <a:rPr lang="en-US" sz="1550" dirty="0">
+                <a:solidFill>
+                  <a:srgbClr val="1A2430"/>
+                </a:solidFill>
+                <a:latin typeface="Garamond" pitchFamily="34" charset="0"/>
+                <a:ea typeface="Garamond" pitchFamily="34" charset="-122"/>
+                <a:cs typeface="Garamond" pitchFamily="34" charset="-120"/>
+              </a:rPr>
+              <a:t>Every variable is read from the raw Census files at its officially documented position. All estimates use ASEC supplement weights.</a:t>
+            </a:r>
+            <a:endParaRPr lang="en-US" sz="1550" dirty="0"/>
+          </a:p>
+        </p:txBody>
+      </p:sp>
+      <p:sp>
+        <p:nvSpPr>
+          <p:cNvPr id="7" name="Text 5"/>
+          <p:cNvSpPr/>
+          <p:nvPr/>
+        </p:nvSpPr>
+        <p:spPr>
+          <a:xfrm>
+            <a:off x="1143000" y="6035040"/>
+            <a:ext cx="9902952" cy="292608"/>
+          </a:xfrm>
+          <a:prstGeom prst="rect">
+            <a:avLst/>
+          </a:prstGeom>
+          <a:noFill/>
+          <a:ln/>
+        </p:spPr>
+        <p:txBody>
+          <a:bodyPr wrap="square" lIns="0" tIns="0" rIns="0" bIns="0" rtlCol="0" anchor="ctr"/>
+          <a:lstStyle/>
+          <a:p>
+            <a:pPr algn="l" indent="0" marL="0">
+              <a:buNone/>
+            </a:pPr>
+            <a:r>
+              <a:rPr lang="en-US" sz="1150" i="1" dirty="0">
                 <a:solidFill>
                   <a:srgbClr val="5A6572"/>
                 </a:solidFill>
@@ -3526,9 +3854,9 @@
                 <a:ea typeface="Garamond" pitchFamily="34" charset="-122"/>
                 <a:cs typeface="Garamond" pitchFamily="34" charset="-120"/>
               </a:rPr>
-              <a:t>Notes: College-graduate teachers aged 18+ whose longest job last year was K–12 teaching; ASEC supplement weights. Thin gray lines are annual values; blue lines are centered 3-year averages, with endpoint values printed. “Public school,” “part-time,” and “pension plan” refer to the longest job held last year; the open circle marks 2013, a year with a reduced sample due to the ASEC redesign. Source: author’s calculations from March CPS supplements, survey years 2006–2025.</a:t>
-            </a:r>
-            <a:endParaRPr lang="en-US" sz="950" dirty="0"/>
+              <a:t>The March 2026 supplement, covering calendar 2025, is not yet public.</a:t>
+            </a:r>
+            <a:endParaRPr lang="en-US" sz="1150" dirty="0"/>
           </a:p>
         </p:txBody>
       </p:sp>
@@ -3597,7 +3925,7 @@
                 <a:ea typeface="Garamond" pitchFamily="34" charset="-122"/>
                 <a:cs typeface="Garamond" pitchFamily="34" charset="-120"/>
               </a:rPr>
-              <a:t>Figure 2. Leaving Teaching, 1997–2024</a:t>
+              <a:t>Figure 1. Composition of the Teaching Workforce, 2005–2024</a:t>
             </a:r>
             <a:endParaRPr lang="en-US" sz="2100" dirty="0"/>
           </a:p>
@@ -3605,7 +3933,7 @@
       </p:sp>
       <p:pic>
         <p:nvPicPr>
-          <p:cNvPr id="3" name="Image 0" descr="figs_png/g2_evolution.png">    </p:cNvPr>
+          <p:cNvPr id="3" name="Image 0" descr="figs_png/g1_workforce.png">    </p:cNvPr>
           <p:cNvPicPr>
             <a:picLocks noChangeAspect="1"/>
           </p:cNvPicPr>
@@ -3619,8 +3947,8 @@
         </p:blipFill>
         <p:spPr>
           <a:xfrm>
-            <a:off x="1385316" y="804672"/>
-            <a:ext cx="9418320" cy="4709160"/>
+            <a:off x="1133040" y="804672"/>
+            <a:ext cx="9922873" cy="4709160"/>
           </a:xfrm>
           <a:prstGeom prst="rect">
             <a:avLst/>
@@ -3660,7 +3988,7 @@
                 <a:ea typeface="Garamond" pitchFamily="34" charset="-122"/>
                 <a:cs typeface="Garamond" pitchFamily="34" charset="-120"/>
               </a:rPr>
-              <a:t>Notes: Share of college-graduate teachers (longest job last calendar year) not employed in a teaching occupation the following March; ASEC weights. Shaded band: 95 percent confidence interval using a design factor of 1.5. Dotted line: the 1997–2024 mean (8.6). The gray band marks the Covid supplements. Source: author’s calculations from March CPS supplements, survey years 1998–2025.</a:t>
+              <a:t>Notes: College-graduate teachers aged 18+ whose longest job last year was K–12 teaching; ASEC supplement weights. Thin gray lines are annual values; blue lines are centered 3-year averages, with endpoint values printed. “Public school,” “part-time,” and “pension plan” refer to the longest job held last year; the open circle marks 2013, a year with a reduced sample due to the ASEC redesign. Source: author’s calculations from March CPS supplements, survey years 2006–2025.</a:t>
             </a:r>
             <a:endParaRPr lang="en-US" sz="950" dirty="0"/>
           </a:p>
@@ -3731,7 +4059,7 @@
                 <a:ea typeface="Garamond" pitchFamily="34" charset="-122"/>
                 <a:cs typeface="Garamond" pitchFamily="34" charset="-120"/>
               </a:rPr>
-              <a:t>Figure 3. Destinations of Teachers Who Leave the Profession</a:t>
+              <a:t>Figure 2. Leaving Teaching, 1997–2024</a:t>
             </a:r>
             <a:endParaRPr lang="en-US" sz="2100" dirty="0"/>
           </a:p>
@@ -3739,7 +4067,7 @@
       </p:sp>
       <p:pic>
         <p:nvPicPr>
-          <p:cNvPr id="3" name="Image 0" descr="figs_png/g3_flow100.png">    </p:cNvPr>
+          <p:cNvPr id="3" name="Image 0" descr="figs_png/g2_evolution.png">    </p:cNvPr>
           <p:cNvPicPr>
             <a:picLocks noChangeAspect="1"/>
           </p:cNvPicPr>
@@ -3753,8 +4081,8 @@
         </p:blipFill>
         <p:spPr>
           <a:xfrm>
-            <a:off x="1180570" y="804672"/>
-            <a:ext cx="9827812" cy="4709160"/>
+            <a:off x="1385316" y="804672"/>
+            <a:ext cx="9418320" cy="4709160"/>
           </a:xfrm>
           <a:prstGeom prst="rect">
             <a:avLst/>
@@ -3794,7 +4122,7 @@
                 <a:ea typeface="Garamond" pitchFamily="34" charset="-122"/>
                 <a:cs typeface="Garamond" pitchFamily="34" charset="-120"/>
               </a:rPr>
-              <a:t>Notes: College-graduate leavers pooled over calendar 2015–2024, ASEC weights. Top bar: labor force status the March after the teaching year; “out of the labor force” is split at age 55. Bottom bar: the occupational destination of the 26 employed leavers, rescaled to sum to their total. Source: author’s calculations from March CPS supplements.</a:t>
+              <a:t>Notes: Share of college-graduate teachers (longest job last calendar year) not employed in a teaching occupation the following March; ASEC weights. Shaded band: 95 percent confidence interval using a design factor of 1.5. Dotted line: the 1997–2024 mean (8.6). The gray band marks the Covid supplements. Source: author’s calculations from March CPS supplements, survey years 1998–2025.</a:t>
             </a:r>
             <a:endParaRPr lang="en-US" sz="950" dirty="0"/>
           </a:p>
@@ -3865,7 +4193,7 @@
                 <a:ea typeface="Garamond" pitchFamily="34" charset="-122"/>
                 <a:cs typeface="Garamond" pitchFamily="34" charset="-120"/>
               </a:rPr>
-              <a:t>Figure 4. Leaving Teaching by Age and Route</a:t>
+              <a:t>Figure 3. Destinations of Teachers Who Leave the Profession</a:t>
             </a:r>
             <a:endParaRPr lang="en-US" sz="2100" dirty="0"/>
           </a:p>
@@ -3873,7 +4201,7 @@
       </p:sp>
       <p:pic>
         <p:nvPicPr>
-          <p:cNvPr id="3" name="Image 0" descr="figs_png/g4_routes_age.png">    </p:cNvPr>
+          <p:cNvPr id="3" name="Image 0" descr="figs_png/g3_flow100.png">    </p:cNvPr>
           <p:cNvPicPr>
             <a:picLocks noChangeAspect="1"/>
           </p:cNvPicPr>
@@ -3887,8 +4215,8 @@
         </p:blipFill>
         <p:spPr>
           <a:xfrm>
-            <a:off x="1497439" y="804672"/>
-            <a:ext cx="9194074" cy="4709160"/>
+            <a:off x="1180570" y="804672"/>
+            <a:ext cx="9827812" cy="4709160"/>
           </a:xfrm>
           <a:prstGeom prst="rect">
             <a:avLst/>
@@ -3928,7 +4256,7 @@
                 <a:ea typeface="Garamond" pitchFamily="34" charset="-122"/>
                 <a:cs typeface="Garamond" pitchFamily="34" charset="-120"/>
               </a:rPr>
-              <a:t>Notes: College-graduate teachers pooled over calendar 2015–2024, ASEC weights; ten age groups. The black line is the total leaving rate; stacked areas decompose it into exits to another job, unemployment, and out of the labor force. Source: author’s calculations from March CPS supplements.</a:t>
+              <a:t>Notes: College-graduate leavers pooled over calendar 2015–2024, ASEC weights. Top bar: labor force status the March after the teaching year; “out of the labor force” is split at age 55. Bottom bar: the occupational destination of the 26 employed leavers, rescaled to sum to their total. Source: author’s calculations from March CPS supplements.</a:t>
             </a:r>
             <a:endParaRPr lang="en-US" sz="950" dirty="0"/>
           </a:p>
@@ -3999,7 +4327,7 @@
                 <a:ea typeface="Garamond" pitchFamily="34" charset="-122"/>
                 <a:cs typeface="Garamond" pitchFamily="34" charset="-120"/>
               </a:rPr>
-              <a:t>Figure 5. Exit Routes by School Sector</a:t>
+              <a:t>Figure 4. Leaving Teaching by Age and Route</a:t>
             </a:r>
             <a:endParaRPr lang="en-US" sz="2100" dirty="0"/>
           </a:p>
@@ -4007,7 +4335,7 @@
       </p:sp>
       <p:pic>
         <p:nvPicPr>
-          <p:cNvPr id="3" name="Image 0" descr="figs_png/g10_sector_routes.png">    </p:cNvPr>
+          <p:cNvPr id="3" name="Image 0" descr="figs_png/g4_routes_age.png">    </p:cNvPr>
           <p:cNvPicPr>
             <a:picLocks noChangeAspect="1"/>
           </p:cNvPicPr>
@@ -4021,8 +4349,8 @@
         </p:blipFill>
         <p:spPr>
           <a:xfrm>
-            <a:off x="2109802" y="804672"/>
-            <a:ext cx="7969348" cy="4709160"/>
+            <a:off x="1497439" y="804672"/>
+            <a:ext cx="9194074" cy="4709160"/>
           </a:xfrm>
           <a:prstGeom prst="rect">
             <a:avLst/>
@@ -4062,7 +4390,7 @@
                 <a:ea typeface="Garamond" pitchFamily="34" charset="-122"/>
                 <a:cs typeface="Garamond" pitchFamily="34" charset="-120"/>
               </a:rPr>
-              <a:t>Notes: Route-specific annual exit rates of college-graduate teachers by sector of the last-year job (class of worker: government vs. private), pooled 2015–2024, ASEC weights. A private-school teacher who moves to a public school—or vice versa—remains a teacher and is not a leaver here. Source: author’s calculations from March CPS supplements.</a:t>
+              <a:t>Notes: College-graduate teachers pooled over calendar 2015–2024, ASEC weights; ten age groups. The black line is the total leaving rate; stacked areas decompose it into exits to another job, unemployment, and out of the labor force. Source: author’s calculations from March CPS supplements.</a:t>
             </a:r>
             <a:endParaRPr lang="en-US" sz="950" dirty="0"/>
           </a:p>
@@ -4133,7 +4461,7 @@
                 <a:ea typeface="Garamond" pitchFamily="34" charset="-122"/>
                 <a:cs typeface="Garamond" pitchFamily="34" charset="-120"/>
               </a:rPr>
-              <a:t>Figure 6. The Effect of a New Baby on Leaving, by Profession</a:t>
+              <a:t>Figure 5. Exit Routes by School Sector</a:t>
             </a:r>
             <a:endParaRPr lang="en-US" sz="2100" dirty="0"/>
           </a:p>
@@ -4141,7 +4469,7 @@
       </p:sp>
       <p:pic>
         <p:nvPicPr>
-          <p:cNvPr id="3" name="Image 0" descr="figs_png/g8_newbaby.png">    </p:cNvPr>
+          <p:cNvPr id="3" name="Image 0" descr="figs_png/g10_sector_routes.png">    </p:cNvPr>
           <p:cNvPicPr>
             <a:picLocks noChangeAspect="1"/>
           </p:cNvPicPr>
@@ -4155,8 +4483,8 @@
         </p:blipFill>
         <p:spPr>
           <a:xfrm>
-            <a:off x="2024799" y="804672"/>
-            <a:ext cx="8139355" cy="4709160"/>
+            <a:off x="2109802" y="804672"/>
+            <a:ext cx="7969348" cy="4709160"/>
           </a:xfrm>
           <a:prstGeom prst="rect">
             <a:avLst/>
@@ -4196,7 +4524,7 @@
                 <a:ea typeface="Garamond" pitchFamily="34" charset="-122"/>
                 <a:cs typeface="Garamond" pitchFamily="34" charset="-120"/>
               </a:rPr>
-              <a:t>Notes: Average marginal effect of a new baby (own child aged 0 in the household) on the probability that a woman leaves each profession, from profession-specific probits with age, age squared, marital status, education, and year effects; whiskers are 95 percent confidence intervals. Solid bars are significant at 5 percent; light bars are not. Samples pool 2010–2024. Source: author’s calculations from March CPS supplements.</a:t>
+              <a:t>Notes: Route-specific annual exit rates of college-graduate teachers by sector of the last-year job (class of worker: government vs. private), pooled 2015–2024, ASEC weights. A private-school teacher who moves to a public school—or vice versa—remains a teacher and is not a leaver here. Source: author’s calculations from March CPS supplements.</a:t>
             </a:r>
             <a:endParaRPr lang="en-US" sz="950" dirty="0"/>
           </a:p>
@@ -4267,7 +4595,7 @@
                 <a:ea typeface="Garamond" pitchFamily="34" charset="-122"/>
                 <a:cs typeface="Garamond" pitchFamily="34" charset="-120"/>
               </a:rPr>
-              <a:t>Figure 7. Labor Force Exit of Women Teachers, With and Without Young Children</a:t>
+              <a:t>Figure 6. The Effect of a New Baby on Leaving, by Profession</a:t>
             </a:r>
             <a:endParaRPr lang="en-US" sz="2100" dirty="0"/>
           </a:p>
@@ -4275,7 +4603,7 @@
       </p:sp>
       <p:pic>
         <p:nvPicPr>
-          <p:cNvPr id="3" name="Image 0" descr="figs_png/g9_mothers.png">    </p:cNvPr>
+          <p:cNvPr id="3" name="Image 0" descr="figs_png/g8_newbaby.png">    </p:cNvPr>
           <p:cNvPicPr>
             <a:picLocks noChangeAspect="1"/>
           </p:cNvPicPr>
@@ -4289,8 +4617,8 @@
         </p:blipFill>
         <p:spPr>
           <a:xfrm>
-            <a:off x="1385316" y="804672"/>
-            <a:ext cx="9418320" cy="4709160"/>
+            <a:off x="2024799" y="804672"/>
+            <a:ext cx="8139355" cy="4709160"/>
           </a:xfrm>
           <a:prstGeom prst="rect">
             <a:avLst/>
@@ -4330,7 +4658,7 @@
                 <a:ea typeface="Garamond" pitchFamily="34" charset="-122"/>
                 <a:cs typeface="Garamond" pitchFamily="34" charset="-120"/>
               </a:rPr>
-              <a:t>Notes: Women teachers aged 22–45, college graduates; annual probability of leaving the labor force (thin lines) and centered 3-year averages (bold), separately for those with and without an own child under 6 at home. Endpoint values printed. Source: author’s calculations from March CPS supplements, survey years 1998–2025.</a:t>
+              <a:t>Notes: Average marginal effect of a new baby (own child aged 0 in the household) on the probability that a woman leaves each profession, from profession-specific probits with age, age squared, marital status, education, and year effects; whiskers are 95 percent confidence intervals. Solid bars are significant at 5 percent; light bars are not. Samples pool 2010–2024. Source: author’s calculations from March CPS supplements.</a:t>
             </a:r>
             <a:endParaRPr lang="en-US" sz="950" dirty="0"/>
           </a:p>

</xml_diff>

<commit_message>
Motivation slide rewritten around the measurement gap; CPF cross-country attrition synthesis
The motivation slide now makes the data argument: follow-up surveys
are infrequent, small, and restricted; the March CPS is annual,
public, and underexploited; Harris-Adams and Aldeman-Yi used it only
in brief comparative articles. Adds the seven-country CPF synthesis
of teacher profession-leaving rates with at least three contrasted
sources per country.

Co-Authored-By: Claude Fable 5 <noreply@anthropic.com>
Claude-Session: https://claude.ai/code/session_01DNzQPDcr3zfLTraMHUHqUn
</commit_message>
<xml_diff>
--- a/report/teacher_attrition_figures.pptx
+++ b/report/teacher_attrition_figures.pptx
@@ -3450,7 +3450,7 @@
                 <a:ea typeface="Garamond" pitchFamily="34" charset="-122"/>
                 <a:cs typeface="Garamond" pitchFamily="34" charset="-120"/>
               </a:rPr>
-              <a:t>One in six American teachers is said to leave every year. That number mixes teachers who change schools with teachers who leave the classroom for good; only the second group is an exodus.</a:t>
+              <a:t>Measuring teacher attrition is hard: it requires following the same teachers over time.</a:t>
             </a:r>
             <a:endParaRPr lang="en-US" sz="1550" dirty="0"/>
           </a:p>
@@ -3464,7 +3464,7 @@
         </p:nvSpPr>
         <p:spPr>
           <a:xfrm>
-            <a:off x="914400" y="2788920"/>
+            <a:off x="914400" y="2331720"/>
             <a:ext cx="10332720" cy="1005840"/>
           </a:xfrm>
           <a:prstGeom prst="rect">
@@ -3492,7 +3492,7 @@
                 <a:ea typeface="Garamond" pitchFamily="34" charset="-122"/>
                 <a:cs typeface="Garamond" pitchFamily="34" charset="-120"/>
               </a:rPr>
-              <a:t>The official measure of profession leaving, the NCES Teacher Follow-up Survey, runs only every few years, covers public schools only, and follows small samples.</a:t>
+              <a:t>In the United States, this is done by the NCES Schools and Staffing Survey and its successor, the National Teacher and Principal Survey, through the Teacher Follow-up Survey. These are snapshots taken every four to five years, representative but small, and the underlying microdata are restricted, not public.</a:t>
             </a:r>
             <a:endParaRPr lang="en-US" sz="1550" dirty="0"/>
           </a:p>
@@ -3506,7 +3506,7 @@
         </p:nvSpPr>
         <p:spPr>
           <a:xfrm>
-            <a:off x="914400" y="3749040"/>
+            <a:off x="914400" y="3611880"/>
             <a:ext cx="10332720" cy="1005840"/>
           </a:xfrm>
           <a:prstGeom prst="rect">
@@ -3534,7 +3534,7 @@
                 <a:ea typeface="Garamond" pitchFamily="34" charset="-122"/>
                 <a:cs typeface="Garamond" pitchFamily="34" charset="-120"/>
               </a:rPr>
-              <a:t>Harris and Adams (2007) and Aldeman and Yi (2025) measure leaving instead with a single question of the March CPS. This deck takes their instrument to its full depth and length: every supplement since 1998, every exit routed, priced, and modeled.</a:t>
+              <a:t>A little-explored alternative is the March supplement of the Current Population Survey: an annual, public survey of around 75,000 households that asks for the longest job held last calendar year and for the occupation held this week, and records where leavers land and what they earn. It offers an independent check on the official statistics and a way to deepen their descriptive analysis.</a:t>
             </a:r>
             <a:endParaRPr lang="en-US" sz="1550" dirty="0"/>
           </a:p>
@@ -3548,7 +3548,7 @@
         </p:nvSpPr>
         <p:spPr>
           <a:xfrm>
-            <a:off x="914400" y="4983480"/>
+            <a:off x="914400" y="4892040"/>
             <a:ext cx="10332720" cy="1005840"/>
           </a:xfrm>
           <a:prstGeom prst="rect">
@@ -3576,7 +3576,7 @@
                 <a:ea typeface="Garamond" pitchFamily="34" charset="-122"/>
                 <a:cs typeface="Garamond" pitchFamily="34" charset="-120"/>
               </a:rPr>
-              <a:t>The result is an annual, all-sector, twenty-eight-year series that complements the NCES surveys and reconciles the numbers in the public debate.</a:t>
+              <a:t>Harris and Adams (2007) used it for 1992–2001, and Aldeman and Yi (2025) for 2015–2024. Both are brief articles centered on comparing the teacher leaving rate with that of other professions; neither exploits the instrument in depth. This paper does.</a:t>
             </a:r>
             <a:endParaRPr lang="en-US" sz="1550" dirty="0"/>
           </a:p>

</xml_diff>

<commit_message>
Deck: OECD-style cover, polished Motivation and Data slides with final wording
Co-Authored-By: Claude Fable 5 <noreply@anthropic.com>
Claude-Session: https://claude.ai/code/session_01DNzQPDcr3zfLTraMHUHqUn
</commit_message>
<xml_diff>
--- a/report/teacher_attrition_figures.pptx
+++ b/report/teacher_attrition_figures.pptx
@@ -1221,7 +1221,7 @@
           <a:p>
             <a:r>
               <a:rPr lang="en-US" dirty="0"/>
-              <a:t>Two literatures, one gap. The follow-up surveys have depth but no frequency, and the CPS papers have frequency but stop at the level. I take the CPS instrument all the way down: routes, ages, sectors, states, family events, and earnings.</a:t>
+              <a:t>Two literatures, one gap. The follow-up surveys have depth but no frequency, and the CPS papers have frequency but stop at the level. I take the instrument all the way down: routes, prices, profiles, and the margins that move the rate.</a:t>
             </a:r>
             <a:endParaRPr lang="en-US" dirty="0"/>
           </a:p>
@@ -2218,8 +2218,8 @@
         </p:nvSpPr>
         <p:spPr>
           <a:xfrm>
-            <a:off x="1280160" y="2148840"/>
-            <a:ext cx="9628632" cy="731520"/>
+            <a:off x="640080" y="457200"/>
+            <a:ext cx="2011680" cy="457200"/>
           </a:xfrm>
           <a:prstGeom prst="rect">
             <a:avLst/>
@@ -2231,13 +2231,91 @@
           <a:bodyPr wrap="square" lIns="0" tIns="0" rIns="0" bIns="0" rtlCol="0" anchor="ctr"/>
           <a:lstStyle/>
           <a:p>
-            <a:pPr algn="ctr" indent="0" marL="0">
+            <a:pPr algn="l" indent="0" marL="0">
               <a:buNone/>
             </a:pPr>
             <a:r>
-              <a:rPr lang="en-US" sz="3000" b="1" dirty="0">
+              <a:rPr lang="en-US" sz="2600" b="1" dirty="0">
                 <a:solidFill>
-                  <a:srgbClr val="26456E"/>
+                  <a:srgbClr val="00549F"/>
+                </a:solidFill>
+                <a:latin typeface="Arial" pitchFamily="34" charset="0"/>
+                <a:ea typeface="Arial" pitchFamily="34" charset="-122"/>
+                <a:cs typeface="Arial" pitchFamily="34" charset="-120"/>
+              </a:rPr>
+              <a:t>OECD</a:t>
+            </a:r>
+            <a:endParaRPr lang="en-US" sz="2600" dirty="0"/>
+          </a:p>
+        </p:txBody>
+      </p:sp>
+      <p:sp>
+        <p:nvSpPr>
+          <p:cNvPr id="3" name="Text 1"/>
+          <p:cNvSpPr/>
+          <p:nvPr/>
+        </p:nvSpPr>
+        <p:spPr>
+          <a:xfrm>
+            <a:off x="640080" y="896112"/>
+            <a:ext cx="5486400" cy="292608"/>
+          </a:xfrm>
+          <a:prstGeom prst="rect">
+            <a:avLst/>
+          </a:prstGeom>
+          <a:noFill/>
+          <a:ln/>
+        </p:spPr>
+        <p:txBody>
+          <a:bodyPr wrap="square" lIns="0" tIns="0" rIns="0" bIns="0" rtlCol="0" anchor="ctr"/>
+          <a:lstStyle/>
+          <a:p>
+            <a:pPr algn="l" indent="0" marL="0">
+              <a:buNone/>
+            </a:pPr>
+            <a:r>
+              <a:rPr lang="en-US" sz="1200" dirty="0">
+                <a:solidFill>
+                  <a:srgbClr val="5A6572"/>
+                </a:solidFill>
+                <a:latin typeface="Garamond" pitchFamily="34" charset="0"/>
+                <a:ea typeface="Garamond" pitchFamily="34" charset="-122"/>
+                <a:cs typeface="Garamond" pitchFamily="34" charset="-120"/>
+              </a:rPr>
+              <a:t>Directorate for Education and Skills</a:t>
+            </a:r>
+            <a:endParaRPr lang="en-US" sz="1200" dirty="0"/>
+          </a:p>
+        </p:txBody>
+      </p:sp>
+      <p:sp>
+        <p:nvSpPr>
+          <p:cNvPr id="4" name="Text 2"/>
+          <p:cNvSpPr/>
+          <p:nvPr/>
+        </p:nvSpPr>
+        <p:spPr>
+          <a:xfrm>
+            <a:off x="640080" y="2377440"/>
+            <a:ext cx="10881360" cy="868680"/>
+          </a:xfrm>
+          <a:prstGeom prst="rect">
+            <a:avLst/>
+          </a:prstGeom>
+          <a:noFill/>
+          <a:ln/>
+        </p:spPr>
+        <p:txBody>
+          <a:bodyPr wrap="square" lIns="0" tIns="0" rIns="0" bIns="0" rtlCol="0" anchor="ctr"/>
+          <a:lstStyle/>
+          <a:p>
+            <a:pPr algn="l" indent="0" marL="0">
+              <a:buNone/>
+            </a:pPr>
+            <a:r>
+              <a:rPr lang="en-US" sz="3400" b="1" dirty="0">
+                <a:solidFill>
+                  <a:srgbClr val="00549F"/>
                 </a:solidFill>
                 <a:latin typeface="Garamond" pitchFamily="34" charset="0"/>
                 <a:ea typeface="Garamond" pitchFamily="34" charset="-122"/>
@@ -2245,20 +2323,20 @@
               </a:rPr>
               <a:t>Who Leaves Teaching, and Why?</a:t>
             </a:r>
-            <a:endParaRPr lang="en-US" sz="3000" dirty="0"/>
-          </a:p>
-        </p:txBody>
-      </p:sp>
-      <p:sp>
-        <p:nvSpPr>
-          <p:cNvPr id="3" name="Text 1"/>
+            <a:endParaRPr lang="en-US" sz="3400" dirty="0"/>
+          </a:p>
+        </p:txBody>
+      </p:sp>
+      <p:sp>
+        <p:nvSpPr>
+          <p:cNvPr id="5" name="Text 3"/>
           <p:cNvSpPr/>
           <p:nvPr/>
         </p:nvSpPr>
         <p:spPr>
           <a:xfrm>
-            <a:off x="1280160" y="2907792"/>
-            <a:ext cx="9628632" cy="457200"/>
+            <a:off x="640080" y="3246120"/>
+            <a:ext cx="10881360" cy="457200"/>
           </a:xfrm>
           <a:prstGeom prst="rect">
             <a:avLst/>
@@ -2270,11 +2348,11 @@
           <a:bodyPr wrap="square" lIns="0" tIns="0" rIns="0" bIns="0" rtlCol="0" anchor="ctr"/>
           <a:lstStyle/>
           <a:p>
-            <a:pPr algn="ctr" indent="0" marL="0">
+            <a:pPr algn="l" indent="0" marL="0">
               <a:buNone/>
             </a:pPr>
             <a:r>
-              <a:rPr lang="en-US" sz="1650" dirty="0">
+              <a:rPr lang="en-US" sz="1800" dirty="0">
                 <a:solidFill>
                   <a:srgbClr val="1A2430"/>
                 </a:solidFill>
@@ -2284,20 +2362,20 @@
               </a:rPr>
               <a:t>The Anatomy of Teacher Attrition in the United States, 1997–2024</a:t>
             </a:r>
-            <a:endParaRPr lang="en-US" sz="1650" dirty="0"/>
-          </a:p>
-        </p:txBody>
-      </p:sp>
-      <p:sp>
-        <p:nvSpPr>
-          <p:cNvPr id="4" name="Text 2"/>
+            <a:endParaRPr lang="en-US" sz="1800" dirty="0"/>
+          </a:p>
+        </p:txBody>
+      </p:sp>
+      <p:sp>
+        <p:nvSpPr>
+          <p:cNvPr id="6" name="Text 4"/>
           <p:cNvSpPr/>
           <p:nvPr/>
         </p:nvSpPr>
         <p:spPr>
           <a:xfrm>
-            <a:off x="1280160" y="4114800"/>
-            <a:ext cx="9628632" cy="384048"/>
+            <a:off x="640080" y="4160520"/>
+            <a:ext cx="10881360" cy="365760"/>
           </a:xfrm>
           <a:prstGeom prst="rect">
             <a:avLst/>
@@ -2309,11 +2387,11 @@
           <a:bodyPr wrap="square" lIns="0" tIns="0" rIns="0" bIns="0" rtlCol="0" anchor="ctr"/>
           <a:lstStyle/>
           <a:p>
-            <a:pPr algn="ctr" indent="0" marL="0">
+            <a:pPr algn="l" indent="0" marL="0">
               <a:buNone/>
             </a:pPr>
             <a:r>
-              <a:rPr lang="en-US" sz="1600" dirty="0">
+              <a:rPr lang="en-US" sz="1500" dirty="0">
                 <a:solidFill>
                   <a:srgbClr val="1A2430"/>
                 </a:solidFill>
@@ -2323,20 +2401,20 @@
               </a:rPr>
               <a:t>José Elías Durán Roa</a:t>
             </a:r>
-            <a:endParaRPr lang="en-US" sz="1600" dirty="0"/>
-          </a:p>
-        </p:txBody>
-      </p:sp>
-      <p:sp>
-        <p:nvSpPr>
-          <p:cNvPr id="5" name="Text 3"/>
+            <a:endParaRPr lang="en-US" sz="1500" dirty="0"/>
+          </a:p>
+        </p:txBody>
+      </p:sp>
+      <p:sp>
+        <p:nvSpPr>
+          <p:cNvPr id="7" name="Text 5"/>
           <p:cNvSpPr/>
           <p:nvPr/>
         </p:nvSpPr>
         <p:spPr>
           <a:xfrm>
-            <a:off x="1280160" y="4517136"/>
-            <a:ext cx="9628632" cy="329184"/>
+            <a:off x="640080" y="4526280"/>
+            <a:ext cx="10881360" cy="320040"/>
           </a:xfrm>
           <a:prstGeom prst="rect">
             <a:avLst/>
@@ -2348,11 +2426,11 @@
           <a:bodyPr wrap="square" lIns="0" tIns="0" rIns="0" bIns="0" rtlCol="0" anchor="ctr"/>
           <a:lstStyle/>
           <a:p>
-            <a:pPr algn="ctr" indent="0" marL="0">
+            <a:pPr algn="l" indent="0" marL="0">
               <a:buNone/>
             </a:pPr>
             <a:r>
-              <a:rPr lang="en-US" sz="1250" i="1" dirty="0">
+              <a:rPr lang="en-US" sz="1250" dirty="0">
                 <a:solidFill>
                   <a:srgbClr val="5A6572"/>
                 </a:solidFill>
@@ -2360,7 +2438,7 @@
                 <a:ea typeface="Garamond" pitchFamily="34" charset="-122"/>
                 <a:cs typeface="Garamond" pitchFamily="34" charset="-120"/>
               </a:rPr>
-              <a:t>University of Alicante and OECD</a:t>
+              <a:t>University of Alicante · OECD · July 2026</a:t>
             </a:r>
             <a:endParaRPr lang="en-US" sz="1250" dirty="0"/>
           </a:p>
@@ -2368,14 +2446,34 @@
       </p:sp>
       <p:sp>
         <p:nvSpPr>
-          <p:cNvPr id="6" name="Text 4"/>
+          <p:cNvPr id="8" name="Shape 6"/>
           <p:cNvSpPr/>
           <p:nvPr/>
         </p:nvSpPr>
         <p:spPr>
           <a:xfrm>
-            <a:off x="1280160" y="5257800"/>
-            <a:ext cx="9628632" cy="310896"/>
+            <a:off x="0" y="6263640"/>
+            <a:ext cx="12188952" cy="594360"/>
+          </a:xfrm>
+          <a:prstGeom prst="rect">
+            <a:avLst/>
+          </a:prstGeom>
+          <a:solidFill>
+            <a:srgbClr val="00549F"/>
+          </a:solidFill>
+          <a:ln/>
+        </p:spPr>
+      </p:sp>
+      <p:sp>
+        <p:nvSpPr>
+          <p:cNvPr id="9" name="Text 7"/>
+          <p:cNvSpPr/>
+          <p:nvPr/>
+        </p:nvSpPr>
+        <p:spPr>
+          <a:xfrm>
+            <a:off x="640080" y="6263640"/>
+            <a:ext cx="10881360" cy="594360"/>
           </a:xfrm>
           <a:prstGeom prst="rect">
             <a:avLst/>
@@ -2387,21 +2485,21 @@
           <a:bodyPr wrap="square" lIns="0" tIns="0" rIns="0" bIns="0" rtlCol="0" anchor="ctr"/>
           <a:lstStyle/>
           <a:p>
-            <a:pPr algn="ctr" indent="0" marL="0">
+            <a:pPr algn="l" indent="0" marL="0">
               <a:buNone/>
             </a:pPr>
             <a:r>
-              <a:rPr lang="en-US" sz="1200" dirty="0">
+              <a:rPr lang="en-US" sz="1100" dirty="0">
                 <a:solidFill>
-                  <a:srgbClr val="5A6572"/>
+                  <a:srgbClr val="FFFFFF"/>
                 </a:solidFill>
                 <a:latin typeface="Garamond" pitchFamily="34" charset="0"/>
                 <a:ea typeface="Garamond" pitchFamily="34" charset="-122"/>
                 <a:cs typeface="Garamond" pitchFamily="34" charset="-120"/>
               </a:rPr>
-              <a:t>July 2026</a:t>
-            </a:r>
-            <a:endParaRPr lang="en-US" sz="1200" dirty="0"/>
+              <a:t>oecd.org  ·  Education and Skills</a:t>
+            </a:r>
+            <a:endParaRPr lang="en-US" sz="1100" dirty="0"/>
           </a:p>
         </p:txBody>
       </p:sp>
@@ -3383,8 +3481,8 @@
         </p:nvSpPr>
         <p:spPr>
           <a:xfrm>
-            <a:off x="914400" y="502920"/>
-            <a:ext cx="9875520" cy="548640"/>
+            <a:off x="822960" y="457200"/>
+            <a:ext cx="10515600" cy="502920"/>
           </a:xfrm>
           <a:prstGeom prst="rect">
             <a:avLst/>
@@ -3400,9 +3498,9 @@
               <a:buNone/>
             </a:pPr>
             <a:r>
-              <a:rPr lang="en-US" sz="2400" b="1" dirty="0">
+              <a:rPr lang="en-US" sz="2600" b="1" dirty="0">
                 <a:solidFill>
-                  <a:srgbClr val="26456E"/>
+                  <a:srgbClr val="00549F"/>
                 </a:solidFill>
                 <a:latin typeface="Garamond" pitchFamily="34" charset="0"/>
                 <a:ea typeface="Garamond" pitchFamily="34" charset="-122"/>
@@ -3410,20 +3508,43 @@
               </a:rPr>
               <a:t>Motivation</a:t>
             </a:r>
-            <a:endParaRPr lang="en-US" sz="2400" dirty="0"/>
-          </a:p>
-        </p:txBody>
-      </p:sp>
-      <p:sp>
-        <p:nvSpPr>
-          <p:cNvPr id="3" name="Text 1"/>
+            <a:endParaRPr lang="en-US" sz="2600" dirty="0"/>
+          </a:p>
+        </p:txBody>
+      </p:sp>
+      <p:sp>
+        <p:nvSpPr>
+          <p:cNvPr id="3" name="Shape 1"/>
           <p:cNvSpPr/>
           <p:nvPr/>
         </p:nvSpPr>
         <p:spPr>
           <a:xfrm>
-            <a:off x="914400" y="1554480"/>
-            <a:ext cx="10332720" cy="1005840"/>
+            <a:off x="822960" y="1024128"/>
+            <a:ext cx="10543032" cy="0"/>
+          </a:xfrm>
+          <a:prstGeom prst="line">
+            <a:avLst/>
+          </a:prstGeom>
+          <a:noFill/>
+          <a:ln w="15240">
+            <a:solidFill>
+              <a:srgbClr val="00549F"/>
+            </a:solidFill>
+            <a:prstDash val="solid"/>
+          </a:ln>
+        </p:spPr>
+      </p:sp>
+      <p:sp>
+        <p:nvSpPr>
+          <p:cNvPr id="4" name="Text 2"/>
+          <p:cNvSpPr/>
+          <p:nvPr/>
+        </p:nvSpPr>
+        <p:spPr>
+          <a:xfrm>
+            <a:off x="822960" y="1371600"/>
+            <a:ext cx="10515600" cy="868680"/>
           </a:xfrm>
           <a:prstGeom prst="rect">
             <a:avLst/>
@@ -3437,7 +3558,7 @@
           <a:p>
             <a:pPr algn="l" indent="0" marL="0">
               <a:lnSpc>
-                <a:spcPts val="2200"/>
+                <a:spcPts val="2300"/>
               </a:lnSpc>
               <a:buNone/>
             </a:pPr>
@@ -3450,7 +3571,7 @@
                 <a:ea typeface="Garamond" pitchFamily="34" charset="-122"/>
                 <a:cs typeface="Garamond" pitchFamily="34" charset="-120"/>
               </a:rPr>
-              <a:t>Measuring teacher attrition is hard: it requires following the same teachers over time.</a:t>
+              <a:t>Measuring teacher attrition is hard as it requires following the same teachers over time.</a:t>
             </a:r>
             <a:endParaRPr lang="en-US" sz="1550" dirty="0"/>
           </a:p>
@@ -3458,14 +3579,14 @@
       </p:sp>
       <p:sp>
         <p:nvSpPr>
-          <p:cNvPr id="4" name="Text 2"/>
+          <p:cNvPr id="5" name="Text 3"/>
           <p:cNvSpPr/>
           <p:nvPr/>
         </p:nvSpPr>
         <p:spPr>
           <a:xfrm>
-            <a:off x="914400" y="2331720"/>
-            <a:ext cx="10332720" cy="1005840"/>
+            <a:off x="822960" y="2084832"/>
+            <a:ext cx="10515600" cy="868680"/>
           </a:xfrm>
           <a:prstGeom prst="rect">
             <a:avLst/>
@@ -3479,7 +3600,7 @@
           <a:p>
             <a:pPr algn="l" indent="0" marL="0">
               <a:lnSpc>
-                <a:spcPts val="2200"/>
+                <a:spcPts val="2300"/>
               </a:lnSpc>
               <a:buNone/>
             </a:pPr>
@@ -3492,7 +3613,7 @@
                 <a:ea typeface="Garamond" pitchFamily="34" charset="-122"/>
                 <a:cs typeface="Garamond" pitchFamily="34" charset="-120"/>
               </a:rPr>
-              <a:t>In the United States, this is done by the NCES Schools and Staffing Survey and its successor, the National Teacher and Principal Survey, through the Teacher Follow-up Survey. These are snapshots taken every four to five years, representative but small, and the underlying microdata are restricted, not public.</a:t>
+              <a:t>In the US, the official source is the NCES Teacher Follow-up Survey. It runs every four to five years, on small samples, and its microdata are not public.</a:t>
             </a:r>
             <a:endParaRPr lang="en-US" sz="1550" dirty="0"/>
           </a:p>
@@ -3500,14 +3621,14 @@
       </p:sp>
       <p:sp>
         <p:nvSpPr>
-          <p:cNvPr id="5" name="Text 3"/>
+          <p:cNvPr id="6" name="Text 4"/>
           <p:cNvSpPr/>
           <p:nvPr/>
         </p:nvSpPr>
         <p:spPr>
           <a:xfrm>
-            <a:off x="914400" y="3611880"/>
-            <a:ext cx="10332720" cy="1005840"/>
+            <a:off x="822960" y="3044952"/>
+            <a:ext cx="10515600" cy="868680"/>
           </a:xfrm>
           <a:prstGeom prst="rect">
             <a:avLst/>
@@ -3521,7 +3642,7 @@
           <a:p>
             <a:pPr algn="l" indent="0" marL="0">
               <a:lnSpc>
-                <a:spcPts val="2200"/>
+                <a:spcPts val="2300"/>
               </a:lnSpc>
               <a:buNone/>
             </a:pPr>
@@ -3534,7 +3655,7 @@
                 <a:ea typeface="Garamond" pitchFamily="34" charset="-122"/>
                 <a:cs typeface="Garamond" pitchFamily="34" charset="-120"/>
               </a:rPr>
-              <a:t>A little-explored alternative is the March supplement of the Current Population Survey: an annual, public survey of around 75,000 households that asks for the longest job held last calendar year and for the occupation held this week, and records where leavers land and what they earn. It offers an independent check on the official statistics and a way to deepen their descriptive analysis.</a:t>
+              <a:t>Researchers found a creative solution, the CPS, the largest longitudinal survey in the US. Harris &amp; Adams (2007) and Aldeman &amp; Yi (2025) used it to show that teacher attrition is similar to that of comparable professions.</a:t>
             </a:r>
             <a:endParaRPr lang="en-US" sz="1550" dirty="0"/>
           </a:p>
@@ -3542,14 +3663,14 @@
       </p:sp>
       <p:sp>
         <p:nvSpPr>
-          <p:cNvPr id="6" name="Text 4"/>
+          <p:cNvPr id="7" name="Text 5"/>
           <p:cNvSpPr/>
           <p:nvPr/>
         </p:nvSpPr>
         <p:spPr>
           <a:xfrm>
-            <a:off x="914400" y="4892040"/>
-            <a:ext cx="10332720" cy="1005840"/>
+            <a:off x="822960" y="4233672"/>
+            <a:ext cx="10515600" cy="457200"/>
           </a:xfrm>
           <a:prstGeom prst="rect">
             <a:avLst/>
@@ -3558,12 +3679,74 @@
           <a:ln/>
         </p:spPr>
         <p:txBody>
+          <a:bodyPr wrap="square" lIns="0" tIns="0" rIns="0" bIns="0" rtlCol="0" anchor="ctr"/>
+          <a:lstStyle/>
+          <a:p>
+            <a:pPr algn="l" indent="0" marL="0">
+              <a:buNone/>
+            </a:pPr>
+            <a:r>
+              <a:rPr lang="en-US" sz="2600" b="1" dirty="0">
+                <a:solidFill>
+                  <a:srgbClr val="00549F"/>
+                </a:solidFill>
+                <a:latin typeface="Garamond" pitchFamily="34" charset="0"/>
+                <a:ea typeface="Garamond" pitchFamily="34" charset="-122"/>
+                <a:cs typeface="Garamond" pitchFamily="34" charset="-120"/>
+              </a:rPr>
+              <a:t>Contribution</a:t>
+            </a:r>
+            <a:endParaRPr lang="en-US" sz="2600" dirty="0"/>
+          </a:p>
+        </p:txBody>
+      </p:sp>
+      <p:sp>
+        <p:nvSpPr>
+          <p:cNvPr id="8" name="Shape 6"/>
+          <p:cNvSpPr/>
+          <p:nvPr/>
+        </p:nvSpPr>
+        <p:spPr>
+          <a:xfrm>
+            <a:off x="822960" y="4754880"/>
+            <a:ext cx="10543032" cy="0"/>
+          </a:xfrm>
+          <a:prstGeom prst="line">
+            <a:avLst/>
+          </a:prstGeom>
+          <a:noFill/>
+          <a:ln w="15240">
+            <a:solidFill>
+              <a:srgbClr val="00549F"/>
+            </a:solidFill>
+            <a:prstDash val="solid"/>
+          </a:ln>
+        </p:spPr>
+      </p:sp>
+      <p:sp>
+        <p:nvSpPr>
+          <p:cNvPr id="9" name="Text 7"/>
+          <p:cNvSpPr/>
+          <p:nvPr/>
+        </p:nvSpPr>
+        <p:spPr>
+          <a:xfrm>
+            <a:off x="822960" y="5010912"/>
+            <a:ext cx="10515600" cy="1188720"/>
+          </a:xfrm>
+          <a:prstGeom prst="rect">
+            <a:avLst/>
+          </a:prstGeom>
+          <a:noFill/>
+          <a:ln/>
+        </p:spPr>
+        <p:txBody>
           <a:bodyPr wrap="square" lIns="0" tIns="0" rIns="0" bIns="0" rtlCol="0" anchor="t"/>
           <a:lstStyle/>
           <a:p>
             <a:pPr algn="l" indent="0" marL="0">
               <a:lnSpc>
-                <a:spcPts val="2200"/>
+                <a:spcPts val="2300"/>
               </a:lnSpc>
               <a:buNone/>
             </a:pPr>
@@ -3576,7 +3759,7 @@
                 <a:ea typeface="Garamond" pitchFamily="34" charset="-122"/>
                 <a:cs typeface="Garamond" pitchFamily="34" charset="-120"/>
               </a:rPr>
-              <a:t>Harris and Adams (2007) used it for 1992–2001, and Aldeman and Yi (2025) for 2015–2024. Both are brief articles centered on comparing the teacher leaving rate with that of other professions; neither exploits the instrument in depth. This paper does.</a:t>
+              <a:t>I build the longest measurement of teacher attrition in the US, twenty-eight consecutive years (1998–2025) from a single instrument, and characterize who leaves, where they go, what leaving pays, who returns, and what moves the rate, from a new baby to the business cycle.</a:t>
             </a:r>
             <a:endParaRPr lang="en-US" sz="1550" dirty="0"/>
           </a:p>
@@ -3622,8 +3805,8 @@
         </p:nvSpPr>
         <p:spPr>
           <a:xfrm>
-            <a:off x="914400" y="502920"/>
-            <a:ext cx="9875520" cy="548640"/>
+            <a:off x="822960" y="457200"/>
+            <a:ext cx="10515600" cy="502920"/>
           </a:xfrm>
           <a:prstGeom prst="rect">
             <a:avLst/>
@@ -3639,9 +3822,9 @@
               <a:buNone/>
             </a:pPr>
             <a:r>
-              <a:rPr lang="en-US" sz="2400" b="1" dirty="0">
+              <a:rPr lang="en-US" sz="2600" b="1" dirty="0">
                 <a:solidFill>
-                  <a:srgbClr val="1F3B66"/>
+                  <a:srgbClr val="00549F"/>
                 </a:solidFill>
                 <a:latin typeface="Garamond" pitchFamily="34" charset="0"/>
                 <a:ea typeface="Garamond" pitchFamily="34" charset="-122"/>
@@ -3649,20 +3832,43 @@
               </a:rPr>
               <a:t>Data</a:t>
             </a:r>
-            <a:endParaRPr lang="en-US" sz="2400" dirty="0"/>
-          </a:p>
-        </p:txBody>
-      </p:sp>
-      <p:sp>
-        <p:nvSpPr>
-          <p:cNvPr id="3" name="Text 1"/>
+            <a:endParaRPr lang="en-US" sz="2600" dirty="0"/>
+          </a:p>
+        </p:txBody>
+      </p:sp>
+      <p:sp>
+        <p:nvSpPr>
+          <p:cNvPr id="3" name="Shape 1"/>
           <p:cNvSpPr/>
           <p:nvPr/>
         </p:nvSpPr>
         <p:spPr>
           <a:xfrm>
-            <a:off x="1143000" y="1874520"/>
-            <a:ext cx="9902952" cy="868680"/>
+            <a:off x="822960" y="1024128"/>
+            <a:ext cx="10543032" cy="0"/>
+          </a:xfrm>
+          <a:prstGeom prst="line">
+            <a:avLst/>
+          </a:prstGeom>
+          <a:noFill/>
+          <a:ln w="15240">
+            <a:solidFill>
+              <a:srgbClr val="00549F"/>
+            </a:solidFill>
+            <a:prstDash val="solid"/>
+          </a:ln>
+        </p:spPr>
+      </p:sp>
+      <p:sp>
+        <p:nvSpPr>
+          <p:cNvPr id="4" name="Text 2"/>
+          <p:cNvSpPr/>
+          <p:nvPr/>
+        </p:nvSpPr>
+        <p:spPr>
+          <a:xfrm>
+            <a:off x="822960" y="1600200"/>
+            <a:ext cx="10515600" cy="868680"/>
           </a:xfrm>
           <a:prstGeom prst="rect">
             <a:avLst/>
@@ -3676,12 +3882,12 @@
           <a:p>
             <a:pPr algn="l" indent="0" marL="0">
               <a:lnSpc>
-                <a:spcPts val="2200"/>
+                <a:spcPts val="2400"/>
               </a:lnSpc>
               <a:buNone/>
             </a:pPr>
             <a:r>
-              <a:rPr lang="en-US" sz="1550" dirty="0">
+              <a:rPr lang="en-US" sz="1600" dirty="0">
                 <a:solidFill>
                   <a:srgbClr val="1A2430"/>
                 </a:solidFill>
@@ -3689,22 +3895,22 @@
                 <a:ea typeface="Garamond" pitchFamily="34" charset="-122"/>
                 <a:cs typeface="Garamond" pitchFamily="34" charset="-120"/>
               </a:rPr>
-              <a:t>March supplement of the Current Population Survey, survey years 1998 to 2025.</a:t>
-            </a:r>
-            <a:endParaRPr lang="en-US" sz="1550" dirty="0"/>
-          </a:p>
-        </p:txBody>
-      </p:sp>
-      <p:sp>
-        <p:nvSpPr>
-          <p:cNvPr id="4" name="Text 2"/>
+              <a:t>The Current Population Survey (CPS) is the main household survey in the US, used to compute the country’s official employment statistics.</a:t>
+            </a:r>
+            <a:endParaRPr lang="en-US" sz="1600" dirty="0"/>
+          </a:p>
+        </p:txBody>
+      </p:sp>
+      <p:sp>
+        <p:nvSpPr>
+          <p:cNvPr id="5" name="Text 3"/>
           <p:cNvSpPr/>
           <p:nvPr/>
         </p:nvSpPr>
         <p:spPr>
           <a:xfrm>
-            <a:off x="1143000" y="2532888"/>
-            <a:ext cx="9902952" cy="868680"/>
+            <a:off x="822960" y="2468880"/>
+            <a:ext cx="10515600" cy="868680"/>
           </a:xfrm>
           <a:prstGeom prst="rect">
             <a:avLst/>
@@ -3718,12 +3924,12 @@
           <a:p>
             <a:pPr algn="l" indent="0" marL="0">
               <a:lnSpc>
-                <a:spcPts val="2200"/>
+                <a:spcPts val="2400"/>
               </a:lnSpc>
               <a:buNone/>
             </a:pPr>
             <a:r>
-              <a:rPr lang="en-US" sz="1550" dirty="0">
+              <a:rPr lang="en-US" sz="1600" dirty="0">
                 <a:solidFill>
                   <a:srgbClr val="1A2430"/>
                 </a:solidFill>
@@ -3731,22 +3937,22 @@
                 <a:ea typeface="Garamond" pitchFamily="34" charset="-122"/>
                 <a:cs typeface="Garamond" pitchFamily="34" charset="-120"/>
               </a:rPr>
-              <a:t>One retrospective question: the longest job held last calendar year, compared with the occupation held this week. Whoever taught last year and no longer teaches this March has left the profession.</a:t>
-            </a:r>
-            <a:endParaRPr lang="en-US" sz="1550" dirty="0"/>
-          </a:p>
-        </p:txBody>
-      </p:sp>
-      <p:sp>
-        <p:nvSpPr>
-          <p:cNvPr id="5" name="Text 3"/>
+              <a:t>I pool all its rounds from 1998 to 2025 into a single file and turn it into a tool for following teachers.</a:t>
+            </a:r>
+            <a:endParaRPr lang="en-US" sz="1600" dirty="0"/>
+          </a:p>
+        </p:txBody>
+      </p:sp>
+      <p:sp>
+        <p:nvSpPr>
+          <p:cNvPr id="6" name="Text 4"/>
           <p:cNvSpPr/>
           <p:nvPr/>
         </p:nvSpPr>
         <p:spPr>
           <a:xfrm>
-            <a:off x="1143000" y="3557016"/>
-            <a:ext cx="9902952" cy="868680"/>
+            <a:off x="822960" y="3337560"/>
+            <a:ext cx="10515600" cy="868680"/>
           </a:xfrm>
           <a:prstGeom prst="rect">
             <a:avLst/>
@@ -3760,12 +3966,12 @@
           <a:p>
             <a:pPr algn="l" indent="0" marL="0">
               <a:lnSpc>
-                <a:spcPts val="2200"/>
+                <a:spcPts val="2400"/>
               </a:lnSpc>
               <a:buNone/>
             </a:pPr>
             <a:r>
-              <a:rPr lang="en-US" sz="1550" dirty="0">
+              <a:rPr lang="en-US" sz="1600" dirty="0">
                 <a:solidFill>
                   <a:srgbClr val="1A2430"/>
                 </a:solidFill>
@@ -3773,22 +3979,22 @@
                 <a:ea typeface="Garamond" pitchFamily="34" charset="-122"/>
                 <a:cs typeface="Garamond" pitchFamily="34" charset="-120"/>
               </a:rPr>
-              <a:t>The pooled file holds 5,009,129 person-year records, 104,545 of them teacher-years, covering calendar years 1997 to 2024.</a:t>
-            </a:r>
-            <a:endParaRPr lang="en-US" sz="1550" dirty="0"/>
-          </a:p>
-        </p:txBody>
-      </p:sp>
-      <p:sp>
-        <p:nvSpPr>
-          <p:cNvPr id="6" name="Text 4"/>
+              <a:t>Each March, respondents report the longest job held last calendar year and their occupation today. Whoever taught last year and no longer teaches has left the profession within the year.</a:t>
+            </a:r>
+            <a:endParaRPr lang="en-US" sz="1600" dirty="0"/>
+          </a:p>
+        </p:txBody>
+      </p:sp>
+      <p:sp>
+        <p:nvSpPr>
+          <p:cNvPr id="7" name="Text 5"/>
           <p:cNvSpPr/>
           <p:nvPr/>
         </p:nvSpPr>
         <p:spPr>
           <a:xfrm>
-            <a:off x="1143000" y="4581144"/>
-            <a:ext cx="9902952" cy="868680"/>
+            <a:off x="822960" y="4480560"/>
+            <a:ext cx="10515600" cy="868680"/>
           </a:xfrm>
           <a:prstGeom prst="rect">
             <a:avLst/>
@@ -3802,12 +4008,12 @@
           <a:p>
             <a:pPr algn="l" indent="0" marL="0">
               <a:lnSpc>
-                <a:spcPts val="2200"/>
+                <a:spcPts val="2400"/>
               </a:lnSpc>
               <a:buNone/>
             </a:pPr>
             <a:r>
-              <a:rPr lang="en-US" sz="1550" dirty="0">
+              <a:rPr lang="en-US" sz="1600" dirty="0">
                 <a:solidFill>
                   <a:srgbClr val="1A2430"/>
                 </a:solidFill>
@@ -3815,48 +4021,9 @@
                 <a:ea typeface="Garamond" pitchFamily="34" charset="-122"/>
                 <a:cs typeface="Garamond" pitchFamily="34" charset="-120"/>
               </a:rPr>
-              <a:t>Every variable is read from the raw Census files at its officially documented position. All estimates use ASEC supplement weights.</a:t>
-            </a:r>
-            <a:endParaRPr lang="en-US" sz="1550" dirty="0"/>
-          </a:p>
-        </p:txBody>
-      </p:sp>
-      <p:sp>
-        <p:nvSpPr>
-          <p:cNvPr id="7" name="Text 5"/>
-          <p:cNvSpPr/>
-          <p:nvPr/>
-        </p:nvSpPr>
-        <p:spPr>
-          <a:xfrm>
-            <a:off x="1143000" y="6035040"/>
-            <a:ext cx="9902952" cy="292608"/>
-          </a:xfrm>
-          <a:prstGeom prst="rect">
-            <a:avLst/>
-          </a:prstGeom>
-          <a:noFill/>
-          <a:ln/>
-        </p:spPr>
-        <p:txBody>
-          <a:bodyPr wrap="square" lIns="0" tIns="0" rIns="0" bIns="0" rtlCol="0" anchor="ctr"/>
-          <a:lstStyle/>
-          <a:p>
-            <a:pPr algn="l" indent="0" marL="0">
-              <a:buNone/>
-            </a:pPr>
-            <a:r>
-              <a:rPr lang="en-US" sz="1150" i="1" dirty="0">
-                <a:solidFill>
-                  <a:srgbClr val="5A6572"/>
-                </a:solidFill>
-                <a:latin typeface="Garamond" pitchFamily="34" charset="0"/>
-                <a:ea typeface="Garamond" pitchFamily="34" charset="-122"/>
-                <a:cs typeface="Garamond" pitchFamily="34" charset="-120"/>
-              </a:rPr>
-              <a:t>The March 2026 supplement, covering calendar 2025, is not yet public.</a:t>
-            </a:r>
-            <a:endParaRPr lang="en-US" sz="1150" dirty="0"/>
+              <a:t>My final dataset holds 5 million individual records, with 104,545 teachers, around 3,700 per year.</a:t>
+            </a:r>
+            <a:endParaRPr lang="en-US" sz="1600" dirty="0"/>
           </a:p>
         </p:txBody>
       </p:sp>

</xml_diff>

<commit_message>
Deck cover: embed OECD logo
Co-Authored-By: Claude Fable 5 <noreply@anthropic.com>
Claude-Session: https://claude.ai/code/session_01DNzQPDcr3zfLTraMHUHqUn
</commit_message>
<xml_diff>
--- a/report/teacher_attrition_figures.pptx
+++ b/report/teacher_attrition_figures.pptx
@@ -2210,48 +2210,33 @@
           <a:chExt cx="0" cy="0"/>
         </a:xfrm>
       </p:grpSpPr>
-      <p:sp>
-        <p:nvSpPr>
-          <p:cNvPr id="2" name="Text 0"/>
-          <p:cNvSpPr/>
-          <p:nvPr/>
-        </p:nvSpPr>
-        <p:spPr>
-          <a:xfrm>
-            <a:off x="640080" y="457200"/>
-            <a:ext cx="2011680" cy="457200"/>
-          </a:xfrm>
-          <a:prstGeom prst="rect">
-            <a:avLst/>
-          </a:prstGeom>
-          <a:noFill/>
-          <a:ln/>
-        </p:spPr>
-        <p:txBody>
-          <a:bodyPr wrap="square" lIns="0" tIns="0" rIns="0" bIns="0" rtlCol="0" anchor="ctr"/>
-          <a:lstStyle/>
-          <a:p>
-            <a:pPr algn="l" indent="0" marL="0">
-              <a:buNone/>
-            </a:pPr>
-            <a:r>
-              <a:rPr lang="en-US" sz="2600" b="1" dirty="0">
-                <a:solidFill>
-                  <a:srgbClr val="00549F"/>
-                </a:solidFill>
-                <a:latin typeface="Arial" pitchFamily="34" charset="0"/>
-                <a:ea typeface="Arial" pitchFamily="34" charset="-122"/>
-                <a:cs typeface="Arial" pitchFamily="34" charset="-120"/>
-              </a:rPr>
-              <a:t>OECD</a:t>
-            </a:r>
-            <a:endParaRPr lang="en-US" sz="2600" dirty="0"/>
-          </a:p>
-        </p:txBody>
-      </p:sp>
-      <p:sp>
-        <p:nvSpPr>
-          <p:cNvPr id="3" name="Text 1"/>
+      <p:pic>
+        <p:nvPicPr>
+          <p:cNvPr id="2" name="Image 0" descr="oecd_logo.png">    </p:cNvPr>
+          <p:cNvPicPr>
+            <a:picLocks noChangeAspect="1"/>
+          </p:cNvPicPr>
+          <p:nvPr/>
+        </p:nvPicPr>
+        <p:blipFill>
+          <a:blip r:embed="rId1"/>
+          <a:stretch>
+            <a:fillRect/>
+          </a:stretch>
+        </p:blipFill>
+        <p:spPr>
+          <a:xfrm>
+            <a:off x="640080" y="411480"/>
+            <a:ext cx="1828800" cy="466344"/>
+          </a:xfrm>
+          <a:prstGeom prst="rect">
+            <a:avLst/>
+          </a:prstGeom>
+        </p:spPr>
+      </p:pic>
+      <p:sp>
+        <p:nvSpPr>
+          <p:cNvPr id="3" name="Text 0"/>
           <p:cNvSpPr/>
           <p:nvPr/>
         </p:nvSpPr>
@@ -2290,7 +2275,7 @@
       </p:sp>
       <p:sp>
         <p:nvSpPr>
-          <p:cNvPr id="4" name="Text 2"/>
+          <p:cNvPr id="4" name="Text 1"/>
           <p:cNvSpPr/>
           <p:nvPr/>
         </p:nvSpPr>
@@ -2329,7 +2314,7 @@
       </p:sp>
       <p:sp>
         <p:nvSpPr>
-          <p:cNvPr id="5" name="Text 3"/>
+          <p:cNvPr id="5" name="Text 2"/>
           <p:cNvSpPr/>
           <p:nvPr/>
         </p:nvSpPr>
@@ -2368,7 +2353,7 @@
       </p:sp>
       <p:sp>
         <p:nvSpPr>
-          <p:cNvPr id="6" name="Text 4"/>
+          <p:cNvPr id="6" name="Text 3"/>
           <p:cNvSpPr/>
           <p:nvPr/>
         </p:nvSpPr>
@@ -2407,7 +2392,7 @@
       </p:sp>
       <p:sp>
         <p:nvSpPr>
-          <p:cNvPr id="7" name="Text 5"/>
+          <p:cNvPr id="7" name="Text 4"/>
           <p:cNvSpPr/>
           <p:nvPr/>
         </p:nvSpPr>
@@ -2446,7 +2431,7 @@
       </p:sp>
       <p:sp>
         <p:nvSpPr>
-          <p:cNvPr id="8" name="Shape 6"/>
+          <p:cNvPr id="8" name="Shape 5"/>
           <p:cNvSpPr/>
           <p:nvPr/>
         </p:nvSpPr>
@@ -2466,7 +2451,7 @@
       </p:sp>
       <p:sp>
         <p:nvSpPr>
-          <p:cNvPr id="9" name="Text 7"/>
+          <p:cNvPr id="9" name="Text 6"/>
           <p:cNvSpPr/>
           <p:nvPr/>
         </p:nvSpPr>

</xml_diff>

<commit_message>
Motivation and Data slides: single text box, uniform paragraph spacing
Co-Authored-By: Claude Fable 5 <noreply@anthropic.com>
Claude-Session: https://claude.ai/code/session_01DNzQPDcr3zfLTraMHUHqUn
</commit_message>
<xml_diff>
--- a/report/teacher_attrition_figures.pptx
+++ b/report/teacher_attrition_figures.pptx
@@ -3528,8 +3528,8 @@
         </p:nvSpPr>
         <p:spPr>
           <a:xfrm>
-            <a:off x="822960" y="1371600"/>
-            <a:ext cx="10515600" cy="868680"/>
+            <a:off x="822960" y="1325880"/>
+            <a:ext cx="10515600" cy="5120640"/>
           </a:xfrm>
           <a:prstGeom prst="rect">
             <a:avLst/>
@@ -3543,12 +3543,15 @@
           <a:p>
             <a:pPr algn="l" indent="0" marL="0">
               <a:lnSpc>
-                <a:spcPts val="2300"/>
+                <a:spcPts val="2400"/>
               </a:lnSpc>
+              <a:spcAft>
+                <a:spcPts val="1400"/>
+              </a:spcAft>
               <a:buNone/>
             </a:pPr>
             <a:r>
-              <a:rPr lang="en-US" sz="1550" dirty="0">
+              <a:rPr lang="en-US" sz="1600" dirty="0">
                 <a:solidFill>
                   <a:srgbClr val="1A2430"/>
                 </a:solidFill>
@@ -3558,39 +3561,20 @@
               </a:rPr>
               <a:t>Measuring teacher attrition is hard as it requires following the same teachers over time.</a:t>
             </a:r>
-            <a:endParaRPr lang="en-US" sz="1550" dirty="0"/>
-          </a:p>
-        </p:txBody>
-      </p:sp>
-      <p:sp>
-        <p:nvSpPr>
-          <p:cNvPr id="5" name="Text 3"/>
-          <p:cNvSpPr/>
-          <p:nvPr/>
-        </p:nvSpPr>
-        <p:spPr>
-          <a:xfrm>
-            <a:off x="822960" y="2084832"/>
-            <a:ext cx="10515600" cy="868680"/>
-          </a:xfrm>
-          <a:prstGeom prst="rect">
-            <a:avLst/>
-          </a:prstGeom>
-          <a:noFill/>
-          <a:ln/>
-        </p:spPr>
-        <p:txBody>
-          <a:bodyPr wrap="square" lIns="0" tIns="0" rIns="0" bIns="0" rtlCol="0" anchor="t"/>
-          <a:lstStyle/>
+            <a:endParaRPr lang="en-US" sz="1600" dirty="0"/>
+          </a:p>
           <a:p>
             <a:pPr algn="l" indent="0" marL="0">
               <a:lnSpc>
-                <a:spcPts val="2300"/>
+                <a:spcPts val="2400"/>
               </a:lnSpc>
+              <a:spcAft>
+                <a:spcPts val="1400"/>
+              </a:spcAft>
               <a:buNone/>
             </a:pPr>
             <a:r>
-              <a:rPr lang="en-US" sz="1550" dirty="0">
+              <a:rPr lang="en-US" sz="1600" dirty="0">
                 <a:solidFill>
                   <a:srgbClr val="1A2430"/>
                 </a:solidFill>
@@ -3600,39 +3584,20 @@
               </a:rPr>
               <a:t>In the US, the official source is the NCES Teacher Follow-up Survey. It runs every four to five years, on small samples, and its microdata are not public.</a:t>
             </a:r>
-            <a:endParaRPr lang="en-US" sz="1550" dirty="0"/>
-          </a:p>
-        </p:txBody>
-      </p:sp>
-      <p:sp>
-        <p:nvSpPr>
-          <p:cNvPr id="6" name="Text 4"/>
-          <p:cNvSpPr/>
-          <p:nvPr/>
-        </p:nvSpPr>
-        <p:spPr>
-          <a:xfrm>
-            <a:off x="822960" y="3044952"/>
-            <a:ext cx="10515600" cy="868680"/>
-          </a:xfrm>
-          <a:prstGeom prst="rect">
-            <a:avLst/>
-          </a:prstGeom>
-          <a:noFill/>
-          <a:ln/>
-        </p:spPr>
-        <p:txBody>
-          <a:bodyPr wrap="square" lIns="0" tIns="0" rIns="0" bIns="0" rtlCol="0" anchor="t"/>
-          <a:lstStyle/>
+            <a:endParaRPr lang="en-US" sz="1600" dirty="0"/>
+          </a:p>
           <a:p>
             <a:pPr algn="l" indent="0" marL="0">
               <a:lnSpc>
-                <a:spcPts val="2300"/>
+                <a:spcPts val="2400"/>
               </a:lnSpc>
+              <a:spcAft>
+                <a:spcPts val="2400"/>
+              </a:spcAft>
               <a:buNone/>
             </a:pPr>
             <a:r>
-              <a:rPr lang="en-US" sz="1550" dirty="0">
+              <a:rPr lang="en-US" sz="1600" dirty="0">
                 <a:solidFill>
                   <a:srgbClr val="1A2430"/>
                 </a:solidFill>
@@ -3642,32 +3607,16 @@
               </a:rPr>
               <a:t>Researchers found a creative solution, the CPS, the largest longitudinal survey in the US. Harris &amp; Adams (2007) and Aldeman &amp; Yi (2025) used it to show that teacher attrition is similar to that of comparable professions.</a:t>
             </a:r>
-            <a:endParaRPr lang="en-US" sz="1550" dirty="0"/>
-          </a:p>
-        </p:txBody>
-      </p:sp>
-      <p:sp>
-        <p:nvSpPr>
-          <p:cNvPr id="7" name="Text 5"/>
-          <p:cNvSpPr/>
-          <p:nvPr/>
-        </p:nvSpPr>
-        <p:spPr>
-          <a:xfrm>
-            <a:off x="822960" y="4233672"/>
-            <a:ext cx="10515600" cy="457200"/>
-          </a:xfrm>
-          <a:prstGeom prst="rect">
-            <a:avLst/>
-          </a:prstGeom>
-          <a:noFill/>
-          <a:ln/>
-        </p:spPr>
-        <p:txBody>
-          <a:bodyPr wrap="square" lIns="0" tIns="0" rIns="0" bIns="0" rtlCol="0" anchor="ctr"/>
-          <a:lstStyle/>
+            <a:endParaRPr lang="en-US" sz="1600" dirty="0"/>
+          </a:p>
           <a:p>
             <a:pPr algn="l" indent="0" marL="0">
+              <a:lnSpc>
+                <a:spcPts val="2400"/>
+              </a:lnSpc>
+              <a:spcAft>
+                <a:spcPts val="1200"/>
+              </a:spcAft>
               <a:buNone/>
             </a:pPr>
             <a:r>
@@ -3681,62 +3630,17 @@
               </a:rPr>
               <a:t>Contribution</a:t>
             </a:r>
-            <a:endParaRPr lang="en-US" sz="2600" dirty="0"/>
-          </a:p>
-        </p:txBody>
-      </p:sp>
-      <p:sp>
-        <p:nvSpPr>
-          <p:cNvPr id="8" name="Shape 6"/>
-          <p:cNvSpPr/>
-          <p:nvPr/>
-        </p:nvSpPr>
-        <p:spPr>
-          <a:xfrm>
-            <a:off x="822960" y="4754880"/>
-            <a:ext cx="10543032" cy="0"/>
-          </a:xfrm>
-          <a:prstGeom prst="line">
-            <a:avLst/>
-          </a:prstGeom>
-          <a:noFill/>
-          <a:ln w="15240">
-            <a:solidFill>
-              <a:srgbClr val="00549F"/>
-            </a:solidFill>
-            <a:prstDash val="solid"/>
-          </a:ln>
-        </p:spPr>
-      </p:sp>
-      <p:sp>
-        <p:nvSpPr>
-          <p:cNvPr id="9" name="Text 7"/>
-          <p:cNvSpPr/>
-          <p:nvPr/>
-        </p:nvSpPr>
-        <p:spPr>
-          <a:xfrm>
-            <a:off x="822960" y="5010912"/>
-            <a:ext cx="10515600" cy="1188720"/>
-          </a:xfrm>
-          <a:prstGeom prst="rect">
-            <a:avLst/>
-          </a:prstGeom>
-          <a:noFill/>
-          <a:ln/>
-        </p:spPr>
-        <p:txBody>
-          <a:bodyPr wrap="square" lIns="0" tIns="0" rIns="0" bIns="0" rtlCol="0" anchor="t"/>
-          <a:lstStyle/>
+            <a:endParaRPr lang="en-US" sz="1600" dirty="0"/>
+          </a:p>
           <a:p>
             <a:pPr algn="l" indent="0" marL="0">
               <a:lnSpc>
-                <a:spcPts val="2300"/>
+                <a:spcPts val="2400"/>
               </a:lnSpc>
               <a:buNone/>
             </a:pPr>
             <a:r>
-              <a:rPr lang="en-US" sz="1550" dirty="0">
+              <a:rPr lang="en-US" sz="1600" dirty="0">
                 <a:solidFill>
                   <a:srgbClr val="1A2430"/>
                 </a:solidFill>
@@ -3746,7 +3650,7 @@
               </a:rPr>
               <a:t>I build the longest measurement of teacher attrition in the US, twenty-eight consecutive years (1998–2025) from a single instrument, and characterize who leaves, where they go, what leaving pays, who returns, and what moves the rate, from a new baby to the business cycle.</a:t>
             </a:r>
-            <a:endParaRPr lang="en-US" sz="1550" dirty="0"/>
+            <a:endParaRPr lang="en-US" sz="1600" dirty="0"/>
           </a:p>
         </p:txBody>
       </p:sp>
@@ -3852,8 +3756,8 @@
         </p:nvSpPr>
         <p:spPr>
           <a:xfrm>
-            <a:off x="822960" y="1600200"/>
-            <a:ext cx="10515600" cy="868680"/>
+            <a:off x="822960" y="1417320"/>
+            <a:ext cx="10515600" cy="4846320"/>
           </a:xfrm>
           <a:prstGeom prst="rect">
             <a:avLst/>
@@ -3867,12 +3771,15 @@
           <a:p>
             <a:pPr algn="l" indent="0" marL="0">
               <a:lnSpc>
-                <a:spcPts val="2400"/>
+                <a:spcPts val="2500"/>
               </a:lnSpc>
+              <a:spcAft>
+                <a:spcPts val="1600"/>
+              </a:spcAft>
               <a:buNone/>
             </a:pPr>
             <a:r>
-              <a:rPr lang="en-US" sz="1600" dirty="0">
+              <a:rPr lang="en-US" sz="1650" dirty="0">
                 <a:solidFill>
                   <a:srgbClr val="1A2430"/>
                 </a:solidFill>
@@ -3882,39 +3789,20 @@
               </a:rPr>
               <a:t>The Current Population Survey (CPS) is the main household survey in the US, used to compute the country’s official employment statistics.</a:t>
             </a:r>
-            <a:endParaRPr lang="en-US" sz="1600" dirty="0"/>
-          </a:p>
-        </p:txBody>
-      </p:sp>
-      <p:sp>
-        <p:nvSpPr>
-          <p:cNvPr id="5" name="Text 3"/>
-          <p:cNvSpPr/>
-          <p:nvPr/>
-        </p:nvSpPr>
-        <p:spPr>
-          <a:xfrm>
-            <a:off x="822960" y="2468880"/>
-            <a:ext cx="10515600" cy="868680"/>
-          </a:xfrm>
-          <a:prstGeom prst="rect">
-            <a:avLst/>
-          </a:prstGeom>
-          <a:noFill/>
-          <a:ln/>
-        </p:spPr>
-        <p:txBody>
-          <a:bodyPr wrap="square" lIns="0" tIns="0" rIns="0" bIns="0" rtlCol="0" anchor="t"/>
-          <a:lstStyle/>
+            <a:endParaRPr lang="en-US" sz="1650" dirty="0"/>
+          </a:p>
           <a:p>
             <a:pPr algn="l" indent="0" marL="0">
               <a:lnSpc>
-                <a:spcPts val="2400"/>
+                <a:spcPts val="2500"/>
               </a:lnSpc>
+              <a:spcAft>
+                <a:spcPts val="1600"/>
+              </a:spcAft>
               <a:buNone/>
             </a:pPr>
             <a:r>
-              <a:rPr lang="en-US" sz="1600" dirty="0">
+              <a:rPr lang="en-US" sz="1650" dirty="0">
                 <a:solidFill>
                   <a:srgbClr val="1A2430"/>
                 </a:solidFill>
@@ -3924,39 +3812,20 @@
               </a:rPr>
               <a:t>I pool all its rounds from 1998 to 2025 into a single file and turn it into a tool for following teachers.</a:t>
             </a:r>
-            <a:endParaRPr lang="en-US" sz="1600" dirty="0"/>
-          </a:p>
-        </p:txBody>
-      </p:sp>
-      <p:sp>
-        <p:nvSpPr>
-          <p:cNvPr id="6" name="Text 4"/>
-          <p:cNvSpPr/>
-          <p:nvPr/>
-        </p:nvSpPr>
-        <p:spPr>
-          <a:xfrm>
-            <a:off x="822960" y="3337560"/>
-            <a:ext cx="10515600" cy="868680"/>
-          </a:xfrm>
-          <a:prstGeom prst="rect">
-            <a:avLst/>
-          </a:prstGeom>
-          <a:noFill/>
-          <a:ln/>
-        </p:spPr>
-        <p:txBody>
-          <a:bodyPr wrap="square" lIns="0" tIns="0" rIns="0" bIns="0" rtlCol="0" anchor="t"/>
-          <a:lstStyle/>
+            <a:endParaRPr lang="en-US" sz="1650" dirty="0"/>
+          </a:p>
           <a:p>
             <a:pPr algn="l" indent="0" marL="0">
               <a:lnSpc>
-                <a:spcPts val="2400"/>
+                <a:spcPts val="2500"/>
               </a:lnSpc>
+              <a:spcAft>
+                <a:spcPts val="1600"/>
+              </a:spcAft>
               <a:buNone/>
             </a:pPr>
             <a:r>
-              <a:rPr lang="en-US" sz="1600" dirty="0">
+              <a:rPr lang="en-US" sz="1650" dirty="0">
                 <a:solidFill>
                   <a:srgbClr val="1A2430"/>
                 </a:solidFill>
@@ -3966,39 +3835,17 @@
               </a:rPr>
               <a:t>Each March, respondents report the longest job held last calendar year and their occupation today. Whoever taught last year and no longer teaches has left the profession within the year.</a:t>
             </a:r>
-            <a:endParaRPr lang="en-US" sz="1600" dirty="0"/>
-          </a:p>
-        </p:txBody>
-      </p:sp>
-      <p:sp>
-        <p:nvSpPr>
-          <p:cNvPr id="7" name="Text 5"/>
-          <p:cNvSpPr/>
-          <p:nvPr/>
-        </p:nvSpPr>
-        <p:spPr>
-          <a:xfrm>
-            <a:off x="822960" y="4480560"/>
-            <a:ext cx="10515600" cy="868680"/>
-          </a:xfrm>
-          <a:prstGeom prst="rect">
-            <a:avLst/>
-          </a:prstGeom>
-          <a:noFill/>
-          <a:ln/>
-        </p:spPr>
-        <p:txBody>
-          <a:bodyPr wrap="square" lIns="0" tIns="0" rIns="0" bIns="0" rtlCol="0" anchor="t"/>
-          <a:lstStyle/>
+            <a:endParaRPr lang="en-US" sz="1650" dirty="0"/>
+          </a:p>
           <a:p>
             <a:pPr algn="l" indent="0" marL="0">
               <a:lnSpc>
-                <a:spcPts val="2400"/>
+                <a:spcPts val="2500"/>
               </a:lnSpc>
               <a:buNone/>
             </a:pPr>
             <a:r>
-              <a:rPr lang="en-US" sz="1600" dirty="0">
+              <a:rPr lang="en-US" sz="1650" dirty="0">
                 <a:solidFill>
                   <a:srgbClr val="1A2430"/>
                 </a:solidFill>
@@ -4008,7 +3855,7 @@
               </a:rPr>
               <a:t>My final dataset holds 5 million individual records, with 104,545 teachers, around 3,700 per year.</a:t>
             </a:r>
-            <a:endParaRPr lang="en-US" sz="1600" dirty="0"/>
+            <a:endParaRPr lang="en-US" sz="1650" dirty="0"/>
           </a:p>
         </p:txBody>
       </p:sp>

</xml_diff>